<commit_message>
fix(2026-07-11): add headings to programming slides
</commit_message>
<xml_diff>
--- a/2026-07-11_Intro_to_Computer_Science_Programming/2026-07-11_Intro_to_Computer_Science_Programming.pptx
+++ b/2026-07-11_Intro_to_Computer_Science_Programming/2026-07-11_Intro_to_Computer_Science_Programming.pptx
@@ -2,55 +2,55 @@
 <file path=ppt/presentation.xml><?xml version="1.0" encoding="utf-8"?>
 <p:presentation xmlns:p="http://schemas.openxmlformats.org/presentationml/2006/main" embedTrueTypeFonts="1" saveSubsetFonts="1">
   <p:sldMasterIdLst>
-    <p:sldMasterId xmlns:r="http://schemas.openxmlformats.org/officeDocument/2006/relationships" id="2147483648" r:id="R295d22b99e1a4d3c"/>
+    <p:sldMasterId xmlns:r="http://schemas.openxmlformats.org/officeDocument/2006/relationships" id="2147483648" r:id="R316865c0804744ac"/>
   </p:sldMasterIdLst>
   <p:notesMasterIdLst>
-    <p:notesMasterId xmlns:r="http://schemas.openxmlformats.org/officeDocument/2006/relationships" r:id="R032dfde6de0649c4"/>
+    <p:notesMasterId xmlns:r="http://schemas.openxmlformats.org/officeDocument/2006/relationships" r:id="Rae702987c6a5429e"/>
   </p:notesMasterIdLst>
   <p:sldIdLst>
-    <p:sldId xmlns:r="http://schemas.openxmlformats.org/officeDocument/2006/relationships" id="256" r:id="R33c7e37091494555"/>
-    <p:sldId xmlns:r="http://schemas.openxmlformats.org/officeDocument/2006/relationships" id="257" r:id="Rbc376f2834f04f48"/>
-    <p:sldId xmlns:r="http://schemas.openxmlformats.org/officeDocument/2006/relationships" id="258" r:id="R3c307944d04c42a9"/>
-    <p:sldId xmlns:r="http://schemas.openxmlformats.org/officeDocument/2006/relationships" id="259" r:id="R75f8c3d58b39435b"/>
-    <p:sldId xmlns:r="http://schemas.openxmlformats.org/officeDocument/2006/relationships" id="260" r:id="Rbaa49995aa4443c9"/>
-    <p:sldId xmlns:r="http://schemas.openxmlformats.org/officeDocument/2006/relationships" id="261" r:id="Rf788fb8d45ae4551"/>
-    <p:sldId xmlns:r="http://schemas.openxmlformats.org/officeDocument/2006/relationships" id="262" r:id="R2db63211b1a7418d"/>
-    <p:sldId xmlns:r="http://schemas.openxmlformats.org/officeDocument/2006/relationships" id="263" r:id="R2d30aa2a4d814d0f"/>
-    <p:sldId xmlns:r="http://schemas.openxmlformats.org/officeDocument/2006/relationships" id="264" r:id="R1111658d6f3a40ac"/>
-    <p:sldId xmlns:r="http://schemas.openxmlformats.org/officeDocument/2006/relationships" id="265" r:id="Rd0387b244b804e4a"/>
-    <p:sldId xmlns:r="http://schemas.openxmlformats.org/officeDocument/2006/relationships" id="266" r:id="R3982c27fa8bf44ba"/>
-    <p:sldId xmlns:r="http://schemas.openxmlformats.org/officeDocument/2006/relationships" id="267" r:id="R02372a034e274697"/>
-    <p:sldId xmlns:r="http://schemas.openxmlformats.org/officeDocument/2006/relationships" id="268" r:id="Rb932a7e617664cf9"/>
-    <p:sldId xmlns:r="http://schemas.openxmlformats.org/officeDocument/2006/relationships" id="269" r:id="R6684adbc7c3c4087"/>
-    <p:sldId xmlns:r="http://schemas.openxmlformats.org/officeDocument/2006/relationships" id="270" r:id="R792b49c0f5714255"/>
-    <p:sldId xmlns:r="http://schemas.openxmlformats.org/officeDocument/2006/relationships" id="271" r:id="R4541f3f2de864932"/>
-    <p:sldId xmlns:r="http://schemas.openxmlformats.org/officeDocument/2006/relationships" id="272" r:id="R2cd223f7182b4625"/>
-    <p:sldId xmlns:r="http://schemas.openxmlformats.org/officeDocument/2006/relationships" id="273" r:id="R909c1c80d3a2419b"/>
-    <p:sldId xmlns:r="http://schemas.openxmlformats.org/officeDocument/2006/relationships" id="274" r:id="R1dd2708c0bac4787"/>
-    <p:sldId xmlns:r="http://schemas.openxmlformats.org/officeDocument/2006/relationships" id="275" r:id="R733105d437c345a5"/>
-    <p:sldId xmlns:r="http://schemas.openxmlformats.org/officeDocument/2006/relationships" id="276" r:id="R051da964e62a48b4"/>
-    <p:sldId xmlns:r="http://schemas.openxmlformats.org/officeDocument/2006/relationships" id="277" r:id="R70771a91d78c4281"/>
-    <p:sldId xmlns:r="http://schemas.openxmlformats.org/officeDocument/2006/relationships" id="278" r:id="Rbdcec2c3c2594929"/>
-    <p:sldId xmlns:r="http://schemas.openxmlformats.org/officeDocument/2006/relationships" id="279" r:id="R56c9e1e542c74562"/>
-    <p:sldId xmlns:r="http://schemas.openxmlformats.org/officeDocument/2006/relationships" id="280" r:id="R9937ef3502f94b57"/>
-    <p:sldId xmlns:r="http://schemas.openxmlformats.org/officeDocument/2006/relationships" id="281" r:id="R6c74cb77537a40a4"/>
+    <p:sldId xmlns:r="http://schemas.openxmlformats.org/officeDocument/2006/relationships" id="256" r:id="Rc83d3e40e03b457e"/>
+    <p:sldId xmlns:r="http://schemas.openxmlformats.org/officeDocument/2006/relationships" id="257" r:id="Rf9bcddc0cf564cbf"/>
+    <p:sldId xmlns:r="http://schemas.openxmlformats.org/officeDocument/2006/relationships" id="258" r:id="R03a998ecb04c4a4c"/>
+    <p:sldId xmlns:r="http://schemas.openxmlformats.org/officeDocument/2006/relationships" id="259" r:id="Rb451c7d0957b4dd2"/>
+    <p:sldId xmlns:r="http://schemas.openxmlformats.org/officeDocument/2006/relationships" id="260" r:id="Rde4997d4cc614fa9"/>
+    <p:sldId xmlns:r="http://schemas.openxmlformats.org/officeDocument/2006/relationships" id="261" r:id="Rb4f59ffb46884f55"/>
+    <p:sldId xmlns:r="http://schemas.openxmlformats.org/officeDocument/2006/relationships" id="262" r:id="Rb4751571797d45fa"/>
+    <p:sldId xmlns:r="http://schemas.openxmlformats.org/officeDocument/2006/relationships" id="263" r:id="Rb44cb73827ae4262"/>
+    <p:sldId xmlns:r="http://schemas.openxmlformats.org/officeDocument/2006/relationships" id="264" r:id="Rd02745f6be054363"/>
+    <p:sldId xmlns:r="http://schemas.openxmlformats.org/officeDocument/2006/relationships" id="265" r:id="R4343efe845f04457"/>
+    <p:sldId xmlns:r="http://schemas.openxmlformats.org/officeDocument/2006/relationships" id="266" r:id="R8e3ae2e0c9e444f1"/>
+    <p:sldId xmlns:r="http://schemas.openxmlformats.org/officeDocument/2006/relationships" id="267" r:id="R6f76174f040b42b7"/>
+    <p:sldId xmlns:r="http://schemas.openxmlformats.org/officeDocument/2006/relationships" id="268" r:id="R9e76b669f36d49e1"/>
+    <p:sldId xmlns:r="http://schemas.openxmlformats.org/officeDocument/2006/relationships" id="269" r:id="R51bce2330cbc4f12"/>
+    <p:sldId xmlns:r="http://schemas.openxmlformats.org/officeDocument/2006/relationships" id="270" r:id="Rde48d84fa9d34946"/>
+    <p:sldId xmlns:r="http://schemas.openxmlformats.org/officeDocument/2006/relationships" id="271" r:id="Rc7a7a03b8abe4ca3"/>
+    <p:sldId xmlns:r="http://schemas.openxmlformats.org/officeDocument/2006/relationships" id="272" r:id="Reff8d42975984343"/>
+    <p:sldId xmlns:r="http://schemas.openxmlformats.org/officeDocument/2006/relationships" id="273" r:id="Ree90b721cc62469e"/>
+    <p:sldId xmlns:r="http://schemas.openxmlformats.org/officeDocument/2006/relationships" id="274" r:id="Rfd75855a636f4c9d"/>
+    <p:sldId xmlns:r="http://schemas.openxmlformats.org/officeDocument/2006/relationships" id="275" r:id="Rd506d3ca9ae04f23"/>
+    <p:sldId xmlns:r="http://schemas.openxmlformats.org/officeDocument/2006/relationships" id="276" r:id="Rded450775c514e6b"/>
+    <p:sldId xmlns:r="http://schemas.openxmlformats.org/officeDocument/2006/relationships" id="277" r:id="R13b9d3c56d174f06"/>
+    <p:sldId xmlns:r="http://schemas.openxmlformats.org/officeDocument/2006/relationships" id="278" r:id="R8e3390b7d14b4a77"/>
+    <p:sldId xmlns:r="http://schemas.openxmlformats.org/officeDocument/2006/relationships" id="279" r:id="Rec5c23fab7d24afd"/>
+    <p:sldId xmlns:r="http://schemas.openxmlformats.org/officeDocument/2006/relationships" id="280" r:id="R987419ddb34149d3"/>
+    <p:sldId xmlns:r="http://schemas.openxmlformats.org/officeDocument/2006/relationships" id="281" r:id="R8db3c34e99024aaa"/>
   </p:sldIdLst>
   <p:sldSz cx="9144000" cy="5143500"/>
   <p:notesSz cx="6858000" cy="9144000"/>
   <p:embeddedFontLst>
     <p:embeddedFont>
       <p:font typeface="Quantico"/>
-      <p:regular xmlns:r="http://schemas.openxmlformats.org/officeDocument/2006/relationships" r:id="Rb036fd1187bf4226"/>
-      <p:bold xmlns:r="http://schemas.openxmlformats.org/officeDocument/2006/relationships" r:id="Rf2a5e55001e84e3a"/>
-      <p:italic xmlns:r="http://schemas.openxmlformats.org/officeDocument/2006/relationships" r:id="Rfe0d788190b74c48"/>
-      <p:boldItalic xmlns:r="http://schemas.openxmlformats.org/officeDocument/2006/relationships" r:id="R3052e6c6f57f4786"/>
+      <p:regular xmlns:r="http://schemas.openxmlformats.org/officeDocument/2006/relationships" r:id="Rfba20f19358a4d87"/>
+      <p:bold xmlns:r="http://schemas.openxmlformats.org/officeDocument/2006/relationships" r:id="R1e0f457907794504"/>
+      <p:italic xmlns:r="http://schemas.openxmlformats.org/officeDocument/2006/relationships" r:id="Rec5fe9435d654475"/>
+      <p:boldItalic xmlns:r="http://schemas.openxmlformats.org/officeDocument/2006/relationships" r:id="R51107f10382e4b32"/>
     </p:embeddedFont>
     <p:embeddedFont>
       <p:font typeface="Source Code Pro"/>
-      <p:regular xmlns:r="http://schemas.openxmlformats.org/officeDocument/2006/relationships" r:id="R81a4a71336614341"/>
-      <p:bold xmlns:r="http://schemas.openxmlformats.org/officeDocument/2006/relationships" r:id="R597118ed2a074743"/>
-      <p:italic xmlns:r="http://schemas.openxmlformats.org/officeDocument/2006/relationships" r:id="R6b0555c4b0714f4d"/>
-      <p:boldItalic xmlns:r="http://schemas.openxmlformats.org/officeDocument/2006/relationships" r:id="Rc9b35fb273dc4e89"/>
+      <p:regular xmlns:r="http://schemas.openxmlformats.org/officeDocument/2006/relationships" r:id="Rdecc040b29c24ef2"/>
+      <p:bold xmlns:r="http://schemas.openxmlformats.org/officeDocument/2006/relationships" r:id="Rc48a5194ca2546c2"/>
+      <p:italic xmlns:r="http://schemas.openxmlformats.org/officeDocument/2006/relationships" r:id="R1301be46e20645ab"/>
+      <p:boldItalic xmlns:r="http://schemas.openxmlformats.org/officeDocument/2006/relationships" r:id="Rcfcb47df48b04529"/>
     </p:embeddedFont>
   </p:embeddedFontLst>
   <p:defaultTextStyle>
@@ -17953,28 +17953,28 @@
   </p:cSld>
   <p:clrMap bg1="lt1" tx1="dk1" bg2="dk2" tx2="lt2" accent1="accent1" accent2="accent2" accent3="accent3" accent4="accent4" accent5="accent5" accent6="accent6" hlink="hlink" folHlink="folHlink"/>
   <p:sldLayoutIdLst>
-    <p:sldLayoutId xmlns:r="http://schemas.openxmlformats.org/officeDocument/2006/relationships" id="2147483649" r:id="R27b16fdca3f74234"/>
-    <p:sldLayoutId xmlns:r="http://schemas.openxmlformats.org/officeDocument/2006/relationships" id="2147483650" r:id="R1ca4fec8b4ac4c6d"/>
-    <p:sldLayoutId xmlns:r="http://schemas.openxmlformats.org/officeDocument/2006/relationships" id="2147483651" r:id="R06182b9b9f0b4c37"/>
-    <p:sldLayoutId xmlns:r="http://schemas.openxmlformats.org/officeDocument/2006/relationships" id="2147483652" r:id="R2e3e39e9f1e0442d"/>
-    <p:sldLayoutId xmlns:r="http://schemas.openxmlformats.org/officeDocument/2006/relationships" id="2147483653" r:id="Ra4bf0da24ffb4af1"/>
-    <p:sldLayoutId xmlns:r="http://schemas.openxmlformats.org/officeDocument/2006/relationships" id="2147483654" r:id="Rac2bce0e82164aab"/>
-    <p:sldLayoutId xmlns:r="http://schemas.openxmlformats.org/officeDocument/2006/relationships" id="2147483655" r:id="Rfc8aeb4a3a434d13"/>
-    <p:sldLayoutId xmlns:r="http://schemas.openxmlformats.org/officeDocument/2006/relationships" id="2147483656" r:id="R264ad26211d74685"/>
-    <p:sldLayoutId xmlns:r="http://schemas.openxmlformats.org/officeDocument/2006/relationships" id="2147483657" r:id="Rbddc82088e414384"/>
-    <p:sldLayoutId xmlns:r="http://schemas.openxmlformats.org/officeDocument/2006/relationships" id="2147483658" r:id="Rc743b7036a1c4c9c"/>
-    <p:sldLayoutId xmlns:r="http://schemas.openxmlformats.org/officeDocument/2006/relationships" id="2147483659" r:id="R08593d44606245e0"/>
-    <p:sldLayoutId xmlns:r="http://schemas.openxmlformats.org/officeDocument/2006/relationships" id="2147483660" r:id="R96cd3c66fbac4710"/>
-    <p:sldLayoutId xmlns:r="http://schemas.openxmlformats.org/officeDocument/2006/relationships" id="2147483661" r:id="R4ced5fb8783a477f"/>
-    <p:sldLayoutId xmlns:r="http://schemas.openxmlformats.org/officeDocument/2006/relationships" id="2147483662" r:id="Rf74d3de9531043ce"/>
-    <p:sldLayoutId xmlns:r="http://schemas.openxmlformats.org/officeDocument/2006/relationships" id="2147483663" r:id="R67af0c4de7c34044"/>
-    <p:sldLayoutId xmlns:r="http://schemas.openxmlformats.org/officeDocument/2006/relationships" id="2147483664" r:id="R6b6b4055ac9e42e9"/>
-    <p:sldLayoutId xmlns:r="http://schemas.openxmlformats.org/officeDocument/2006/relationships" id="2147483665" r:id="Rfa89669d45474808"/>
-    <p:sldLayoutId xmlns:r="http://schemas.openxmlformats.org/officeDocument/2006/relationships" id="2147483666" r:id="Rcfc9b3fc55804f46"/>
-    <p:sldLayoutId xmlns:r="http://schemas.openxmlformats.org/officeDocument/2006/relationships" id="2147483667" r:id="R927be512e2424b52"/>
-    <p:sldLayoutId xmlns:r="http://schemas.openxmlformats.org/officeDocument/2006/relationships" id="2147483668" r:id="R7e3c14293c35406a"/>
-    <p:sldLayoutId xmlns:r="http://schemas.openxmlformats.org/officeDocument/2006/relationships" id="2147483669" r:id="R32a43aa74a2640c6"/>
-    <p:sldLayoutId xmlns:r="http://schemas.openxmlformats.org/officeDocument/2006/relationships" id="2147483670" r:id="R05bf5d713f884ec5"/>
+    <p:sldLayoutId xmlns:r="http://schemas.openxmlformats.org/officeDocument/2006/relationships" id="2147483649" r:id="R21ebd40119fc4a4d"/>
+    <p:sldLayoutId xmlns:r="http://schemas.openxmlformats.org/officeDocument/2006/relationships" id="2147483650" r:id="R2f5ed9d025834e8e"/>
+    <p:sldLayoutId xmlns:r="http://schemas.openxmlformats.org/officeDocument/2006/relationships" id="2147483651" r:id="R730a2ef0a5f748d2"/>
+    <p:sldLayoutId xmlns:r="http://schemas.openxmlformats.org/officeDocument/2006/relationships" id="2147483652" r:id="R4627175da4124cec"/>
+    <p:sldLayoutId xmlns:r="http://schemas.openxmlformats.org/officeDocument/2006/relationships" id="2147483653" r:id="Ra4174e529dd54a6d"/>
+    <p:sldLayoutId xmlns:r="http://schemas.openxmlformats.org/officeDocument/2006/relationships" id="2147483654" r:id="R9bd1f42ec2ab4e2f"/>
+    <p:sldLayoutId xmlns:r="http://schemas.openxmlformats.org/officeDocument/2006/relationships" id="2147483655" r:id="R6c5209c2057a465a"/>
+    <p:sldLayoutId xmlns:r="http://schemas.openxmlformats.org/officeDocument/2006/relationships" id="2147483656" r:id="Rad2bdfae646a4841"/>
+    <p:sldLayoutId xmlns:r="http://schemas.openxmlformats.org/officeDocument/2006/relationships" id="2147483657" r:id="R7eaccfe1d3a14db5"/>
+    <p:sldLayoutId xmlns:r="http://schemas.openxmlformats.org/officeDocument/2006/relationships" id="2147483658" r:id="R3024559cb9764bb4"/>
+    <p:sldLayoutId xmlns:r="http://schemas.openxmlformats.org/officeDocument/2006/relationships" id="2147483659" r:id="R8cc8e6c365344c19"/>
+    <p:sldLayoutId xmlns:r="http://schemas.openxmlformats.org/officeDocument/2006/relationships" id="2147483660" r:id="R116a576682764054"/>
+    <p:sldLayoutId xmlns:r="http://schemas.openxmlformats.org/officeDocument/2006/relationships" id="2147483661" r:id="R7e4295cdfa3b4f10"/>
+    <p:sldLayoutId xmlns:r="http://schemas.openxmlformats.org/officeDocument/2006/relationships" id="2147483662" r:id="R5c0465a2e09a4485"/>
+    <p:sldLayoutId xmlns:r="http://schemas.openxmlformats.org/officeDocument/2006/relationships" id="2147483663" r:id="Rc94b7756d2604211"/>
+    <p:sldLayoutId xmlns:r="http://schemas.openxmlformats.org/officeDocument/2006/relationships" id="2147483664" r:id="Rdea4fc94a1cf4350"/>
+    <p:sldLayoutId xmlns:r="http://schemas.openxmlformats.org/officeDocument/2006/relationships" id="2147483665" r:id="R03d2f1c378f94235"/>
+    <p:sldLayoutId xmlns:r="http://schemas.openxmlformats.org/officeDocument/2006/relationships" id="2147483666" r:id="Re158bd60edf940e8"/>
+    <p:sldLayoutId xmlns:r="http://schemas.openxmlformats.org/officeDocument/2006/relationships" id="2147483667" r:id="R4a618a026cc948c7"/>
+    <p:sldLayoutId xmlns:r="http://schemas.openxmlformats.org/officeDocument/2006/relationships" id="2147483668" r:id="R3b25be747c9b4812"/>
+    <p:sldLayoutId xmlns:r="http://schemas.openxmlformats.org/officeDocument/2006/relationships" id="2147483669" r:id="Rb5c20ce71d954093"/>
+    <p:sldLayoutId xmlns:r="http://schemas.openxmlformats.org/officeDocument/2006/relationships" id="2147483670" r:id="Rf2b2d0c0f2744114"/>
   </p:sldLayoutIdLst>
   <p:hf sldNum="0" hdr="0" ftr="0" dt="0"/>
   <p:txStyles>
@@ -19562,7 +19562,7 @@
         </p:nvSpPr>
         <p:spPr>
           <a:xfrm xmlns:a="http://schemas.openxmlformats.org/drawingml/2006/main">
-            <a:off x="1252403" y="2678261"/>
+            <a:off x="1252403" y="2857500"/>
             <a:ext cx="4190700" cy="384600"/>
           </a:xfrm>
           <a:prstGeom xmlns:a="http://schemas.openxmlformats.org/drawingml/2006/main" prst="rect">
@@ -19609,7 +19609,7 @@
         <p:spPr>
           <a:xfrm xmlns:a="http://schemas.openxmlformats.org/drawingml/2006/main">
             <a:off x="1252403" y="1022536"/>
-            <a:ext cx="4190700" cy="548640"/>
+            <a:ext cx="4190700" cy="733500"/>
           </a:xfrm>
           <a:prstGeom xmlns:a="http://schemas.openxmlformats.org/drawingml/2006/main" prst="rect">
             <a:avLst/>
@@ -19659,7 +19659,7 @@
         </p:nvSpPr>
         <p:spPr>
           <a:xfrm xmlns:a="http://schemas.openxmlformats.org/drawingml/2006/main">
-            <a:off x="1252403" y="1620161"/>
+            <a:off x="1252403" y="1790700"/>
             <a:ext cx="4190700" cy="384600"/>
           </a:xfrm>
           <a:prstGeom xmlns:a="http://schemas.openxmlformats.org/drawingml/2006/main" prst="rect">
@@ -19706,7 +19706,7 @@
         <p:spPr>
           <a:xfrm xmlns:a="http://schemas.openxmlformats.org/drawingml/2006/main">
             <a:off x="1252403" y="2080661"/>
-            <a:ext cx="4190700" cy="548640"/>
+            <a:ext cx="4190700" cy="733500"/>
           </a:xfrm>
           <a:prstGeom xmlns:a="http://schemas.openxmlformats.org/drawingml/2006/main" prst="rect">
             <a:avLst/>
@@ -19752,7 +19752,7 @@
         <p:spPr>
           <a:xfrm xmlns:a="http://schemas.openxmlformats.org/drawingml/2006/main">
             <a:off x="1252404" y="3138786"/>
-            <a:ext cx="4190700" cy="548640"/>
+            <a:ext cx="4190700" cy="733500"/>
           </a:xfrm>
           <a:prstGeom xmlns:a="http://schemas.openxmlformats.org/drawingml/2006/main" prst="rect">
             <a:avLst/>
@@ -19802,7 +19802,7 @@
         </p:nvSpPr>
         <p:spPr>
           <a:xfrm xmlns:a="http://schemas.openxmlformats.org/drawingml/2006/main">
-            <a:off x="1252404" y="3736386"/>
+            <a:off x="1252404" y="3914775"/>
             <a:ext cx="4190700" cy="384600"/>
           </a:xfrm>
           <a:prstGeom xmlns:a="http://schemas.openxmlformats.org/drawingml/2006/main" prst="rect">
@@ -20065,6 +20065,62 @@
           </a:p>
         </p:txBody>
       </p:sp>
+      <p:sp>
+        <p:nvSpPr>
+          <p:cNvPr id="313" name="slide-heading-10">
+            <a:extLst xmlns:a="http://schemas.openxmlformats.org/drawingml/2006/main">
+              <a:ext uri="{FF2B5EF4-FFF2-40B4-BE49-F238E27FC236}">
+                <a16:creationId xmlns:a16="http://schemas.microsoft.com/office/drawing/2014/main" id="{EB4D228F-D243-4881-BA76-77C63C827DC2}"/>
+              </a:ext>
+            </a:extLst>
+          </p:cNvPr>
+          <p:cNvSpPr>
+            <a:spLocks xmlns:a="http://schemas.openxmlformats.org/drawingml/2006/main" noGrp="1"/>
+          </p:cNvSpPr>
+          <p:nvPr/>
+        </p:nvSpPr>
+        <p:spPr>
+          <a:xfrm xmlns:a="http://schemas.openxmlformats.org/drawingml/2006/main">
+            <a:off x="552450" y="219075"/>
+            <a:ext cx="6858000" cy="266700"/>
+          </a:xfrm>
+          <a:prstGeom xmlns:a="http://schemas.openxmlformats.org/drawingml/2006/main" prst="rect">
+            <a:avLst/>
+          </a:prstGeom>
+          <a:noFill xmlns:a="http://schemas.openxmlformats.org/drawingml/2006/main"/>
+          <a:ln xmlns:a="http://schemas.openxmlformats.org/drawingml/2006/main" w="0">
+            <a:noFill/>
+            <a:prstDash val="solid"/>
+          </a:ln>
+        </p:spPr>
+        <p:txBody>
+          <a:bodyPr xmlns:a="http://schemas.openxmlformats.org/drawingml/2006/main"/>
+          <a:lstStyle xmlns:a="http://schemas.openxmlformats.org/drawingml/2006/main"/>
+          <a:p xmlns:a="http://schemas.openxmlformats.org/drawingml/2006/main">
+            <a:pPr algn="l">
+              <a:defRPr sz="1350" b="1">
+                <a:solidFill>
+                  <a:srgbClr val="FFFFFF"/>
+                </a:solidFill>
+                <a:latin typeface="Source Code Pro"/>
+                <a:ea typeface="Source Code Pro"/>
+                <a:cs typeface="Source Code Pro"/>
+              </a:defRPr>
+            </a:pPr>
+            <a:r>
+              <a:rPr sz="1350" b="1">
+                <a:solidFill>
+                  <a:srgbClr val="FFFFFF"/>
+                </a:solidFill>
+                <a:latin typeface="Source Code Pro"/>
+                <a:ea typeface="Source Code Pro"/>
+                <a:cs typeface="Source Code Pro"/>
+              </a:rPr>
+              <a:t>Find class in Microsoft Teams</a:t>
+            </a:r>
+          </a:p>
+        </p:txBody>
+      </p:sp>
     </p:spTree>
     <p:extLst>
       <p:ext uri="{BB962C8B-B14F-4D97-AF65-F5344CB8AC3E}">
@@ -20105,7 +20161,7 @@
         </p:nvSpPr>
         <p:spPr>
           <a:xfrm xmlns:a="http://schemas.openxmlformats.org/drawingml/2006/main">
-            <a:off x="1252403" y="2678261"/>
+            <a:off x="1252403" y="2857500"/>
             <a:ext cx="4190700" cy="384600"/>
           </a:xfrm>
           <a:prstGeom xmlns:a="http://schemas.openxmlformats.org/drawingml/2006/main" prst="rect">
@@ -20152,7 +20208,7 @@
         <p:spPr>
           <a:xfrm xmlns:a="http://schemas.openxmlformats.org/drawingml/2006/main">
             <a:off x="1252403" y="1022536"/>
-            <a:ext cx="4190700" cy="548640"/>
+            <a:ext cx="4190700" cy="733500"/>
           </a:xfrm>
           <a:prstGeom xmlns:a="http://schemas.openxmlformats.org/drawingml/2006/main" prst="rect">
             <a:avLst/>
@@ -20202,7 +20258,7 @@
         </p:nvSpPr>
         <p:spPr>
           <a:xfrm xmlns:a="http://schemas.openxmlformats.org/drawingml/2006/main">
-            <a:off x="1252403" y="1620161"/>
+            <a:off x="1252403" y="1790700"/>
             <a:ext cx="4190700" cy="384600"/>
           </a:xfrm>
           <a:prstGeom xmlns:a="http://schemas.openxmlformats.org/drawingml/2006/main" prst="rect">
@@ -20249,7 +20305,7 @@
         <p:spPr>
           <a:xfrm xmlns:a="http://schemas.openxmlformats.org/drawingml/2006/main">
             <a:off x="1252403" y="2080661"/>
-            <a:ext cx="4190700" cy="548640"/>
+            <a:ext cx="4190700" cy="733500"/>
           </a:xfrm>
           <a:prstGeom xmlns:a="http://schemas.openxmlformats.org/drawingml/2006/main" prst="rect">
             <a:avLst/>
@@ -20295,7 +20351,7 @@
         <p:spPr>
           <a:xfrm xmlns:a="http://schemas.openxmlformats.org/drawingml/2006/main">
             <a:off x="1252404" y="3138786"/>
-            <a:ext cx="4190700" cy="548640"/>
+            <a:ext cx="4190700" cy="733500"/>
           </a:xfrm>
           <a:prstGeom xmlns:a="http://schemas.openxmlformats.org/drawingml/2006/main" prst="rect">
             <a:avLst/>
@@ -20345,7 +20401,7 @@
         </p:nvSpPr>
         <p:spPr>
           <a:xfrm xmlns:a="http://schemas.openxmlformats.org/drawingml/2006/main">
-            <a:off x="1252404" y="3736386"/>
+            <a:off x="1252404" y="3914775"/>
             <a:ext cx="4190700" cy="384600"/>
           </a:xfrm>
           <a:prstGeom xmlns:a="http://schemas.openxmlformats.org/drawingml/2006/main" prst="rect">
@@ -20608,6 +20664,62 @@
           </a:p>
         </p:txBody>
       </p:sp>
+      <p:sp>
+        <p:nvSpPr>
+          <p:cNvPr id="313" name="slide-heading-11">
+            <a:extLst xmlns:a="http://schemas.openxmlformats.org/drawingml/2006/main">
+              <a:ext uri="{FF2B5EF4-FFF2-40B4-BE49-F238E27FC236}">
+                <a16:creationId xmlns:a16="http://schemas.microsoft.com/office/drawing/2014/main" id="{9DE39D22-8A17-4CC3-AD46-A745C8F2AF0D}"/>
+              </a:ext>
+            </a:extLst>
+          </p:cNvPr>
+          <p:cNvSpPr>
+            <a:spLocks xmlns:a="http://schemas.openxmlformats.org/drawingml/2006/main" noGrp="1"/>
+          </p:cNvSpPr>
+          <p:nvPr/>
+        </p:nvSpPr>
+        <p:spPr>
+          <a:xfrm xmlns:a="http://schemas.openxmlformats.org/drawingml/2006/main">
+            <a:off x="552450" y="219075"/>
+            <a:ext cx="6858000" cy="266700"/>
+          </a:xfrm>
+          <a:prstGeom xmlns:a="http://schemas.openxmlformats.org/drawingml/2006/main" prst="rect">
+            <a:avLst/>
+          </a:prstGeom>
+          <a:noFill xmlns:a="http://schemas.openxmlformats.org/drawingml/2006/main"/>
+          <a:ln xmlns:a="http://schemas.openxmlformats.org/drawingml/2006/main" w="0">
+            <a:noFill/>
+            <a:prstDash val="solid"/>
+          </a:ln>
+        </p:spPr>
+        <p:txBody>
+          <a:bodyPr xmlns:a="http://schemas.openxmlformats.org/drawingml/2006/main"/>
+          <a:lstStyle xmlns:a="http://schemas.openxmlformats.org/drawingml/2006/main"/>
+          <a:p xmlns:a="http://schemas.openxmlformats.org/drawingml/2006/main">
+            <a:pPr algn="l">
+              <a:defRPr sz="1350" b="1">
+                <a:solidFill>
+                  <a:srgbClr val="FFFFFF"/>
+                </a:solidFill>
+                <a:latin typeface="Source Code Pro"/>
+                <a:ea typeface="Source Code Pro"/>
+                <a:cs typeface="Source Code Pro"/>
+              </a:defRPr>
+            </a:pPr>
+            <a:r>
+              <a:rPr sz="1350" b="1">
+                <a:solidFill>
+                  <a:srgbClr val="FFFFFF"/>
+                </a:solidFill>
+                <a:latin typeface="Source Code Pro"/>
+                <a:ea typeface="Source Code Pro"/>
+                <a:cs typeface="Source Code Pro"/>
+              </a:rPr>
+              <a:t>Know the Teams channels</a:t>
+            </a:r>
+          </a:p>
+        </p:txBody>
+      </p:sp>
     </p:spTree>
     <p:extLst>
       <p:ext uri="{BB962C8B-B14F-4D97-AF65-F5344CB8AC3E}">
@@ -20648,7 +20760,7 @@
         </p:nvSpPr>
         <p:spPr>
           <a:xfrm xmlns:a="http://schemas.openxmlformats.org/drawingml/2006/main">
-            <a:off x="1252403" y="2678261"/>
+            <a:off x="1252403" y="2857500"/>
             <a:ext cx="4190700" cy="384600"/>
           </a:xfrm>
           <a:prstGeom xmlns:a="http://schemas.openxmlformats.org/drawingml/2006/main" prst="rect">
@@ -20695,7 +20807,7 @@
         <p:spPr>
           <a:xfrm xmlns:a="http://schemas.openxmlformats.org/drawingml/2006/main">
             <a:off x="1252403" y="1022536"/>
-            <a:ext cx="4190700" cy="548640"/>
+            <a:ext cx="4190700" cy="733500"/>
           </a:xfrm>
           <a:prstGeom xmlns:a="http://schemas.openxmlformats.org/drawingml/2006/main" prst="rect">
             <a:avLst/>
@@ -20745,7 +20857,7 @@
         </p:nvSpPr>
         <p:spPr>
           <a:xfrm xmlns:a="http://schemas.openxmlformats.org/drawingml/2006/main">
-            <a:off x="1252403" y="1620161"/>
+            <a:off x="1252403" y="1790700"/>
             <a:ext cx="4190700" cy="384600"/>
           </a:xfrm>
           <a:prstGeom xmlns:a="http://schemas.openxmlformats.org/drawingml/2006/main" prst="rect">
@@ -20792,7 +20904,7 @@
         <p:spPr>
           <a:xfrm xmlns:a="http://schemas.openxmlformats.org/drawingml/2006/main">
             <a:off x="1252403" y="2080661"/>
-            <a:ext cx="4190700" cy="548640"/>
+            <a:ext cx="4190700" cy="733500"/>
           </a:xfrm>
           <a:prstGeom xmlns:a="http://schemas.openxmlformats.org/drawingml/2006/main" prst="rect">
             <a:avLst/>
@@ -20838,7 +20950,7 @@
         <p:spPr>
           <a:xfrm xmlns:a="http://schemas.openxmlformats.org/drawingml/2006/main">
             <a:off x="1252404" y="3138786"/>
-            <a:ext cx="4190700" cy="548640"/>
+            <a:ext cx="4190700" cy="733500"/>
           </a:xfrm>
           <a:prstGeom xmlns:a="http://schemas.openxmlformats.org/drawingml/2006/main" prst="rect">
             <a:avLst/>
@@ -20888,7 +21000,7 @@
         </p:nvSpPr>
         <p:spPr>
           <a:xfrm xmlns:a="http://schemas.openxmlformats.org/drawingml/2006/main">
-            <a:off x="1252404" y="3736386"/>
+            <a:off x="1252404" y="3914775"/>
             <a:ext cx="4190700" cy="384600"/>
           </a:xfrm>
           <a:prstGeom xmlns:a="http://schemas.openxmlformats.org/drawingml/2006/main" prst="rect">
@@ -21151,6 +21263,62 @@
           </a:p>
         </p:txBody>
       </p:sp>
+      <p:sp>
+        <p:nvSpPr>
+          <p:cNvPr id="313" name="slide-heading-12">
+            <a:extLst xmlns:a="http://schemas.openxmlformats.org/drawingml/2006/main">
+              <a:ext uri="{FF2B5EF4-FFF2-40B4-BE49-F238E27FC236}">
+                <a16:creationId xmlns:a16="http://schemas.microsoft.com/office/drawing/2014/main" id="{E9F6E9FD-1A91-403A-9E34-4884CF214F5B}"/>
+              </a:ext>
+            </a:extLst>
+          </p:cNvPr>
+          <p:cNvSpPr>
+            <a:spLocks xmlns:a="http://schemas.openxmlformats.org/drawingml/2006/main" noGrp="1"/>
+          </p:cNvSpPr>
+          <p:nvPr/>
+        </p:nvSpPr>
+        <p:spPr>
+          <a:xfrm xmlns:a="http://schemas.openxmlformats.org/drawingml/2006/main">
+            <a:off x="552450" y="219075"/>
+            <a:ext cx="6858000" cy="266700"/>
+          </a:xfrm>
+          <a:prstGeom xmlns:a="http://schemas.openxmlformats.org/drawingml/2006/main" prst="rect">
+            <a:avLst/>
+          </a:prstGeom>
+          <a:noFill xmlns:a="http://schemas.openxmlformats.org/drawingml/2006/main"/>
+          <a:ln xmlns:a="http://schemas.openxmlformats.org/drawingml/2006/main" w="0">
+            <a:noFill/>
+            <a:prstDash val="solid"/>
+          </a:ln>
+        </p:spPr>
+        <p:txBody>
+          <a:bodyPr xmlns:a="http://schemas.openxmlformats.org/drawingml/2006/main"/>
+          <a:lstStyle xmlns:a="http://schemas.openxmlformats.org/drawingml/2006/main"/>
+          <a:p xmlns:a="http://schemas.openxmlformats.org/drawingml/2006/main">
+            <a:pPr algn="l">
+              <a:defRPr sz="1350" b="1">
+                <a:solidFill>
+                  <a:srgbClr val="FFFFFF"/>
+                </a:solidFill>
+                <a:latin typeface="Source Code Pro"/>
+                <a:ea typeface="Source Code Pro"/>
+                <a:cs typeface="Source Code Pro"/>
+              </a:defRPr>
+            </a:pPr>
+            <a:r>
+              <a:rPr sz="1350" b="1">
+                <a:solidFill>
+                  <a:srgbClr val="FFFFFF"/>
+                </a:solidFill>
+                <a:latin typeface="Source Code Pro"/>
+                <a:ea typeface="Source Code Pro"/>
+                <a:cs typeface="Source Code Pro"/>
+              </a:rPr>
+              <a:t>Use hangout for extra help</a:t>
+            </a:r>
+          </a:p>
+        </p:txBody>
+      </p:sp>
     </p:spTree>
     <p:extLst>
       <p:ext uri="{BB962C8B-B14F-4D97-AF65-F5344CB8AC3E}">
@@ -21191,7 +21359,7 @@
         </p:nvSpPr>
         <p:spPr>
           <a:xfrm xmlns:a="http://schemas.openxmlformats.org/drawingml/2006/main">
-            <a:off x="1252403" y="2678261"/>
+            <a:off x="1252403" y="2857500"/>
             <a:ext cx="4190700" cy="384600"/>
           </a:xfrm>
           <a:prstGeom xmlns:a="http://schemas.openxmlformats.org/drawingml/2006/main" prst="rect">
@@ -21238,7 +21406,7 @@
         <p:spPr>
           <a:xfrm xmlns:a="http://schemas.openxmlformats.org/drawingml/2006/main">
             <a:off x="1252403" y="1022536"/>
-            <a:ext cx="4190700" cy="548640"/>
+            <a:ext cx="4190700" cy="733500"/>
           </a:xfrm>
           <a:prstGeom xmlns:a="http://schemas.openxmlformats.org/drawingml/2006/main" prst="rect">
             <a:avLst/>
@@ -21291,7 +21459,7 @@
         </p:nvSpPr>
         <p:spPr>
           <a:xfrm xmlns:a="http://schemas.openxmlformats.org/drawingml/2006/main">
-            <a:off x="1252403" y="1620161"/>
+            <a:off x="1252403" y="1790700"/>
             <a:ext cx="4190700" cy="384600"/>
           </a:xfrm>
           <a:prstGeom xmlns:a="http://schemas.openxmlformats.org/drawingml/2006/main" prst="rect">
@@ -21338,7 +21506,7 @@
         <p:spPr>
           <a:xfrm xmlns:a="http://schemas.openxmlformats.org/drawingml/2006/main">
             <a:off x="1252403" y="2080661"/>
-            <a:ext cx="4190700" cy="548640"/>
+            <a:ext cx="4190700" cy="733500"/>
           </a:xfrm>
           <a:prstGeom xmlns:a="http://schemas.openxmlformats.org/drawingml/2006/main" prst="rect">
             <a:avLst/>
@@ -21392,7 +21560,7 @@
         <p:spPr>
           <a:xfrm xmlns:a="http://schemas.openxmlformats.org/drawingml/2006/main">
             <a:off x="1252404" y="3138786"/>
-            <a:ext cx="4190700" cy="548640"/>
+            <a:ext cx="4190700" cy="733500"/>
           </a:xfrm>
           <a:prstGeom xmlns:a="http://schemas.openxmlformats.org/drawingml/2006/main" prst="rect">
             <a:avLst/>
@@ -21445,7 +21613,7 @@
         </p:nvSpPr>
         <p:spPr>
           <a:xfrm xmlns:a="http://schemas.openxmlformats.org/drawingml/2006/main">
-            <a:off x="1252404" y="3736386"/>
+            <a:off x="1252404" y="3914775"/>
             <a:ext cx="4190700" cy="384600"/>
           </a:xfrm>
           <a:prstGeom xmlns:a="http://schemas.openxmlformats.org/drawingml/2006/main" prst="rect">
@@ -21704,6 +21872,62 @@
                 </a:solidFill>
               </a:rPr>
               <a:t>[</a:t>
+            </a:r>
+          </a:p>
+        </p:txBody>
+      </p:sp>
+      <p:sp>
+        <p:nvSpPr>
+          <p:cNvPr id="313" name="slide-heading-13">
+            <a:extLst xmlns:a="http://schemas.openxmlformats.org/drawingml/2006/main">
+              <a:ext uri="{FF2B5EF4-FFF2-40B4-BE49-F238E27FC236}">
+                <a16:creationId xmlns:a16="http://schemas.microsoft.com/office/drawing/2014/main" id="{4ECF204A-636A-4922-8392-3A1E06A68D47}"/>
+              </a:ext>
+            </a:extLst>
+          </p:cNvPr>
+          <p:cNvSpPr>
+            <a:spLocks xmlns:a="http://schemas.openxmlformats.org/drawingml/2006/main" noGrp="1"/>
+          </p:cNvSpPr>
+          <p:nvPr/>
+        </p:nvSpPr>
+        <p:spPr>
+          <a:xfrm xmlns:a="http://schemas.openxmlformats.org/drawingml/2006/main">
+            <a:off x="552450" y="219075"/>
+            <a:ext cx="6858000" cy="266700"/>
+          </a:xfrm>
+          <a:prstGeom xmlns:a="http://schemas.openxmlformats.org/drawingml/2006/main" prst="rect">
+            <a:avLst/>
+          </a:prstGeom>
+          <a:noFill xmlns:a="http://schemas.openxmlformats.org/drawingml/2006/main"/>
+          <a:ln xmlns:a="http://schemas.openxmlformats.org/drawingml/2006/main" w="0">
+            <a:noFill/>
+            <a:prstDash val="solid"/>
+          </a:ln>
+        </p:spPr>
+        <p:txBody>
+          <a:bodyPr xmlns:a="http://schemas.openxmlformats.org/drawingml/2006/main"/>
+          <a:lstStyle xmlns:a="http://schemas.openxmlformats.org/drawingml/2006/main"/>
+          <a:p xmlns:a="http://schemas.openxmlformats.org/drawingml/2006/main">
+            <a:pPr algn="l">
+              <a:defRPr sz="1350" b="1">
+                <a:solidFill>
+                  <a:srgbClr val="FFFFFF"/>
+                </a:solidFill>
+                <a:latin typeface="Source Code Pro"/>
+                <a:ea typeface="Source Code Pro"/>
+                <a:cs typeface="Source Code Pro"/>
+              </a:defRPr>
+            </a:pPr>
+            <a:r>
+              <a:rPr sz="1350" b="1">
+                <a:solidFill>
+                  <a:srgbClr val="FFFFFF"/>
+                </a:solidFill>
+                <a:latin typeface="Source Code Pro"/>
+                <a:ea typeface="Source Code Pro"/>
+                <a:cs typeface="Source Code Pro"/>
+              </a:rPr>
+              <a:t>Class habits that help everyone</a:t>
             </a:r>
           </a:p>
         </p:txBody>
@@ -23956,7 +24180,7 @@
         </p:nvSpPr>
         <p:spPr>
           <a:xfrm xmlns:a="http://schemas.openxmlformats.org/drawingml/2006/main">
-            <a:off x="1252403" y="2678261"/>
+            <a:off x="1252403" y="2857500"/>
             <a:ext cx="4190700" cy="384600"/>
           </a:xfrm>
           <a:prstGeom xmlns:a="http://schemas.openxmlformats.org/drawingml/2006/main" prst="rect">
@@ -24003,7 +24227,7 @@
         <p:spPr>
           <a:xfrm xmlns:a="http://schemas.openxmlformats.org/drawingml/2006/main">
             <a:off x="1252403" y="1022536"/>
-            <a:ext cx="4190700" cy="548640"/>
+            <a:ext cx="4190700" cy="733500"/>
           </a:xfrm>
           <a:prstGeom xmlns:a="http://schemas.openxmlformats.org/drawingml/2006/main" prst="rect">
             <a:avLst/>
@@ -24053,7 +24277,7 @@
         </p:nvSpPr>
         <p:spPr>
           <a:xfrm xmlns:a="http://schemas.openxmlformats.org/drawingml/2006/main">
-            <a:off x="1252403" y="1620161"/>
+            <a:off x="1252403" y="1790700"/>
             <a:ext cx="4190700" cy="384600"/>
           </a:xfrm>
           <a:prstGeom xmlns:a="http://schemas.openxmlformats.org/drawingml/2006/main" prst="rect">
@@ -24100,7 +24324,7 @@
         <p:spPr>
           <a:xfrm xmlns:a="http://schemas.openxmlformats.org/drawingml/2006/main">
             <a:off x="1252403" y="2080661"/>
-            <a:ext cx="4190700" cy="548640"/>
+            <a:ext cx="4190700" cy="733500"/>
           </a:xfrm>
           <a:prstGeom xmlns:a="http://schemas.openxmlformats.org/drawingml/2006/main" prst="rect">
             <a:avLst/>
@@ -24146,7 +24370,7 @@
         <p:spPr>
           <a:xfrm xmlns:a="http://schemas.openxmlformats.org/drawingml/2006/main">
             <a:off x="1252404" y="3138786"/>
-            <a:ext cx="4190700" cy="548640"/>
+            <a:ext cx="4190700" cy="733500"/>
           </a:xfrm>
           <a:prstGeom xmlns:a="http://schemas.openxmlformats.org/drawingml/2006/main" prst="rect">
             <a:avLst/>
@@ -24196,7 +24420,7 @@
         </p:nvSpPr>
         <p:spPr>
           <a:xfrm xmlns:a="http://schemas.openxmlformats.org/drawingml/2006/main">
-            <a:off x="1252404" y="3736386"/>
+            <a:off x="1252404" y="3914775"/>
             <a:ext cx="4190700" cy="384600"/>
           </a:xfrm>
           <a:prstGeom xmlns:a="http://schemas.openxmlformats.org/drawingml/2006/main" prst="rect">
@@ -24459,6 +24683,62 @@
           </a:p>
         </p:txBody>
       </p:sp>
+      <p:sp>
+        <p:nvSpPr>
+          <p:cNvPr id="313" name="slide-heading-17">
+            <a:extLst xmlns:a="http://schemas.openxmlformats.org/drawingml/2006/main">
+              <a:ext uri="{FF2B5EF4-FFF2-40B4-BE49-F238E27FC236}">
+                <a16:creationId xmlns:a16="http://schemas.microsoft.com/office/drawing/2014/main" id="{87C46D78-4836-4F18-AD1F-869A79E49118}"/>
+              </a:ext>
+            </a:extLst>
+          </p:cNvPr>
+          <p:cNvSpPr>
+            <a:spLocks xmlns:a="http://schemas.openxmlformats.org/drawingml/2006/main" noGrp="1"/>
+          </p:cNvSpPr>
+          <p:nvPr/>
+        </p:nvSpPr>
+        <p:spPr>
+          <a:xfrm xmlns:a="http://schemas.openxmlformats.org/drawingml/2006/main">
+            <a:off x="552450" y="219075"/>
+            <a:ext cx="6858000" cy="266700"/>
+          </a:xfrm>
+          <a:prstGeom xmlns:a="http://schemas.openxmlformats.org/drawingml/2006/main" prst="rect">
+            <a:avLst/>
+          </a:prstGeom>
+          <a:noFill xmlns:a="http://schemas.openxmlformats.org/drawingml/2006/main"/>
+          <a:ln xmlns:a="http://schemas.openxmlformats.org/drawingml/2006/main" w="0">
+            <a:noFill/>
+            <a:prstDash val="solid"/>
+          </a:ln>
+        </p:spPr>
+        <p:txBody>
+          <a:bodyPr xmlns:a="http://schemas.openxmlformats.org/drawingml/2006/main"/>
+          <a:lstStyle xmlns:a="http://schemas.openxmlformats.org/drawingml/2006/main"/>
+          <a:p xmlns:a="http://schemas.openxmlformats.org/drawingml/2006/main">
+            <a:pPr algn="l">
+              <a:defRPr sz="1350" b="1">
+                <a:solidFill>
+                  <a:srgbClr val="FFFFFF"/>
+                </a:solidFill>
+                <a:latin typeface="Source Code Pro"/>
+                <a:ea typeface="Source Code Pro"/>
+                <a:cs typeface="Source Code Pro"/>
+              </a:defRPr>
+            </a:pPr>
+            <a:r>
+              <a:rPr sz="1350" b="1">
+                <a:solidFill>
+                  <a:srgbClr val="FFFFFF"/>
+                </a:solidFill>
+                <a:latin typeface="Source Code Pro"/>
+                <a:ea typeface="Source Code Pro"/>
+                <a:cs typeface="Source Code Pro"/>
+              </a:rPr>
+              <a:t>Breakout room jobs</a:t>
+            </a:r>
+          </a:p>
+        </p:txBody>
+      </p:sp>
     </p:spTree>
     <p:extLst>
       <p:ext uri="{BB962C8B-B14F-4D97-AF65-F5344CB8AC3E}">
@@ -24499,7 +24779,7 @@
         </p:nvSpPr>
         <p:spPr>
           <a:xfrm xmlns:a="http://schemas.openxmlformats.org/drawingml/2006/main">
-            <a:off x="1252403" y="2678261"/>
+            <a:off x="1252403" y="2857500"/>
             <a:ext cx="4190700" cy="384600"/>
           </a:xfrm>
           <a:prstGeom xmlns:a="http://schemas.openxmlformats.org/drawingml/2006/main" prst="rect">
@@ -24546,7 +24826,7 @@
         <p:spPr>
           <a:xfrm xmlns:a="http://schemas.openxmlformats.org/drawingml/2006/main">
             <a:off x="1252403" y="1022536"/>
-            <a:ext cx="4190700" cy="548640"/>
+            <a:ext cx="4190700" cy="733500"/>
           </a:xfrm>
           <a:prstGeom xmlns:a="http://schemas.openxmlformats.org/drawingml/2006/main" prst="rect">
             <a:avLst/>
@@ -24596,7 +24876,7 @@
         </p:nvSpPr>
         <p:spPr>
           <a:xfrm xmlns:a="http://schemas.openxmlformats.org/drawingml/2006/main">
-            <a:off x="1252403" y="1620161"/>
+            <a:off x="1252403" y="1790700"/>
             <a:ext cx="4190700" cy="384600"/>
           </a:xfrm>
           <a:prstGeom xmlns:a="http://schemas.openxmlformats.org/drawingml/2006/main" prst="rect">
@@ -24643,7 +24923,7 @@
         <p:spPr>
           <a:xfrm xmlns:a="http://schemas.openxmlformats.org/drawingml/2006/main">
             <a:off x="1252403" y="2080661"/>
-            <a:ext cx="4190700" cy="548640"/>
+            <a:ext cx="4190700" cy="733500"/>
           </a:xfrm>
           <a:prstGeom xmlns:a="http://schemas.openxmlformats.org/drawingml/2006/main" prst="rect">
             <a:avLst/>
@@ -24689,7 +24969,7 @@
         <p:spPr>
           <a:xfrm xmlns:a="http://schemas.openxmlformats.org/drawingml/2006/main">
             <a:off x="1252404" y="3138786"/>
-            <a:ext cx="4190700" cy="548640"/>
+            <a:ext cx="4190700" cy="733500"/>
           </a:xfrm>
           <a:prstGeom xmlns:a="http://schemas.openxmlformats.org/drawingml/2006/main" prst="rect">
             <a:avLst/>
@@ -24739,7 +25019,7 @@
         </p:nvSpPr>
         <p:spPr>
           <a:xfrm xmlns:a="http://schemas.openxmlformats.org/drawingml/2006/main">
-            <a:off x="1252404" y="3736386"/>
+            <a:off x="1252404" y="3914775"/>
             <a:ext cx="4190700" cy="384600"/>
           </a:xfrm>
           <a:prstGeom xmlns:a="http://schemas.openxmlformats.org/drawingml/2006/main" prst="rect">
@@ -25002,6 +25282,62 @@
           </a:p>
         </p:txBody>
       </p:sp>
+      <p:sp>
+        <p:nvSpPr>
+          <p:cNvPr id="313" name="slide-heading-18">
+            <a:extLst xmlns:a="http://schemas.openxmlformats.org/drawingml/2006/main">
+              <a:ext uri="{FF2B5EF4-FFF2-40B4-BE49-F238E27FC236}">
+                <a16:creationId xmlns:a16="http://schemas.microsoft.com/office/drawing/2014/main" id="{D99756FA-5D29-4B40-AB32-0BA3B9CC34F3}"/>
+              </a:ext>
+            </a:extLst>
+          </p:cNvPr>
+          <p:cNvSpPr>
+            <a:spLocks xmlns:a="http://schemas.openxmlformats.org/drawingml/2006/main" noGrp="1"/>
+          </p:cNvSpPr>
+          <p:nvPr/>
+        </p:nvSpPr>
+        <p:spPr>
+          <a:xfrm xmlns:a="http://schemas.openxmlformats.org/drawingml/2006/main">
+            <a:off x="552450" y="219075"/>
+            <a:ext cx="6858000" cy="266700"/>
+          </a:xfrm>
+          <a:prstGeom xmlns:a="http://schemas.openxmlformats.org/drawingml/2006/main" prst="rect">
+            <a:avLst/>
+          </a:prstGeom>
+          <a:noFill xmlns:a="http://schemas.openxmlformats.org/drawingml/2006/main"/>
+          <a:ln xmlns:a="http://schemas.openxmlformats.org/drawingml/2006/main" w="0">
+            <a:noFill/>
+            <a:prstDash val="solid"/>
+          </a:ln>
+        </p:spPr>
+        <p:txBody>
+          <a:bodyPr xmlns:a="http://schemas.openxmlformats.org/drawingml/2006/main"/>
+          <a:lstStyle xmlns:a="http://schemas.openxmlformats.org/drawingml/2006/main"/>
+          <a:p xmlns:a="http://schemas.openxmlformats.org/drawingml/2006/main">
+            <a:pPr algn="l">
+              <a:defRPr sz="1350" b="1">
+                <a:solidFill>
+                  <a:srgbClr val="FFFFFF"/>
+                </a:solidFill>
+                <a:latin typeface="Source Code Pro"/>
+                <a:ea typeface="Source Code Pro"/>
+                <a:cs typeface="Source Code Pro"/>
+              </a:defRPr>
+            </a:pPr>
+            <a:r>
+              <a:rPr sz="1350" b="1">
+                <a:solidFill>
+                  <a:srgbClr val="FFFFFF"/>
+                </a:solidFill>
+                <a:latin typeface="Source Code Pro"/>
+                <a:ea typeface="Source Code Pro"/>
+                <a:cs typeface="Source Code Pro"/>
+              </a:rPr>
+              <a:t>How to work as a code crew</a:t>
+            </a:r>
+          </a:p>
+        </p:txBody>
+      </p:sp>
     </p:spTree>
     <p:extLst>
       <p:ext uri="{BB962C8B-B14F-4D97-AF65-F5344CB8AC3E}">
@@ -25042,7 +25378,7 @@
         </p:nvSpPr>
         <p:spPr>
           <a:xfrm xmlns:a="http://schemas.openxmlformats.org/drawingml/2006/main">
-            <a:off x="1252403" y="2678261"/>
+            <a:off x="1252403" y="2857500"/>
             <a:ext cx="4190700" cy="384600"/>
           </a:xfrm>
           <a:prstGeom xmlns:a="http://schemas.openxmlformats.org/drawingml/2006/main" prst="rect">
@@ -25089,7 +25425,7 @@
         <p:spPr>
           <a:xfrm xmlns:a="http://schemas.openxmlformats.org/drawingml/2006/main">
             <a:off x="1252403" y="1022536"/>
-            <a:ext cx="4190700" cy="548640"/>
+            <a:ext cx="4190700" cy="733500"/>
           </a:xfrm>
           <a:prstGeom xmlns:a="http://schemas.openxmlformats.org/drawingml/2006/main" prst="rect">
             <a:avLst/>
@@ -25139,7 +25475,7 @@
         </p:nvSpPr>
         <p:spPr>
           <a:xfrm xmlns:a="http://schemas.openxmlformats.org/drawingml/2006/main">
-            <a:off x="1252403" y="1620161"/>
+            <a:off x="1252403" y="1790700"/>
             <a:ext cx="4190700" cy="384600"/>
           </a:xfrm>
           <a:prstGeom xmlns:a="http://schemas.openxmlformats.org/drawingml/2006/main" prst="rect">
@@ -25186,7 +25522,7 @@
         <p:spPr>
           <a:xfrm xmlns:a="http://schemas.openxmlformats.org/drawingml/2006/main">
             <a:off x="1252403" y="2080661"/>
-            <a:ext cx="4190700" cy="548640"/>
+            <a:ext cx="4190700" cy="733500"/>
           </a:xfrm>
           <a:prstGeom xmlns:a="http://schemas.openxmlformats.org/drawingml/2006/main" prst="rect">
             <a:avLst/>
@@ -25232,7 +25568,7 @@
         <p:spPr>
           <a:xfrm xmlns:a="http://schemas.openxmlformats.org/drawingml/2006/main">
             <a:off x="1252404" y="3138786"/>
-            <a:ext cx="4190700" cy="548640"/>
+            <a:ext cx="4190700" cy="733500"/>
           </a:xfrm>
           <a:prstGeom xmlns:a="http://schemas.openxmlformats.org/drawingml/2006/main" prst="rect">
             <a:avLst/>
@@ -25282,7 +25618,7 @@
         </p:nvSpPr>
         <p:spPr>
           <a:xfrm xmlns:a="http://schemas.openxmlformats.org/drawingml/2006/main">
-            <a:off x="1252404" y="3736386"/>
+            <a:off x="1252404" y="3914775"/>
             <a:ext cx="4190700" cy="384600"/>
           </a:xfrm>
           <a:prstGeom xmlns:a="http://schemas.openxmlformats.org/drawingml/2006/main" prst="rect">
@@ -25545,6 +25881,62 @@
           </a:p>
         </p:txBody>
       </p:sp>
+      <p:sp>
+        <p:nvSpPr>
+          <p:cNvPr id="313" name="slide-heading-19">
+            <a:extLst xmlns:a="http://schemas.openxmlformats.org/drawingml/2006/main">
+              <a:ext uri="{FF2B5EF4-FFF2-40B4-BE49-F238E27FC236}">
+                <a16:creationId xmlns:a16="http://schemas.microsoft.com/office/drawing/2014/main" id="{B4DFFC3B-38DB-4F89-B81C-9AD2BCCEEDE4}"/>
+              </a:ext>
+            </a:extLst>
+          </p:cNvPr>
+          <p:cNvSpPr>
+            <a:spLocks xmlns:a="http://schemas.openxmlformats.org/drawingml/2006/main" noGrp="1"/>
+          </p:cNvSpPr>
+          <p:nvPr/>
+        </p:nvSpPr>
+        <p:spPr>
+          <a:xfrm xmlns:a="http://schemas.openxmlformats.org/drawingml/2006/main">
+            <a:off x="552450" y="219075"/>
+            <a:ext cx="6858000" cy="266700"/>
+          </a:xfrm>
+          <a:prstGeom xmlns:a="http://schemas.openxmlformats.org/drawingml/2006/main" prst="rect">
+            <a:avLst/>
+          </a:prstGeom>
+          <a:noFill xmlns:a="http://schemas.openxmlformats.org/drawingml/2006/main"/>
+          <a:ln xmlns:a="http://schemas.openxmlformats.org/drawingml/2006/main" w="0">
+            <a:noFill/>
+            <a:prstDash val="solid"/>
+          </a:ln>
+        </p:spPr>
+        <p:txBody>
+          <a:bodyPr xmlns:a="http://schemas.openxmlformats.org/drawingml/2006/main"/>
+          <a:lstStyle xmlns:a="http://schemas.openxmlformats.org/drawingml/2006/main"/>
+          <a:p xmlns:a="http://schemas.openxmlformats.org/drawingml/2006/main">
+            <a:pPr algn="l">
+              <a:defRPr sz="1350" b="1">
+                <a:solidFill>
+                  <a:srgbClr val="FFFFFF"/>
+                </a:solidFill>
+                <a:latin typeface="Source Code Pro"/>
+                <a:ea typeface="Source Code Pro"/>
+                <a:cs typeface="Source Code Pro"/>
+              </a:defRPr>
+            </a:pPr>
+            <a:r>
+              <a:rPr sz="1350" b="1">
+                <a:solidFill>
+                  <a:srgbClr val="FFFFFF"/>
+                </a:solidFill>
+                <a:latin typeface="Source Code Pro"/>
+                <a:ea typeface="Source Code Pro"/>
+                <a:cs typeface="Source Code Pro"/>
+              </a:rPr>
+              <a:t>Code.org Music Lab</a:t>
+            </a:r>
+          </a:p>
+        </p:txBody>
+      </p:sp>
     </p:spTree>
     <p:extLst>
       <p:ext uri="{BB962C8B-B14F-4D97-AF65-F5344CB8AC3E}">
@@ -25986,7 +26378,7 @@
           <p:nvPr/>
         </p:nvPicPr>
         <p:blipFill>
-          <a:blip xmlns:r="http://schemas.openxmlformats.org/officeDocument/2006/relationships" xmlns:a="http://schemas.openxmlformats.org/drawingml/2006/main" r:embed="Ra78dda24fb924957">
+          <a:blip xmlns:r="http://schemas.openxmlformats.org/officeDocument/2006/relationships" xmlns:a="http://schemas.openxmlformats.org/drawingml/2006/main" r:embed="R96d59a3c51fb40f4">
             <a:alphaModFix/>
           </a:blip>
           <a:stretch xmlns:a="http://schemas.openxmlformats.org/drawingml/2006/main">
@@ -26046,7 +26438,7 @@
         </p:nvSpPr>
         <p:spPr>
           <a:xfrm xmlns:a="http://schemas.openxmlformats.org/drawingml/2006/main">
-            <a:off x="1252403" y="2678261"/>
+            <a:off x="1252403" y="2857500"/>
             <a:ext cx="4190700" cy="384600"/>
           </a:xfrm>
           <a:prstGeom xmlns:a="http://schemas.openxmlformats.org/drawingml/2006/main" prst="rect">
@@ -26093,7 +26485,7 @@
         <p:spPr>
           <a:xfrm xmlns:a="http://schemas.openxmlformats.org/drawingml/2006/main">
             <a:off x="1252403" y="1022536"/>
-            <a:ext cx="4190700" cy="548640"/>
+            <a:ext cx="4190700" cy="733500"/>
           </a:xfrm>
           <a:prstGeom xmlns:a="http://schemas.openxmlformats.org/drawingml/2006/main" prst="rect">
             <a:avLst/>
@@ -26143,7 +26535,7 @@
         </p:nvSpPr>
         <p:spPr>
           <a:xfrm xmlns:a="http://schemas.openxmlformats.org/drawingml/2006/main">
-            <a:off x="1252403" y="1620161"/>
+            <a:off x="1252403" y="1790700"/>
             <a:ext cx="4190700" cy="384600"/>
           </a:xfrm>
           <a:prstGeom xmlns:a="http://schemas.openxmlformats.org/drawingml/2006/main" prst="rect">
@@ -26190,7 +26582,7 @@
         <p:spPr>
           <a:xfrm xmlns:a="http://schemas.openxmlformats.org/drawingml/2006/main">
             <a:off x="1252403" y="2080661"/>
-            <a:ext cx="4190700" cy="548640"/>
+            <a:ext cx="4190700" cy="733500"/>
           </a:xfrm>
           <a:prstGeom xmlns:a="http://schemas.openxmlformats.org/drawingml/2006/main" prst="rect">
             <a:avLst/>
@@ -26236,7 +26628,7 @@
         <p:spPr>
           <a:xfrm xmlns:a="http://schemas.openxmlformats.org/drawingml/2006/main">
             <a:off x="1252404" y="3138786"/>
-            <a:ext cx="4190700" cy="548640"/>
+            <a:ext cx="4190700" cy="733500"/>
           </a:xfrm>
           <a:prstGeom xmlns:a="http://schemas.openxmlformats.org/drawingml/2006/main" prst="rect">
             <a:avLst/>
@@ -26286,7 +26678,7 @@
         </p:nvSpPr>
         <p:spPr>
           <a:xfrm xmlns:a="http://schemas.openxmlformats.org/drawingml/2006/main">
-            <a:off x="1252404" y="3736386"/>
+            <a:off x="1252404" y="3914775"/>
             <a:ext cx="4190700" cy="384600"/>
           </a:xfrm>
           <a:prstGeom xmlns:a="http://schemas.openxmlformats.org/drawingml/2006/main" prst="rect">
@@ -26549,6 +26941,62 @@
           </a:p>
         </p:txBody>
       </p:sp>
+      <p:sp>
+        <p:nvSpPr>
+          <p:cNvPr id="313" name="slide-heading-20">
+            <a:extLst xmlns:a="http://schemas.openxmlformats.org/drawingml/2006/main">
+              <a:ext uri="{FF2B5EF4-FFF2-40B4-BE49-F238E27FC236}">
+                <a16:creationId xmlns:a16="http://schemas.microsoft.com/office/drawing/2014/main" id="{C5439BF0-29BD-4E5A-9CA0-F03254D0EA24}"/>
+              </a:ext>
+            </a:extLst>
+          </p:cNvPr>
+          <p:cNvSpPr>
+            <a:spLocks xmlns:a="http://schemas.openxmlformats.org/drawingml/2006/main" noGrp="1"/>
+          </p:cNvSpPr>
+          <p:nvPr/>
+        </p:nvSpPr>
+        <p:spPr>
+          <a:xfrm xmlns:a="http://schemas.openxmlformats.org/drawingml/2006/main">
+            <a:off x="552450" y="219075"/>
+            <a:ext cx="6858000" cy="266700"/>
+          </a:xfrm>
+          <a:prstGeom xmlns:a="http://schemas.openxmlformats.org/drawingml/2006/main" prst="rect">
+            <a:avLst/>
+          </a:prstGeom>
+          <a:noFill xmlns:a="http://schemas.openxmlformats.org/drawingml/2006/main"/>
+          <a:ln xmlns:a="http://schemas.openxmlformats.org/drawingml/2006/main" w="0">
+            <a:noFill/>
+            <a:prstDash val="solid"/>
+          </a:ln>
+        </p:spPr>
+        <p:txBody>
+          <a:bodyPr xmlns:a="http://schemas.openxmlformats.org/drawingml/2006/main"/>
+          <a:lstStyle xmlns:a="http://schemas.openxmlformats.org/drawingml/2006/main"/>
+          <a:p xmlns:a="http://schemas.openxmlformats.org/drawingml/2006/main">
+            <a:pPr algn="l">
+              <a:defRPr sz="1350" b="1">
+                <a:solidFill>
+                  <a:srgbClr val="FFFFFF"/>
+                </a:solidFill>
+                <a:latin typeface="Source Code Pro"/>
+                <a:ea typeface="Source Code Pro"/>
+                <a:cs typeface="Source Code Pro"/>
+              </a:defRPr>
+            </a:pPr>
+            <a:r>
+              <a:rPr sz="1350" b="1">
+                <a:solidFill>
+                  <a:srgbClr val="FFFFFF"/>
+                </a:solidFill>
+                <a:latin typeface="Source Code Pro"/>
+                <a:ea typeface="Source Code Pro"/>
+                <a:cs typeface="Source Code Pro"/>
+              </a:rPr>
+              <a:t>Programming words we will use</a:t>
+            </a:r>
+          </a:p>
+        </p:txBody>
+      </p:sp>
     </p:spTree>
     <p:extLst>
       <p:ext uri="{BB962C8B-B14F-4D97-AF65-F5344CB8AC3E}">
@@ -26589,7 +27037,7 @@
         </p:nvSpPr>
         <p:spPr>
           <a:xfrm xmlns:a="http://schemas.openxmlformats.org/drawingml/2006/main">
-            <a:off x="1252403" y="2678261"/>
+            <a:off x="1252403" y="2857500"/>
             <a:ext cx="4190700" cy="384600"/>
           </a:xfrm>
           <a:prstGeom xmlns:a="http://schemas.openxmlformats.org/drawingml/2006/main" prst="rect">
@@ -26636,7 +27084,7 @@
         <p:spPr>
           <a:xfrm xmlns:a="http://schemas.openxmlformats.org/drawingml/2006/main">
             <a:off x="1252403" y="1022536"/>
-            <a:ext cx="4190700" cy="548640"/>
+            <a:ext cx="4190700" cy="733500"/>
           </a:xfrm>
           <a:prstGeom xmlns:a="http://schemas.openxmlformats.org/drawingml/2006/main" prst="rect">
             <a:avLst/>
@@ -26686,7 +27134,7 @@
         </p:nvSpPr>
         <p:spPr>
           <a:xfrm xmlns:a="http://schemas.openxmlformats.org/drawingml/2006/main">
-            <a:off x="1252403" y="1620161"/>
+            <a:off x="1252403" y="1790700"/>
             <a:ext cx="4190700" cy="384600"/>
           </a:xfrm>
           <a:prstGeom xmlns:a="http://schemas.openxmlformats.org/drawingml/2006/main" prst="rect">
@@ -26733,7 +27181,7 @@
         <p:spPr>
           <a:xfrm xmlns:a="http://schemas.openxmlformats.org/drawingml/2006/main">
             <a:off x="1252403" y="2080661"/>
-            <a:ext cx="4190700" cy="548640"/>
+            <a:ext cx="4190700" cy="733500"/>
           </a:xfrm>
           <a:prstGeom xmlns:a="http://schemas.openxmlformats.org/drawingml/2006/main" prst="rect">
             <a:avLst/>
@@ -26779,7 +27227,7 @@
         <p:spPr>
           <a:xfrm xmlns:a="http://schemas.openxmlformats.org/drawingml/2006/main">
             <a:off x="1252404" y="3138786"/>
-            <a:ext cx="4190700" cy="548640"/>
+            <a:ext cx="4190700" cy="733500"/>
           </a:xfrm>
           <a:prstGeom xmlns:a="http://schemas.openxmlformats.org/drawingml/2006/main" prst="rect">
             <a:avLst/>
@@ -26829,7 +27277,7 @@
         </p:nvSpPr>
         <p:spPr>
           <a:xfrm xmlns:a="http://schemas.openxmlformats.org/drawingml/2006/main">
-            <a:off x="1252404" y="3736386"/>
+            <a:off x="1252404" y="3914775"/>
             <a:ext cx="4190700" cy="384600"/>
           </a:xfrm>
           <a:prstGeom xmlns:a="http://schemas.openxmlformats.org/drawingml/2006/main" prst="rect">
@@ -27092,6 +27540,62 @@
           </a:p>
         </p:txBody>
       </p:sp>
+      <p:sp>
+        <p:nvSpPr>
+          <p:cNvPr id="313" name="slide-heading-21">
+            <a:extLst xmlns:a="http://schemas.openxmlformats.org/drawingml/2006/main">
+              <a:ext uri="{FF2B5EF4-FFF2-40B4-BE49-F238E27FC236}">
+                <a16:creationId xmlns:a16="http://schemas.microsoft.com/office/drawing/2014/main" id="{C7C205A3-D42F-435E-AA4F-28E016136596}"/>
+              </a:ext>
+            </a:extLst>
+          </p:cNvPr>
+          <p:cNvSpPr>
+            <a:spLocks xmlns:a="http://schemas.openxmlformats.org/drawingml/2006/main" noGrp="1"/>
+          </p:cNvSpPr>
+          <p:nvPr/>
+        </p:nvSpPr>
+        <p:spPr>
+          <a:xfrm xmlns:a="http://schemas.openxmlformats.org/drawingml/2006/main">
+            <a:off x="552450" y="219075"/>
+            <a:ext cx="6858000" cy="266700"/>
+          </a:xfrm>
+          <a:prstGeom xmlns:a="http://schemas.openxmlformats.org/drawingml/2006/main" prst="rect">
+            <a:avLst/>
+          </a:prstGeom>
+          <a:noFill xmlns:a="http://schemas.openxmlformats.org/drawingml/2006/main"/>
+          <a:ln xmlns:a="http://schemas.openxmlformats.org/drawingml/2006/main" w="0">
+            <a:noFill/>
+            <a:prstDash val="solid"/>
+          </a:ln>
+        </p:spPr>
+        <p:txBody>
+          <a:bodyPr xmlns:a="http://schemas.openxmlformats.org/drawingml/2006/main"/>
+          <a:lstStyle xmlns:a="http://schemas.openxmlformats.org/drawingml/2006/main"/>
+          <a:p xmlns:a="http://schemas.openxmlformats.org/drawingml/2006/main">
+            <a:pPr algn="l">
+              <a:defRPr sz="1350" b="1">
+                <a:solidFill>
+                  <a:srgbClr val="FFFFFF"/>
+                </a:solidFill>
+                <a:latin typeface="Source Code Pro"/>
+                <a:ea typeface="Source Code Pro"/>
+                <a:cs typeface="Source Code Pro"/>
+              </a:defRPr>
+            </a:pPr>
+            <a:r>
+              <a:rPr sz="1350" b="1">
+                <a:solidFill>
+                  <a:srgbClr val="FFFFFF"/>
+                </a:solidFill>
+                <a:latin typeface="Source Code Pro"/>
+                <a:ea typeface="Source Code Pro"/>
+                <a:cs typeface="Source Code Pro"/>
+              </a:rPr>
+              <a:t>AI can help, but you decide</a:t>
+            </a:r>
+          </a:p>
+        </p:txBody>
+      </p:sp>
     </p:spTree>
     <p:extLst>
       <p:ext uri="{BB962C8B-B14F-4D97-AF65-F5344CB8AC3E}">
@@ -27132,7 +27636,7 @@
         </p:nvSpPr>
         <p:spPr>
           <a:xfrm xmlns:a="http://schemas.openxmlformats.org/drawingml/2006/main">
-            <a:off x="1252403" y="2678261"/>
+            <a:off x="1252403" y="2857500"/>
             <a:ext cx="4190700" cy="384600"/>
           </a:xfrm>
           <a:prstGeom xmlns:a="http://schemas.openxmlformats.org/drawingml/2006/main" prst="rect">
@@ -27179,7 +27683,7 @@
         <p:spPr>
           <a:xfrm xmlns:a="http://schemas.openxmlformats.org/drawingml/2006/main">
             <a:off x="1252403" y="1022536"/>
-            <a:ext cx="4190700" cy="548640"/>
+            <a:ext cx="4190700" cy="733500"/>
           </a:xfrm>
           <a:prstGeom xmlns:a="http://schemas.openxmlformats.org/drawingml/2006/main" prst="rect">
             <a:avLst/>
@@ -27229,7 +27733,7 @@
         </p:nvSpPr>
         <p:spPr>
           <a:xfrm xmlns:a="http://schemas.openxmlformats.org/drawingml/2006/main">
-            <a:off x="1252403" y="1620161"/>
+            <a:off x="1252403" y="1790700"/>
             <a:ext cx="4190700" cy="384600"/>
           </a:xfrm>
           <a:prstGeom xmlns:a="http://schemas.openxmlformats.org/drawingml/2006/main" prst="rect">
@@ -27276,7 +27780,7 @@
         <p:spPr>
           <a:xfrm xmlns:a="http://schemas.openxmlformats.org/drawingml/2006/main">
             <a:off x="1252403" y="2080661"/>
-            <a:ext cx="4190700" cy="548640"/>
+            <a:ext cx="4190700" cy="733500"/>
           </a:xfrm>
           <a:prstGeom xmlns:a="http://schemas.openxmlformats.org/drawingml/2006/main" prst="rect">
             <a:avLst/>
@@ -27322,7 +27826,7 @@
         <p:spPr>
           <a:xfrm xmlns:a="http://schemas.openxmlformats.org/drawingml/2006/main">
             <a:off x="1252404" y="3138786"/>
-            <a:ext cx="4190700" cy="548640"/>
+            <a:ext cx="4190700" cy="733500"/>
           </a:xfrm>
           <a:prstGeom xmlns:a="http://schemas.openxmlformats.org/drawingml/2006/main" prst="rect">
             <a:avLst/>
@@ -27372,7 +27876,7 @@
         </p:nvSpPr>
         <p:spPr>
           <a:xfrm xmlns:a="http://schemas.openxmlformats.org/drawingml/2006/main">
-            <a:off x="1252404" y="3736386"/>
+            <a:off x="1252404" y="3914775"/>
             <a:ext cx="4190700" cy="384600"/>
           </a:xfrm>
           <a:prstGeom xmlns:a="http://schemas.openxmlformats.org/drawingml/2006/main" prst="rect">
@@ -27631,6 +28135,62 @@
                 </a:solidFill>
               </a:rPr>
               <a:t>[</a:t>
+            </a:r>
+          </a:p>
+        </p:txBody>
+      </p:sp>
+      <p:sp>
+        <p:nvSpPr>
+          <p:cNvPr id="313" name="slide-heading-22">
+            <a:extLst xmlns:a="http://schemas.openxmlformats.org/drawingml/2006/main">
+              <a:ext uri="{FF2B5EF4-FFF2-40B4-BE49-F238E27FC236}">
+                <a16:creationId xmlns:a16="http://schemas.microsoft.com/office/drawing/2014/main" id="{7ACF9CCC-EB63-42EC-8B0B-7C8D856395B8}"/>
+              </a:ext>
+            </a:extLst>
+          </p:cNvPr>
+          <p:cNvSpPr>
+            <a:spLocks xmlns:a="http://schemas.openxmlformats.org/drawingml/2006/main" noGrp="1"/>
+          </p:cNvSpPr>
+          <p:nvPr/>
+        </p:nvSpPr>
+        <p:spPr>
+          <a:xfrm xmlns:a="http://schemas.openxmlformats.org/drawingml/2006/main">
+            <a:off x="552450" y="219075"/>
+            <a:ext cx="6858000" cy="266700"/>
+          </a:xfrm>
+          <a:prstGeom xmlns:a="http://schemas.openxmlformats.org/drawingml/2006/main" prst="rect">
+            <a:avLst/>
+          </a:prstGeom>
+          <a:noFill xmlns:a="http://schemas.openxmlformats.org/drawingml/2006/main"/>
+          <a:ln xmlns:a="http://schemas.openxmlformats.org/drawingml/2006/main" w="0">
+            <a:noFill/>
+            <a:prstDash val="solid"/>
+          </a:ln>
+        </p:spPr>
+        <p:txBody>
+          <a:bodyPr xmlns:a="http://schemas.openxmlformats.org/drawingml/2006/main"/>
+          <a:lstStyle xmlns:a="http://schemas.openxmlformats.org/drawingml/2006/main"/>
+          <a:p xmlns:a="http://schemas.openxmlformats.org/drawingml/2006/main">
+            <a:pPr algn="l">
+              <a:defRPr sz="1350" b="1">
+                <a:solidFill>
+                  <a:srgbClr val="FFFFFF"/>
+                </a:solidFill>
+                <a:latin typeface="Source Code Pro"/>
+                <a:ea typeface="Source Code Pro"/>
+                <a:cs typeface="Source Code Pro"/>
+              </a:defRPr>
+            </a:pPr>
+            <a:r>
+              <a:rPr sz="1350" b="1">
+                <a:solidFill>
+                  <a:srgbClr val="FFFFFF"/>
+                </a:solidFill>
+                <a:latin typeface="Source Code Pro"/>
+                <a:ea typeface="Source Code Pro"/>
+                <a:cs typeface="Source Code Pro"/>
+              </a:rPr>
+              <a:t>Share what your crew made</a:t>
             </a:r>
           </a:p>
         </p:txBody>
@@ -28411,7 +28971,7 @@
         </p:nvSpPr>
         <p:spPr>
           <a:xfrm xmlns:a="http://schemas.openxmlformats.org/drawingml/2006/main">
-            <a:off x="1252403" y="2678261"/>
+            <a:off x="1252403" y="2857500"/>
             <a:ext cx="4190700" cy="384600"/>
           </a:xfrm>
           <a:prstGeom xmlns:a="http://schemas.openxmlformats.org/drawingml/2006/main" prst="rect">
@@ -28458,7 +29018,7 @@
         <p:spPr>
           <a:xfrm xmlns:a="http://schemas.openxmlformats.org/drawingml/2006/main">
             <a:off x="1252403" y="1022536"/>
-            <a:ext cx="4190700" cy="548640"/>
+            <a:ext cx="4190700" cy="733500"/>
           </a:xfrm>
           <a:prstGeom xmlns:a="http://schemas.openxmlformats.org/drawingml/2006/main" prst="rect">
             <a:avLst/>
@@ -28508,7 +29068,7 @@
         </p:nvSpPr>
         <p:spPr>
           <a:xfrm xmlns:a="http://schemas.openxmlformats.org/drawingml/2006/main">
-            <a:off x="1252403" y="1620161"/>
+            <a:off x="1252403" y="1790700"/>
             <a:ext cx="4190700" cy="384600"/>
           </a:xfrm>
           <a:prstGeom xmlns:a="http://schemas.openxmlformats.org/drawingml/2006/main" prst="rect">
@@ -28555,7 +29115,7 @@
         <p:spPr>
           <a:xfrm xmlns:a="http://schemas.openxmlformats.org/drawingml/2006/main">
             <a:off x="1252403" y="2080661"/>
-            <a:ext cx="4190700" cy="548640"/>
+            <a:ext cx="4190700" cy="733500"/>
           </a:xfrm>
           <a:prstGeom xmlns:a="http://schemas.openxmlformats.org/drawingml/2006/main" prst="rect">
             <a:avLst/>
@@ -28601,7 +29161,7 @@
         <p:spPr>
           <a:xfrm xmlns:a="http://schemas.openxmlformats.org/drawingml/2006/main">
             <a:off x="1252404" y="3138786"/>
-            <a:ext cx="4190700" cy="548640"/>
+            <a:ext cx="4190700" cy="733500"/>
           </a:xfrm>
           <a:prstGeom xmlns:a="http://schemas.openxmlformats.org/drawingml/2006/main" prst="rect">
             <a:avLst/>
@@ -28651,7 +29211,7 @@
         </p:nvSpPr>
         <p:spPr>
           <a:xfrm xmlns:a="http://schemas.openxmlformats.org/drawingml/2006/main">
-            <a:off x="1252404" y="3736386"/>
+            <a:off x="1252404" y="3914775"/>
             <a:ext cx="4190700" cy="384600"/>
           </a:xfrm>
           <a:prstGeom xmlns:a="http://schemas.openxmlformats.org/drawingml/2006/main" prst="rect">
@@ -28914,6 +29474,62 @@
           </a:p>
         </p:txBody>
       </p:sp>
+      <p:sp>
+        <p:nvSpPr>
+          <p:cNvPr id="313" name="slide-heading-24">
+            <a:extLst xmlns:a="http://schemas.openxmlformats.org/drawingml/2006/main">
+              <a:ext uri="{FF2B5EF4-FFF2-40B4-BE49-F238E27FC236}">
+                <a16:creationId xmlns:a16="http://schemas.microsoft.com/office/drawing/2014/main" id="{10A7C660-D469-4279-8BF0-C97A112E2F74}"/>
+              </a:ext>
+            </a:extLst>
+          </p:cNvPr>
+          <p:cNvSpPr>
+            <a:spLocks xmlns:a="http://schemas.openxmlformats.org/drawingml/2006/main" noGrp="1"/>
+          </p:cNvSpPr>
+          <p:nvPr/>
+        </p:nvSpPr>
+        <p:spPr>
+          <a:xfrm xmlns:a="http://schemas.openxmlformats.org/drawingml/2006/main">
+            <a:off x="552450" y="219075"/>
+            <a:ext cx="6858000" cy="266700"/>
+          </a:xfrm>
+          <a:prstGeom xmlns:a="http://schemas.openxmlformats.org/drawingml/2006/main" prst="rect">
+            <a:avLst/>
+          </a:prstGeom>
+          <a:noFill xmlns:a="http://schemas.openxmlformats.org/drawingml/2006/main"/>
+          <a:ln xmlns:a="http://schemas.openxmlformats.org/drawingml/2006/main" w="0">
+            <a:noFill/>
+            <a:prstDash val="solid"/>
+          </a:ln>
+        </p:spPr>
+        <p:txBody>
+          <a:bodyPr xmlns:a="http://schemas.openxmlformats.org/drawingml/2006/main"/>
+          <a:lstStyle xmlns:a="http://schemas.openxmlformats.org/drawingml/2006/main"/>
+          <a:p xmlns:a="http://schemas.openxmlformats.org/drawingml/2006/main">
+            <a:pPr algn="l">
+              <a:defRPr sz="1350" b="1">
+                <a:solidFill>
+                  <a:srgbClr val="FFFFFF"/>
+                </a:solidFill>
+                <a:latin typeface="Source Code Pro"/>
+                <a:ea typeface="Source Code Pro"/>
+                <a:cs typeface="Source Code Pro"/>
+              </a:defRPr>
+            </a:pPr>
+            <a:r>
+              <a:rPr sz="1350" b="1">
+                <a:solidFill>
+                  <a:srgbClr val="FFFFFF"/>
+                </a:solidFill>
+                <a:latin typeface="Source Code Pro"/>
+                <a:ea typeface="Source Code Pro"/>
+                <a:cs typeface="Source Code Pro"/>
+              </a:rPr>
+              <a:t>Homework: Music Lab remix</a:t>
+            </a:r>
+          </a:p>
+        </p:txBody>
+      </p:sp>
     </p:spTree>
     <p:extLst>
       <p:ext uri="{BB962C8B-B14F-4D97-AF65-F5344CB8AC3E}">
@@ -28954,7 +29570,7 @@
         </p:nvSpPr>
         <p:spPr>
           <a:xfrm xmlns:a="http://schemas.openxmlformats.org/drawingml/2006/main">
-            <a:off x="1252403" y="2678261"/>
+            <a:off x="1252403" y="2857500"/>
             <a:ext cx="4190700" cy="384600"/>
           </a:xfrm>
           <a:prstGeom xmlns:a="http://schemas.openxmlformats.org/drawingml/2006/main" prst="rect">
@@ -29001,7 +29617,7 @@
         <p:spPr>
           <a:xfrm xmlns:a="http://schemas.openxmlformats.org/drawingml/2006/main">
             <a:off x="1252403" y="1022536"/>
-            <a:ext cx="4190700" cy="548640"/>
+            <a:ext cx="4190700" cy="733500"/>
           </a:xfrm>
           <a:prstGeom xmlns:a="http://schemas.openxmlformats.org/drawingml/2006/main" prst="rect">
             <a:avLst/>
@@ -29051,7 +29667,7 @@
         </p:nvSpPr>
         <p:spPr>
           <a:xfrm xmlns:a="http://schemas.openxmlformats.org/drawingml/2006/main">
-            <a:off x="1252403" y="1620161"/>
+            <a:off x="1252403" y="1790700"/>
             <a:ext cx="4190700" cy="384600"/>
           </a:xfrm>
           <a:prstGeom xmlns:a="http://schemas.openxmlformats.org/drawingml/2006/main" prst="rect">
@@ -29098,7 +29714,7 @@
         <p:spPr>
           <a:xfrm xmlns:a="http://schemas.openxmlformats.org/drawingml/2006/main">
             <a:off x="1252403" y="2080661"/>
-            <a:ext cx="4190700" cy="548640"/>
+            <a:ext cx="4190700" cy="733500"/>
           </a:xfrm>
           <a:prstGeom xmlns:a="http://schemas.openxmlformats.org/drawingml/2006/main" prst="rect">
             <a:avLst/>
@@ -29144,7 +29760,7 @@
         <p:spPr>
           <a:xfrm xmlns:a="http://schemas.openxmlformats.org/drawingml/2006/main">
             <a:off x="1252404" y="3138786"/>
-            <a:ext cx="4190700" cy="548640"/>
+            <a:ext cx="4190700" cy="733500"/>
           </a:xfrm>
           <a:prstGeom xmlns:a="http://schemas.openxmlformats.org/drawingml/2006/main" prst="rect">
             <a:avLst/>
@@ -29194,7 +29810,7 @@
         </p:nvSpPr>
         <p:spPr>
           <a:xfrm xmlns:a="http://schemas.openxmlformats.org/drawingml/2006/main">
-            <a:off x="1252404" y="3736386"/>
+            <a:off x="1252404" y="3914775"/>
             <a:ext cx="4190700" cy="384600"/>
           </a:xfrm>
           <a:prstGeom xmlns:a="http://schemas.openxmlformats.org/drawingml/2006/main" prst="rect">
@@ -29453,6 +30069,62 @@
                 </a:solidFill>
               </a:rPr>
               <a:t>[</a:t>
+            </a:r>
+          </a:p>
+        </p:txBody>
+      </p:sp>
+      <p:sp>
+        <p:nvSpPr>
+          <p:cNvPr id="313" name="slide-heading-25">
+            <a:extLst xmlns:a="http://schemas.openxmlformats.org/drawingml/2006/main">
+              <a:ext uri="{FF2B5EF4-FFF2-40B4-BE49-F238E27FC236}">
+                <a16:creationId xmlns:a16="http://schemas.microsoft.com/office/drawing/2014/main" id="{72E08CB2-5A61-45A9-9E0B-B95914960732}"/>
+              </a:ext>
+            </a:extLst>
+          </p:cNvPr>
+          <p:cNvSpPr>
+            <a:spLocks xmlns:a="http://schemas.openxmlformats.org/drawingml/2006/main" noGrp="1"/>
+          </p:cNvSpPr>
+          <p:nvPr/>
+        </p:nvSpPr>
+        <p:spPr>
+          <a:xfrm xmlns:a="http://schemas.openxmlformats.org/drawingml/2006/main">
+            <a:off x="552450" y="219075"/>
+            <a:ext cx="6858000" cy="266700"/>
+          </a:xfrm>
+          <a:prstGeom xmlns:a="http://schemas.openxmlformats.org/drawingml/2006/main" prst="rect">
+            <a:avLst/>
+          </a:prstGeom>
+          <a:noFill xmlns:a="http://schemas.openxmlformats.org/drawingml/2006/main"/>
+          <a:ln xmlns:a="http://schemas.openxmlformats.org/drawingml/2006/main" w="0">
+            <a:noFill/>
+            <a:prstDash val="solid"/>
+          </a:ln>
+        </p:spPr>
+        <p:txBody>
+          <a:bodyPr xmlns:a="http://schemas.openxmlformats.org/drawingml/2006/main"/>
+          <a:lstStyle xmlns:a="http://schemas.openxmlformats.org/drawingml/2006/main"/>
+          <a:p xmlns:a="http://schemas.openxmlformats.org/drawingml/2006/main">
+            <a:pPr algn="l">
+              <a:defRPr sz="1350" b="1">
+                <a:solidFill>
+                  <a:srgbClr val="FFFFFF"/>
+                </a:solidFill>
+                <a:latin typeface="Source Code Pro"/>
+                <a:ea typeface="Source Code Pro"/>
+                <a:cs typeface="Source Code Pro"/>
+              </a:defRPr>
+            </a:pPr>
+            <a:r>
+              <a:rPr sz="1350" b="1">
+                <a:solidFill>
+                  <a:srgbClr val="FFFFFF"/>
+                </a:solidFill>
+                <a:latin typeface="Source Code Pro"/>
+                <a:ea typeface="Source Code Pro"/>
+                <a:cs typeface="Source Code Pro"/>
+              </a:rPr>
+              <a:t>Next week we start TypeScript</a:t>
             </a:r>
           </a:p>
         </p:txBody>
@@ -30520,7 +31192,7 @@
           <p:nvPr/>
         </p:nvPicPr>
         <p:blipFill>
-          <a:blip xmlns:r="http://schemas.openxmlformats.org/officeDocument/2006/relationships" xmlns:a="http://schemas.openxmlformats.org/drawingml/2006/main" r:embed="R631074e59a0b454c"/>
+          <a:blip xmlns:r="http://schemas.openxmlformats.org/officeDocument/2006/relationships" xmlns:a="http://schemas.openxmlformats.org/drawingml/2006/main" r:embed="Re20179d6e9c74a8c"/>
           <a:stretch xmlns:a="http://schemas.openxmlformats.org/drawingml/2006/main">
             <a:fillRect l="0" t="0" r="0" b="0"/>
           </a:stretch>
@@ -30882,7 +31554,7 @@
           <p:nvPr/>
         </p:nvPicPr>
         <p:blipFill>
-          <a:blip xmlns:r="http://schemas.openxmlformats.org/officeDocument/2006/relationships" xmlns:a="http://schemas.openxmlformats.org/drawingml/2006/main" r:embed="Rdc2db03b26d74c6a"/>
+          <a:blip xmlns:r="http://schemas.openxmlformats.org/officeDocument/2006/relationships" xmlns:a="http://schemas.openxmlformats.org/drawingml/2006/main" r:embed="Rde2092cdea9b4126"/>
           <a:stretch xmlns:a="http://schemas.openxmlformats.org/drawingml/2006/main">
             <a:fillRect l="0" t="0" r="0" b="0"/>
           </a:stretch>
@@ -31086,7 +31758,7 @@
           <p:nvPr/>
         </p:nvPicPr>
         <p:blipFill>
-          <a:blip xmlns:r="http://schemas.openxmlformats.org/officeDocument/2006/relationships" xmlns:a="http://schemas.openxmlformats.org/drawingml/2006/main" r:embed="Rf7557e696e134fa3"/>
+          <a:blip xmlns:r="http://schemas.openxmlformats.org/officeDocument/2006/relationships" xmlns:a="http://schemas.openxmlformats.org/drawingml/2006/main" r:embed="R0f2426831e324b49"/>
           <a:stretch xmlns:a="http://schemas.openxmlformats.org/drawingml/2006/main">
             <a:fillRect l="0" t="0" r="0" b="0"/>
           </a:stretch>
@@ -31141,7 +31813,7 @@
         </p:nvSpPr>
         <p:spPr>
           <a:xfrm xmlns:a="http://schemas.openxmlformats.org/drawingml/2006/main">
-            <a:off x="1252403" y="2678261"/>
+            <a:off x="1252403" y="2857500"/>
             <a:ext cx="4190700" cy="384600"/>
           </a:xfrm>
           <a:prstGeom xmlns:a="http://schemas.openxmlformats.org/drawingml/2006/main" prst="rect">
@@ -31188,7 +31860,7 @@
         <p:spPr>
           <a:xfrm xmlns:a="http://schemas.openxmlformats.org/drawingml/2006/main">
             <a:off x="1252403" y="1022536"/>
-            <a:ext cx="4190700" cy="548640"/>
+            <a:ext cx="4190700" cy="733500"/>
           </a:xfrm>
           <a:prstGeom xmlns:a="http://schemas.openxmlformats.org/drawingml/2006/main" prst="rect">
             <a:avLst/>
@@ -31238,7 +31910,7 @@
         </p:nvSpPr>
         <p:spPr>
           <a:xfrm xmlns:a="http://schemas.openxmlformats.org/drawingml/2006/main">
-            <a:off x="1252403" y="1620161"/>
+            <a:off x="1252403" y="1790700"/>
             <a:ext cx="4190700" cy="384600"/>
           </a:xfrm>
           <a:prstGeom xmlns:a="http://schemas.openxmlformats.org/drawingml/2006/main" prst="rect">
@@ -31285,7 +31957,7 @@
         <p:spPr>
           <a:xfrm xmlns:a="http://schemas.openxmlformats.org/drawingml/2006/main">
             <a:off x="1252403" y="2080661"/>
-            <a:ext cx="4190700" cy="548640"/>
+            <a:ext cx="4190700" cy="733500"/>
           </a:xfrm>
           <a:prstGeom xmlns:a="http://schemas.openxmlformats.org/drawingml/2006/main" prst="rect">
             <a:avLst/>
@@ -31331,7 +32003,7 @@
         <p:spPr>
           <a:xfrm xmlns:a="http://schemas.openxmlformats.org/drawingml/2006/main">
             <a:off x="1252404" y="3138786"/>
-            <a:ext cx="4190700" cy="548640"/>
+            <a:ext cx="4190700" cy="733500"/>
           </a:xfrm>
           <a:prstGeom xmlns:a="http://schemas.openxmlformats.org/drawingml/2006/main" prst="rect">
             <a:avLst/>
@@ -31381,7 +32053,7 @@
         </p:nvSpPr>
         <p:spPr>
           <a:xfrm xmlns:a="http://schemas.openxmlformats.org/drawingml/2006/main">
-            <a:off x="1252404" y="3736386"/>
+            <a:off x="1252404" y="3914775"/>
             <a:ext cx="4190700" cy="384600"/>
           </a:xfrm>
           <a:prstGeom xmlns:a="http://schemas.openxmlformats.org/drawingml/2006/main" prst="rect">
@@ -31644,6 +32316,62 @@
           </a:p>
         </p:txBody>
       </p:sp>
+      <p:sp>
+        <p:nvSpPr>
+          <p:cNvPr id="313" name="slide-heading-6">
+            <a:extLst xmlns:a="http://schemas.openxmlformats.org/drawingml/2006/main">
+              <a:ext uri="{FF2B5EF4-FFF2-40B4-BE49-F238E27FC236}">
+                <a16:creationId xmlns:a16="http://schemas.microsoft.com/office/drawing/2014/main" id="{E73CF497-0584-42DA-AFC9-6F53A87DBDF6}"/>
+              </a:ext>
+            </a:extLst>
+          </p:cNvPr>
+          <p:cNvSpPr>
+            <a:spLocks xmlns:a="http://schemas.openxmlformats.org/drawingml/2006/main" noGrp="1"/>
+          </p:cNvSpPr>
+          <p:nvPr/>
+        </p:nvSpPr>
+        <p:spPr>
+          <a:xfrm xmlns:a="http://schemas.openxmlformats.org/drawingml/2006/main">
+            <a:off x="552450" y="219075"/>
+            <a:ext cx="6858000" cy="266700"/>
+          </a:xfrm>
+          <a:prstGeom xmlns:a="http://schemas.openxmlformats.org/drawingml/2006/main" prst="rect">
+            <a:avLst/>
+          </a:prstGeom>
+          <a:noFill xmlns:a="http://schemas.openxmlformats.org/drawingml/2006/main"/>
+          <a:ln xmlns:a="http://schemas.openxmlformats.org/drawingml/2006/main" w="0">
+            <a:noFill/>
+            <a:prstDash val="solid"/>
+          </a:ln>
+        </p:spPr>
+        <p:txBody>
+          <a:bodyPr xmlns:a="http://schemas.openxmlformats.org/drawingml/2006/main"/>
+          <a:lstStyle xmlns:a="http://schemas.openxmlformats.org/drawingml/2006/main"/>
+          <a:p xmlns:a="http://schemas.openxmlformats.org/drawingml/2006/main">
+            <a:pPr algn="l">
+              <a:defRPr sz="1350" b="1">
+                <a:solidFill>
+                  <a:srgbClr val="FFFFFF"/>
+                </a:solidFill>
+                <a:latin typeface="Source Code Pro"/>
+                <a:ea typeface="Source Code Pro"/>
+                <a:cs typeface="Source Code Pro"/>
+              </a:defRPr>
+            </a:pPr>
+            <a:r>
+              <a:rPr sz="1350" b="1">
+                <a:solidFill>
+                  <a:srgbClr val="FFFFFF"/>
+                </a:solidFill>
+                <a:latin typeface="Source Code Pro"/>
+                <a:ea typeface="Source Code Pro"/>
+                <a:cs typeface="Source Code Pro"/>
+              </a:rPr>
+              <a:t>Today's mission</a:t>
+            </a:r>
+          </a:p>
+        </p:txBody>
+      </p:sp>
     </p:spTree>
     <p:extLst>
       <p:ext uri="{BB962C8B-B14F-4D97-AF65-F5344CB8AC3E}">
@@ -31684,7 +32412,7 @@
         </p:nvSpPr>
         <p:spPr>
           <a:xfrm xmlns:a="http://schemas.openxmlformats.org/drawingml/2006/main">
-            <a:off x="1252403" y="2678261"/>
+            <a:off x="1252403" y="2857500"/>
             <a:ext cx="4190700" cy="384600"/>
           </a:xfrm>
           <a:prstGeom xmlns:a="http://schemas.openxmlformats.org/drawingml/2006/main" prst="rect">
@@ -31731,7 +32459,7 @@
         <p:spPr>
           <a:xfrm xmlns:a="http://schemas.openxmlformats.org/drawingml/2006/main">
             <a:off x="1252403" y="1022536"/>
-            <a:ext cx="4190700" cy="548640"/>
+            <a:ext cx="4190700" cy="733500"/>
           </a:xfrm>
           <a:prstGeom xmlns:a="http://schemas.openxmlformats.org/drawingml/2006/main" prst="rect">
             <a:avLst/>
@@ -31781,7 +32509,7 @@
         </p:nvSpPr>
         <p:spPr>
           <a:xfrm xmlns:a="http://schemas.openxmlformats.org/drawingml/2006/main">
-            <a:off x="1252403" y="1620161"/>
+            <a:off x="1252403" y="1790700"/>
             <a:ext cx="4190700" cy="384600"/>
           </a:xfrm>
           <a:prstGeom xmlns:a="http://schemas.openxmlformats.org/drawingml/2006/main" prst="rect">
@@ -31828,7 +32556,7 @@
         <p:spPr>
           <a:xfrm xmlns:a="http://schemas.openxmlformats.org/drawingml/2006/main">
             <a:off x="1252403" y="2080661"/>
-            <a:ext cx="4190700" cy="548640"/>
+            <a:ext cx="4190700" cy="733500"/>
           </a:xfrm>
           <a:prstGeom xmlns:a="http://schemas.openxmlformats.org/drawingml/2006/main" prst="rect">
             <a:avLst/>
@@ -31874,7 +32602,7 @@
         <p:spPr>
           <a:xfrm xmlns:a="http://schemas.openxmlformats.org/drawingml/2006/main">
             <a:off x="1252404" y="3138786"/>
-            <a:ext cx="4190700" cy="548640"/>
+            <a:ext cx="4190700" cy="733500"/>
           </a:xfrm>
           <a:prstGeom xmlns:a="http://schemas.openxmlformats.org/drawingml/2006/main" prst="rect">
             <a:avLst/>
@@ -31924,7 +32652,7 @@
         </p:nvSpPr>
         <p:spPr>
           <a:xfrm xmlns:a="http://schemas.openxmlformats.org/drawingml/2006/main">
-            <a:off x="1252404" y="3736386"/>
+            <a:off x="1252404" y="3914775"/>
             <a:ext cx="4190700" cy="384600"/>
           </a:xfrm>
           <a:prstGeom xmlns:a="http://schemas.openxmlformats.org/drawingml/2006/main" prst="rect">
@@ -32187,6 +32915,62 @@
           </a:p>
         </p:txBody>
       </p:sp>
+      <p:sp>
+        <p:nvSpPr>
+          <p:cNvPr id="313" name="slide-heading-7">
+            <a:extLst xmlns:a="http://schemas.openxmlformats.org/drawingml/2006/main">
+              <a:ext uri="{FF2B5EF4-FFF2-40B4-BE49-F238E27FC236}">
+                <a16:creationId xmlns:a16="http://schemas.microsoft.com/office/drawing/2014/main" id="{0C27150C-6CF9-4E45-86A8-40688D407385}"/>
+              </a:ext>
+            </a:extLst>
+          </p:cNvPr>
+          <p:cNvSpPr>
+            <a:spLocks xmlns:a="http://schemas.openxmlformats.org/drawingml/2006/main" noGrp="1"/>
+          </p:cNvSpPr>
+          <p:nvPr/>
+        </p:nvSpPr>
+        <p:spPr>
+          <a:xfrm xmlns:a="http://schemas.openxmlformats.org/drawingml/2006/main">
+            <a:off x="552450" y="219075"/>
+            <a:ext cx="6858000" cy="266700"/>
+          </a:xfrm>
+          <a:prstGeom xmlns:a="http://schemas.openxmlformats.org/drawingml/2006/main" prst="rect">
+            <a:avLst/>
+          </a:prstGeom>
+          <a:noFill xmlns:a="http://schemas.openxmlformats.org/drawingml/2006/main"/>
+          <a:ln xmlns:a="http://schemas.openxmlformats.org/drawingml/2006/main" w="0">
+            <a:noFill/>
+            <a:prstDash val="solid"/>
+          </a:ln>
+        </p:spPr>
+        <p:txBody>
+          <a:bodyPr xmlns:a="http://schemas.openxmlformats.org/drawingml/2006/main"/>
+          <a:lstStyle xmlns:a="http://schemas.openxmlformats.org/drawingml/2006/main"/>
+          <a:p xmlns:a="http://schemas.openxmlformats.org/drawingml/2006/main">
+            <a:pPr algn="l">
+              <a:defRPr sz="1350" b="1">
+                <a:solidFill>
+                  <a:srgbClr val="FFFFFF"/>
+                </a:solidFill>
+                <a:latin typeface="Source Code Pro"/>
+                <a:ea typeface="Source Code Pro"/>
+                <a:cs typeface="Source Code Pro"/>
+              </a:defRPr>
+            </a:pPr>
+            <a:r>
+              <a:rPr sz="1350" b="1">
+                <a:solidFill>
+                  <a:srgbClr val="FFFFFF"/>
+                </a:solidFill>
+                <a:latin typeface="Source Code Pro"/>
+                <a:ea typeface="Source Code Pro"/>
+                <a:cs typeface="Source Code Pro"/>
+              </a:rPr>
+              <a:t>Introduce yourself</a:t>
+            </a:r>
+          </a:p>
+        </p:txBody>
+      </p:sp>
     </p:spTree>
     <p:extLst>
       <p:ext uri="{BB962C8B-B14F-4D97-AF65-F5344CB8AC3E}">
@@ -32227,7 +33011,7 @@
         </p:nvSpPr>
         <p:spPr>
           <a:xfrm xmlns:a="http://schemas.openxmlformats.org/drawingml/2006/main">
-            <a:off x="1252403" y="2678261"/>
+            <a:off x="1252403" y="2857500"/>
             <a:ext cx="4190700" cy="384600"/>
           </a:xfrm>
           <a:prstGeom xmlns:a="http://schemas.openxmlformats.org/drawingml/2006/main" prst="rect">
@@ -32274,7 +33058,7 @@
         <p:spPr>
           <a:xfrm xmlns:a="http://schemas.openxmlformats.org/drawingml/2006/main">
             <a:off x="1252403" y="1022536"/>
-            <a:ext cx="4190700" cy="548640"/>
+            <a:ext cx="4190700" cy="733500"/>
           </a:xfrm>
           <a:prstGeom xmlns:a="http://schemas.openxmlformats.org/drawingml/2006/main" prst="rect">
             <a:avLst/>
@@ -32324,7 +33108,7 @@
         </p:nvSpPr>
         <p:spPr>
           <a:xfrm xmlns:a="http://schemas.openxmlformats.org/drawingml/2006/main">
-            <a:off x="1252403" y="1620161"/>
+            <a:off x="1252403" y="1790700"/>
             <a:ext cx="4190700" cy="384600"/>
           </a:xfrm>
           <a:prstGeom xmlns:a="http://schemas.openxmlformats.org/drawingml/2006/main" prst="rect">
@@ -32371,7 +33155,7 @@
         <p:spPr>
           <a:xfrm xmlns:a="http://schemas.openxmlformats.org/drawingml/2006/main">
             <a:off x="1252403" y="2080661"/>
-            <a:ext cx="4190700" cy="548640"/>
+            <a:ext cx="4190700" cy="733500"/>
           </a:xfrm>
           <a:prstGeom xmlns:a="http://schemas.openxmlformats.org/drawingml/2006/main" prst="rect">
             <a:avLst/>
@@ -32417,7 +33201,7 @@
         <p:spPr>
           <a:xfrm xmlns:a="http://schemas.openxmlformats.org/drawingml/2006/main">
             <a:off x="1252404" y="3138786"/>
-            <a:ext cx="4190700" cy="548640"/>
+            <a:ext cx="4190700" cy="733500"/>
           </a:xfrm>
           <a:prstGeom xmlns:a="http://schemas.openxmlformats.org/drawingml/2006/main" prst="rect">
             <a:avLst/>
@@ -32467,7 +33251,7 @@
         </p:nvSpPr>
         <p:spPr>
           <a:xfrm xmlns:a="http://schemas.openxmlformats.org/drawingml/2006/main">
-            <a:off x="1252404" y="3736386"/>
+            <a:off x="1252404" y="3914775"/>
             <a:ext cx="4190700" cy="384600"/>
           </a:xfrm>
           <a:prstGeom xmlns:a="http://schemas.openxmlformats.org/drawingml/2006/main" prst="rect">
@@ -32730,6 +33514,62 @@
           </a:p>
         </p:txBody>
       </p:sp>
+      <p:sp>
+        <p:nvSpPr>
+          <p:cNvPr id="313" name="slide-heading-8">
+            <a:extLst xmlns:a="http://schemas.openxmlformats.org/drawingml/2006/main">
+              <a:ext uri="{FF2B5EF4-FFF2-40B4-BE49-F238E27FC236}">
+                <a16:creationId xmlns:a16="http://schemas.microsoft.com/office/drawing/2014/main" id="{42A63C4E-0D5B-4E2F-9924-0968778D40A2}"/>
+              </a:ext>
+            </a:extLst>
+          </p:cNvPr>
+          <p:cNvSpPr>
+            <a:spLocks xmlns:a="http://schemas.openxmlformats.org/drawingml/2006/main" noGrp="1"/>
+          </p:cNvSpPr>
+          <p:nvPr/>
+        </p:nvSpPr>
+        <p:spPr>
+          <a:xfrm xmlns:a="http://schemas.openxmlformats.org/drawingml/2006/main">
+            <a:off x="552450" y="219075"/>
+            <a:ext cx="6858000" cy="266700"/>
+          </a:xfrm>
+          <a:prstGeom xmlns:a="http://schemas.openxmlformats.org/drawingml/2006/main" prst="rect">
+            <a:avLst/>
+          </a:prstGeom>
+          <a:noFill xmlns:a="http://schemas.openxmlformats.org/drawingml/2006/main"/>
+          <a:ln xmlns:a="http://schemas.openxmlformats.org/drawingml/2006/main" w="0">
+            <a:noFill/>
+            <a:prstDash val="solid"/>
+          </a:ln>
+        </p:spPr>
+        <p:txBody>
+          <a:bodyPr xmlns:a="http://schemas.openxmlformats.org/drawingml/2006/main"/>
+          <a:lstStyle xmlns:a="http://schemas.openxmlformats.org/drawingml/2006/main"/>
+          <a:p xmlns:a="http://schemas.openxmlformats.org/drawingml/2006/main">
+            <a:pPr algn="l">
+              <a:defRPr sz="1350" b="1">
+                <a:solidFill>
+                  <a:srgbClr val="FFFFFF"/>
+                </a:solidFill>
+                <a:latin typeface="Source Code Pro"/>
+                <a:ea typeface="Source Code Pro"/>
+                <a:cs typeface="Source Code Pro"/>
+              </a:defRPr>
+            </a:pPr>
+            <a:r>
+              <a:rPr sz="1350" b="1">
+                <a:solidFill>
+                  <a:srgbClr val="FFFFFF"/>
+                </a:solidFill>
+                <a:latin typeface="Source Code Pro"/>
+                <a:ea typeface="Source Code Pro"/>
+                <a:cs typeface="Source Code Pro"/>
+              </a:rPr>
+              <a:t>Programming starts with ideas</a:t>
+            </a:r>
+          </a:p>
+        </p:txBody>
+      </p:sp>
     </p:spTree>
     <p:extLst>
       <p:ext uri="{BB962C8B-B14F-4D97-AF65-F5344CB8AC3E}">
@@ -32770,7 +33610,7 @@
         </p:nvSpPr>
         <p:spPr>
           <a:xfrm xmlns:a="http://schemas.openxmlformats.org/drawingml/2006/main">
-            <a:off x="1252403" y="2678261"/>
+            <a:off x="1252403" y="2857500"/>
             <a:ext cx="4190700" cy="384600"/>
           </a:xfrm>
           <a:prstGeom xmlns:a="http://schemas.openxmlformats.org/drawingml/2006/main" prst="rect">
@@ -32817,7 +33657,7 @@
         <p:spPr>
           <a:xfrm xmlns:a="http://schemas.openxmlformats.org/drawingml/2006/main">
             <a:off x="1252403" y="1022536"/>
-            <a:ext cx="4190700" cy="548640"/>
+            <a:ext cx="4190700" cy="733500"/>
           </a:xfrm>
           <a:prstGeom xmlns:a="http://schemas.openxmlformats.org/drawingml/2006/main" prst="rect">
             <a:avLst/>
@@ -32867,7 +33707,7 @@
         </p:nvSpPr>
         <p:spPr>
           <a:xfrm xmlns:a="http://schemas.openxmlformats.org/drawingml/2006/main">
-            <a:off x="1252403" y="1620161"/>
+            <a:off x="1252403" y="1790700"/>
             <a:ext cx="4190700" cy="384600"/>
           </a:xfrm>
           <a:prstGeom xmlns:a="http://schemas.openxmlformats.org/drawingml/2006/main" prst="rect">
@@ -32914,7 +33754,7 @@
         <p:spPr>
           <a:xfrm xmlns:a="http://schemas.openxmlformats.org/drawingml/2006/main">
             <a:off x="1252403" y="2080661"/>
-            <a:ext cx="4190700" cy="548640"/>
+            <a:ext cx="4190700" cy="733500"/>
           </a:xfrm>
           <a:prstGeom xmlns:a="http://schemas.openxmlformats.org/drawingml/2006/main" prst="rect">
             <a:avLst/>
@@ -32960,7 +33800,7 @@
         <p:spPr>
           <a:xfrm xmlns:a="http://schemas.openxmlformats.org/drawingml/2006/main">
             <a:off x="1252404" y="3138786"/>
-            <a:ext cx="4190700" cy="548640"/>
+            <a:ext cx="4190700" cy="733500"/>
           </a:xfrm>
           <a:prstGeom xmlns:a="http://schemas.openxmlformats.org/drawingml/2006/main" prst="rect">
             <a:avLst/>
@@ -33010,7 +33850,7 @@
         </p:nvSpPr>
         <p:spPr>
           <a:xfrm xmlns:a="http://schemas.openxmlformats.org/drawingml/2006/main">
-            <a:off x="1252404" y="3736386"/>
+            <a:off x="1252404" y="3914775"/>
             <a:ext cx="4190700" cy="384600"/>
           </a:xfrm>
           <a:prstGeom xmlns:a="http://schemas.openxmlformats.org/drawingml/2006/main" prst="rect">
@@ -33269,6 +34109,62 @@
                 </a:solidFill>
               </a:rPr>
               <a:t>[</a:t>
+            </a:r>
+          </a:p>
+        </p:txBody>
+      </p:sp>
+      <p:sp>
+        <p:nvSpPr>
+          <p:cNvPr id="313" name="slide-heading-9">
+            <a:extLst xmlns:a="http://schemas.openxmlformats.org/drawingml/2006/main">
+              <a:ext uri="{FF2B5EF4-FFF2-40B4-BE49-F238E27FC236}">
+                <a16:creationId xmlns:a16="http://schemas.microsoft.com/office/drawing/2014/main" id="{DC58C05B-4865-470F-A3BA-388C322B816A}"/>
+              </a:ext>
+            </a:extLst>
+          </p:cNvPr>
+          <p:cNvSpPr>
+            <a:spLocks xmlns:a="http://schemas.openxmlformats.org/drawingml/2006/main" noGrp="1"/>
+          </p:cNvSpPr>
+          <p:nvPr/>
+        </p:nvSpPr>
+        <p:spPr>
+          <a:xfrm xmlns:a="http://schemas.openxmlformats.org/drawingml/2006/main">
+            <a:off x="552450" y="219075"/>
+            <a:ext cx="6858000" cy="266700"/>
+          </a:xfrm>
+          <a:prstGeom xmlns:a="http://schemas.openxmlformats.org/drawingml/2006/main" prst="rect">
+            <a:avLst/>
+          </a:prstGeom>
+          <a:noFill xmlns:a="http://schemas.openxmlformats.org/drawingml/2006/main"/>
+          <a:ln xmlns:a="http://schemas.openxmlformats.org/drawingml/2006/main" w="0">
+            <a:noFill/>
+            <a:prstDash val="solid"/>
+          </a:ln>
+        </p:spPr>
+        <p:txBody>
+          <a:bodyPr xmlns:a="http://schemas.openxmlformats.org/drawingml/2006/main"/>
+          <a:lstStyle xmlns:a="http://schemas.openxmlformats.org/drawingml/2006/main"/>
+          <a:p xmlns:a="http://schemas.openxmlformats.org/drawingml/2006/main">
+            <a:pPr algn="l">
+              <a:defRPr sz="1350" b="1">
+                <a:solidFill>
+                  <a:srgbClr val="FFFFFF"/>
+                </a:solidFill>
+                <a:latin typeface="Source Code Pro"/>
+                <a:ea typeface="Source Code Pro"/>
+                <a:cs typeface="Source Code Pro"/>
+              </a:defRPr>
+            </a:pPr>
+            <a:r>
+              <a:rPr sz="1350" b="1">
+                <a:solidFill>
+                  <a:srgbClr val="FFFFFF"/>
+                </a:solidFill>
+                <a:latin typeface="Source Code Pro"/>
+                <a:ea typeface="Source Code Pro"/>
+                <a:cs typeface="Source Code Pro"/>
+              </a:rPr>
+              <a:t>Our Saturday class routine</a:t>
             </a:r>
           </a:p>
         </p:txBody>

</xml_diff>

<commit_message>
fix(2026-07-11): match slide heading style
</commit_message>
<xml_diff>
--- a/2026-07-11_Intro_to_Computer_Science_Programming/2026-07-11_Intro_to_Computer_Science_Programming.pptx
+++ b/2026-07-11_Intro_to_Computer_Science_Programming/2026-07-11_Intro_to_Computer_Science_Programming.pptx
@@ -2,55 +2,55 @@
 <file path=ppt/presentation.xml><?xml version="1.0" encoding="utf-8"?>
 <p:presentation xmlns:p="http://schemas.openxmlformats.org/presentationml/2006/main" embedTrueTypeFonts="1" saveSubsetFonts="1">
   <p:sldMasterIdLst>
-    <p:sldMasterId xmlns:r="http://schemas.openxmlformats.org/officeDocument/2006/relationships" id="2147483648" r:id="R316865c0804744ac"/>
+    <p:sldMasterId xmlns:r="http://schemas.openxmlformats.org/officeDocument/2006/relationships" id="2147483648" r:id="R3b4eb1c274d24026"/>
   </p:sldMasterIdLst>
   <p:notesMasterIdLst>
-    <p:notesMasterId xmlns:r="http://schemas.openxmlformats.org/officeDocument/2006/relationships" r:id="Rae702987c6a5429e"/>
+    <p:notesMasterId xmlns:r="http://schemas.openxmlformats.org/officeDocument/2006/relationships" r:id="R92feef4b6a164373"/>
   </p:notesMasterIdLst>
   <p:sldIdLst>
-    <p:sldId xmlns:r="http://schemas.openxmlformats.org/officeDocument/2006/relationships" id="256" r:id="Rc83d3e40e03b457e"/>
-    <p:sldId xmlns:r="http://schemas.openxmlformats.org/officeDocument/2006/relationships" id="257" r:id="Rf9bcddc0cf564cbf"/>
-    <p:sldId xmlns:r="http://schemas.openxmlformats.org/officeDocument/2006/relationships" id="258" r:id="R03a998ecb04c4a4c"/>
-    <p:sldId xmlns:r="http://schemas.openxmlformats.org/officeDocument/2006/relationships" id="259" r:id="Rb451c7d0957b4dd2"/>
-    <p:sldId xmlns:r="http://schemas.openxmlformats.org/officeDocument/2006/relationships" id="260" r:id="Rde4997d4cc614fa9"/>
-    <p:sldId xmlns:r="http://schemas.openxmlformats.org/officeDocument/2006/relationships" id="261" r:id="Rb4f59ffb46884f55"/>
-    <p:sldId xmlns:r="http://schemas.openxmlformats.org/officeDocument/2006/relationships" id="262" r:id="Rb4751571797d45fa"/>
-    <p:sldId xmlns:r="http://schemas.openxmlformats.org/officeDocument/2006/relationships" id="263" r:id="Rb44cb73827ae4262"/>
-    <p:sldId xmlns:r="http://schemas.openxmlformats.org/officeDocument/2006/relationships" id="264" r:id="Rd02745f6be054363"/>
-    <p:sldId xmlns:r="http://schemas.openxmlformats.org/officeDocument/2006/relationships" id="265" r:id="R4343efe845f04457"/>
-    <p:sldId xmlns:r="http://schemas.openxmlformats.org/officeDocument/2006/relationships" id="266" r:id="R8e3ae2e0c9e444f1"/>
-    <p:sldId xmlns:r="http://schemas.openxmlformats.org/officeDocument/2006/relationships" id="267" r:id="R6f76174f040b42b7"/>
-    <p:sldId xmlns:r="http://schemas.openxmlformats.org/officeDocument/2006/relationships" id="268" r:id="R9e76b669f36d49e1"/>
-    <p:sldId xmlns:r="http://schemas.openxmlformats.org/officeDocument/2006/relationships" id="269" r:id="R51bce2330cbc4f12"/>
-    <p:sldId xmlns:r="http://schemas.openxmlformats.org/officeDocument/2006/relationships" id="270" r:id="Rde48d84fa9d34946"/>
-    <p:sldId xmlns:r="http://schemas.openxmlformats.org/officeDocument/2006/relationships" id="271" r:id="Rc7a7a03b8abe4ca3"/>
-    <p:sldId xmlns:r="http://schemas.openxmlformats.org/officeDocument/2006/relationships" id="272" r:id="Reff8d42975984343"/>
-    <p:sldId xmlns:r="http://schemas.openxmlformats.org/officeDocument/2006/relationships" id="273" r:id="Ree90b721cc62469e"/>
-    <p:sldId xmlns:r="http://schemas.openxmlformats.org/officeDocument/2006/relationships" id="274" r:id="Rfd75855a636f4c9d"/>
-    <p:sldId xmlns:r="http://schemas.openxmlformats.org/officeDocument/2006/relationships" id="275" r:id="Rd506d3ca9ae04f23"/>
-    <p:sldId xmlns:r="http://schemas.openxmlformats.org/officeDocument/2006/relationships" id="276" r:id="Rded450775c514e6b"/>
-    <p:sldId xmlns:r="http://schemas.openxmlformats.org/officeDocument/2006/relationships" id="277" r:id="R13b9d3c56d174f06"/>
-    <p:sldId xmlns:r="http://schemas.openxmlformats.org/officeDocument/2006/relationships" id="278" r:id="R8e3390b7d14b4a77"/>
-    <p:sldId xmlns:r="http://schemas.openxmlformats.org/officeDocument/2006/relationships" id="279" r:id="Rec5c23fab7d24afd"/>
-    <p:sldId xmlns:r="http://schemas.openxmlformats.org/officeDocument/2006/relationships" id="280" r:id="R987419ddb34149d3"/>
-    <p:sldId xmlns:r="http://schemas.openxmlformats.org/officeDocument/2006/relationships" id="281" r:id="R8db3c34e99024aaa"/>
+    <p:sldId xmlns:r="http://schemas.openxmlformats.org/officeDocument/2006/relationships" id="256" r:id="Rd94febe393374a7f"/>
+    <p:sldId xmlns:r="http://schemas.openxmlformats.org/officeDocument/2006/relationships" id="257" r:id="Rcd080cf73ea746d7"/>
+    <p:sldId xmlns:r="http://schemas.openxmlformats.org/officeDocument/2006/relationships" id="258" r:id="R6e3668c970f44cf0"/>
+    <p:sldId xmlns:r="http://schemas.openxmlformats.org/officeDocument/2006/relationships" id="259" r:id="R455fdb550fad4788"/>
+    <p:sldId xmlns:r="http://schemas.openxmlformats.org/officeDocument/2006/relationships" id="260" r:id="Rf1457677984a423d"/>
+    <p:sldId xmlns:r="http://schemas.openxmlformats.org/officeDocument/2006/relationships" id="261" r:id="R225d2b71901e421b"/>
+    <p:sldId xmlns:r="http://schemas.openxmlformats.org/officeDocument/2006/relationships" id="262" r:id="Ra2d5baa2848e4300"/>
+    <p:sldId xmlns:r="http://schemas.openxmlformats.org/officeDocument/2006/relationships" id="263" r:id="R4239a5e40fc8477a"/>
+    <p:sldId xmlns:r="http://schemas.openxmlformats.org/officeDocument/2006/relationships" id="264" r:id="R04c923c23c674af9"/>
+    <p:sldId xmlns:r="http://schemas.openxmlformats.org/officeDocument/2006/relationships" id="265" r:id="R444a8f1106d74044"/>
+    <p:sldId xmlns:r="http://schemas.openxmlformats.org/officeDocument/2006/relationships" id="266" r:id="R0c526b69462546a1"/>
+    <p:sldId xmlns:r="http://schemas.openxmlformats.org/officeDocument/2006/relationships" id="267" r:id="R3584a4828d1d496b"/>
+    <p:sldId xmlns:r="http://schemas.openxmlformats.org/officeDocument/2006/relationships" id="268" r:id="Rcae0cef513ae4da7"/>
+    <p:sldId xmlns:r="http://schemas.openxmlformats.org/officeDocument/2006/relationships" id="269" r:id="R4a9c884ff4784241"/>
+    <p:sldId xmlns:r="http://schemas.openxmlformats.org/officeDocument/2006/relationships" id="270" r:id="R54853493cacd4509"/>
+    <p:sldId xmlns:r="http://schemas.openxmlformats.org/officeDocument/2006/relationships" id="271" r:id="Reb24ac8b36844933"/>
+    <p:sldId xmlns:r="http://schemas.openxmlformats.org/officeDocument/2006/relationships" id="272" r:id="R7da55bc024b6469e"/>
+    <p:sldId xmlns:r="http://schemas.openxmlformats.org/officeDocument/2006/relationships" id="273" r:id="R6369efebb97e401b"/>
+    <p:sldId xmlns:r="http://schemas.openxmlformats.org/officeDocument/2006/relationships" id="274" r:id="Rdae5811f91ba4789"/>
+    <p:sldId xmlns:r="http://schemas.openxmlformats.org/officeDocument/2006/relationships" id="275" r:id="R067545a7a82f41e8"/>
+    <p:sldId xmlns:r="http://schemas.openxmlformats.org/officeDocument/2006/relationships" id="276" r:id="R15b4ed74f0894b5a"/>
+    <p:sldId xmlns:r="http://schemas.openxmlformats.org/officeDocument/2006/relationships" id="277" r:id="R7865d703741c4f3a"/>
+    <p:sldId xmlns:r="http://schemas.openxmlformats.org/officeDocument/2006/relationships" id="278" r:id="R95645096c70c4a37"/>
+    <p:sldId xmlns:r="http://schemas.openxmlformats.org/officeDocument/2006/relationships" id="279" r:id="R6e285976ba7744ad"/>
+    <p:sldId xmlns:r="http://schemas.openxmlformats.org/officeDocument/2006/relationships" id="280" r:id="R627d7fdbe5054847"/>
+    <p:sldId xmlns:r="http://schemas.openxmlformats.org/officeDocument/2006/relationships" id="281" r:id="R6a40418975994017"/>
   </p:sldIdLst>
   <p:sldSz cx="9144000" cy="5143500"/>
   <p:notesSz cx="6858000" cy="9144000"/>
   <p:embeddedFontLst>
     <p:embeddedFont>
       <p:font typeface="Quantico"/>
-      <p:regular xmlns:r="http://schemas.openxmlformats.org/officeDocument/2006/relationships" r:id="Rfba20f19358a4d87"/>
-      <p:bold xmlns:r="http://schemas.openxmlformats.org/officeDocument/2006/relationships" r:id="R1e0f457907794504"/>
-      <p:italic xmlns:r="http://schemas.openxmlformats.org/officeDocument/2006/relationships" r:id="Rec5fe9435d654475"/>
-      <p:boldItalic xmlns:r="http://schemas.openxmlformats.org/officeDocument/2006/relationships" r:id="R51107f10382e4b32"/>
+      <p:regular xmlns:r="http://schemas.openxmlformats.org/officeDocument/2006/relationships" r:id="R523dc4b30b964ec9"/>
+      <p:bold xmlns:r="http://schemas.openxmlformats.org/officeDocument/2006/relationships" r:id="Rb400b9af09f840ce"/>
+      <p:italic xmlns:r="http://schemas.openxmlformats.org/officeDocument/2006/relationships" r:id="Rc906242da7e04149"/>
+      <p:boldItalic xmlns:r="http://schemas.openxmlformats.org/officeDocument/2006/relationships" r:id="Rdf4d33b368c14d35"/>
     </p:embeddedFont>
     <p:embeddedFont>
       <p:font typeface="Source Code Pro"/>
-      <p:regular xmlns:r="http://schemas.openxmlformats.org/officeDocument/2006/relationships" r:id="Rdecc040b29c24ef2"/>
-      <p:bold xmlns:r="http://schemas.openxmlformats.org/officeDocument/2006/relationships" r:id="Rc48a5194ca2546c2"/>
-      <p:italic xmlns:r="http://schemas.openxmlformats.org/officeDocument/2006/relationships" r:id="R1301be46e20645ab"/>
-      <p:boldItalic xmlns:r="http://schemas.openxmlformats.org/officeDocument/2006/relationships" r:id="Rcfcb47df48b04529"/>
+      <p:regular xmlns:r="http://schemas.openxmlformats.org/officeDocument/2006/relationships" r:id="R8aeffa911ca14701"/>
+      <p:bold xmlns:r="http://schemas.openxmlformats.org/officeDocument/2006/relationships" r:id="Rb429eee467774760"/>
+      <p:italic xmlns:r="http://schemas.openxmlformats.org/officeDocument/2006/relationships" r:id="R06824bffc7634510"/>
+      <p:boldItalic xmlns:r="http://schemas.openxmlformats.org/officeDocument/2006/relationships" r:id="R0accc5d07c734001"/>
     </p:embeddedFont>
   </p:embeddedFontLst>
   <p:defaultTextStyle>
@@ -17953,28 +17953,28 @@
   </p:cSld>
   <p:clrMap bg1="lt1" tx1="dk1" bg2="dk2" tx2="lt2" accent1="accent1" accent2="accent2" accent3="accent3" accent4="accent4" accent5="accent5" accent6="accent6" hlink="hlink" folHlink="folHlink"/>
   <p:sldLayoutIdLst>
-    <p:sldLayoutId xmlns:r="http://schemas.openxmlformats.org/officeDocument/2006/relationships" id="2147483649" r:id="R21ebd40119fc4a4d"/>
-    <p:sldLayoutId xmlns:r="http://schemas.openxmlformats.org/officeDocument/2006/relationships" id="2147483650" r:id="R2f5ed9d025834e8e"/>
-    <p:sldLayoutId xmlns:r="http://schemas.openxmlformats.org/officeDocument/2006/relationships" id="2147483651" r:id="R730a2ef0a5f748d2"/>
-    <p:sldLayoutId xmlns:r="http://schemas.openxmlformats.org/officeDocument/2006/relationships" id="2147483652" r:id="R4627175da4124cec"/>
-    <p:sldLayoutId xmlns:r="http://schemas.openxmlformats.org/officeDocument/2006/relationships" id="2147483653" r:id="Ra4174e529dd54a6d"/>
-    <p:sldLayoutId xmlns:r="http://schemas.openxmlformats.org/officeDocument/2006/relationships" id="2147483654" r:id="R9bd1f42ec2ab4e2f"/>
-    <p:sldLayoutId xmlns:r="http://schemas.openxmlformats.org/officeDocument/2006/relationships" id="2147483655" r:id="R6c5209c2057a465a"/>
-    <p:sldLayoutId xmlns:r="http://schemas.openxmlformats.org/officeDocument/2006/relationships" id="2147483656" r:id="Rad2bdfae646a4841"/>
-    <p:sldLayoutId xmlns:r="http://schemas.openxmlformats.org/officeDocument/2006/relationships" id="2147483657" r:id="R7eaccfe1d3a14db5"/>
-    <p:sldLayoutId xmlns:r="http://schemas.openxmlformats.org/officeDocument/2006/relationships" id="2147483658" r:id="R3024559cb9764bb4"/>
-    <p:sldLayoutId xmlns:r="http://schemas.openxmlformats.org/officeDocument/2006/relationships" id="2147483659" r:id="R8cc8e6c365344c19"/>
-    <p:sldLayoutId xmlns:r="http://schemas.openxmlformats.org/officeDocument/2006/relationships" id="2147483660" r:id="R116a576682764054"/>
-    <p:sldLayoutId xmlns:r="http://schemas.openxmlformats.org/officeDocument/2006/relationships" id="2147483661" r:id="R7e4295cdfa3b4f10"/>
-    <p:sldLayoutId xmlns:r="http://schemas.openxmlformats.org/officeDocument/2006/relationships" id="2147483662" r:id="R5c0465a2e09a4485"/>
-    <p:sldLayoutId xmlns:r="http://schemas.openxmlformats.org/officeDocument/2006/relationships" id="2147483663" r:id="Rc94b7756d2604211"/>
-    <p:sldLayoutId xmlns:r="http://schemas.openxmlformats.org/officeDocument/2006/relationships" id="2147483664" r:id="Rdea4fc94a1cf4350"/>
-    <p:sldLayoutId xmlns:r="http://schemas.openxmlformats.org/officeDocument/2006/relationships" id="2147483665" r:id="R03d2f1c378f94235"/>
-    <p:sldLayoutId xmlns:r="http://schemas.openxmlformats.org/officeDocument/2006/relationships" id="2147483666" r:id="Re158bd60edf940e8"/>
-    <p:sldLayoutId xmlns:r="http://schemas.openxmlformats.org/officeDocument/2006/relationships" id="2147483667" r:id="R4a618a026cc948c7"/>
-    <p:sldLayoutId xmlns:r="http://schemas.openxmlformats.org/officeDocument/2006/relationships" id="2147483668" r:id="R3b25be747c9b4812"/>
-    <p:sldLayoutId xmlns:r="http://schemas.openxmlformats.org/officeDocument/2006/relationships" id="2147483669" r:id="Rb5c20ce71d954093"/>
-    <p:sldLayoutId xmlns:r="http://schemas.openxmlformats.org/officeDocument/2006/relationships" id="2147483670" r:id="Rf2b2d0c0f2744114"/>
+    <p:sldLayoutId xmlns:r="http://schemas.openxmlformats.org/officeDocument/2006/relationships" id="2147483649" r:id="Rc604adb281c94f6b"/>
+    <p:sldLayoutId xmlns:r="http://schemas.openxmlformats.org/officeDocument/2006/relationships" id="2147483650" r:id="R4a3746803beb4b79"/>
+    <p:sldLayoutId xmlns:r="http://schemas.openxmlformats.org/officeDocument/2006/relationships" id="2147483651" r:id="Rf822cf1c267748ae"/>
+    <p:sldLayoutId xmlns:r="http://schemas.openxmlformats.org/officeDocument/2006/relationships" id="2147483652" r:id="R22125ee904c944f1"/>
+    <p:sldLayoutId xmlns:r="http://schemas.openxmlformats.org/officeDocument/2006/relationships" id="2147483653" r:id="R0a447dd64cb34d28"/>
+    <p:sldLayoutId xmlns:r="http://schemas.openxmlformats.org/officeDocument/2006/relationships" id="2147483654" r:id="Rbf8abc33f673497d"/>
+    <p:sldLayoutId xmlns:r="http://schemas.openxmlformats.org/officeDocument/2006/relationships" id="2147483655" r:id="Reeb06a758787420f"/>
+    <p:sldLayoutId xmlns:r="http://schemas.openxmlformats.org/officeDocument/2006/relationships" id="2147483656" r:id="Ra20c9c54cb9f4b14"/>
+    <p:sldLayoutId xmlns:r="http://schemas.openxmlformats.org/officeDocument/2006/relationships" id="2147483657" r:id="Rbe80e6bc41f44e7d"/>
+    <p:sldLayoutId xmlns:r="http://schemas.openxmlformats.org/officeDocument/2006/relationships" id="2147483658" r:id="Rc0d6938f29b44a33"/>
+    <p:sldLayoutId xmlns:r="http://schemas.openxmlformats.org/officeDocument/2006/relationships" id="2147483659" r:id="Rf1b52ede8fe14fcb"/>
+    <p:sldLayoutId xmlns:r="http://schemas.openxmlformats.org/officeDocument/2006/relationships" id="2147483660" r:id="R50e7a0d9dc3f414e"/>
+    <p:sldLayoutId xmlns:r="http://schemas.openxmlformats.org/officeDocument/2006/relationships" id="2147483661" r:id="R45e1dad6676049e7"/>
+    <p:sldLayoutId xmlns:r="http://schemas.openxmlformats.org/officeDocument/2006/relationships" id="2147483662" r:id="R60128d31b1864452"/>
+    <p:sldLayoutId xmlns:r="http://schemas.openxmlformats.org/officeDocument/2006/relationships" id="2147483663" r:id="R459caf1f592a4c03"/>
+    <p:sldLayoutId xmlns:r="http://schemas.openxmlformats.org/officeDocument/2006/relationships" id="2147483664" r:id="R5b654e360ee94800"/>
+    <p:sldLayoutId xmlns:r="http://schemas.openxmlformats.org/officeDocument/2006/relationships" id="2147483665" r:id="Rd2ddbf651a7d43f5"/>
+    <p:sldLayoutId xmlns:r="http://schemas.openxmlformats.org/officeDocument/2006/relationships" id="2147483666" r:id="R1bf63582000641a6"/>
+    <p:sldLayoutId xmlns:r="http://schemas.openxmlformats.org/officeDocument/2006/relationships" id="2147483667" r:id="R5fc94e3547fa43be"/>
+    <p:sldLayoutId xmlns:r="http://schemas.openxmlformats.org/officeDocument/2006/relationships" id="2147483668" r:id="Rbc88a9654a664144"/>
+    <p:sldLayoutId xmlns:r="http://schemas.openxmlformats.org/officeDocument/2006/relationships" id="2147483669" r:id="R8293d955d301404c"/>
+    <p:sldLayoutId xmlns:r="http://schemas.openxmlformats.org/officeDocument/2006/relationships" id="2147483670" r:id="Rd7cc72f752c24963"/>
   </p:sldLayoutIdLst>
   <p:hf sldNum="0" hdr="0" ftr="0" dt="0"/>
   <p:txStyles>
@@ -20067,10 +20067,10 @@
       </p:sp>
       <p:sp>
         <p:nvSpPr>
-          <p:cNvPr id="313" name="slide-heading-10">
-            <a:extLst xmlns:a="http://schemas.openxmlformats.org/drawingml/2006/main">
-              <a:ext uri="{FF2B5EF4-FFF2-40B4-BE49-F238E27FC236}">
-                <a16:creationId xmlns:a16="http://schemas.microsoft.com/office/drawing/2014/main" id="{EB4D228F-D243-4881-BA76-77C63C827DC2}"/>
+          <p:cNvPr id="313" name="slide-heading-marker-10">
+            <a:extLst xmlns:a="http://schemas.openxmlformats.org/drawingml/2006/main">
+              <a:ext uri="{FF2B5EF4-FFF2-40B4-BE49-F238E27FC236}">
+                <a16:creationId xmlns:a16="http://schemas.microsoft.com/office/drawing/2014/main" id="{D9D2D26E-6407-43BB-852F-7CB5FA81EE9F}"/>
               </a:ext>
             </a:extLst>
           </p:cNvPr>
@@ -20081,8 +20081,8 @@
         </p:nvSpPr>
         <p:spPr>
           <a:xfrm xmlns:a="http://schemas.openxmlformats.org/drawingml/2006/main">
-            <a:off x="552450" y="219075"/>
-            <a:ext cx="6858000" cy="266700"/>
+            <a:off x="742950" y="447675"/>
+            <a:ext cx="476250" cy="323850"/>
           </a:xfrm>
           <a:prstGeom xmlns:a="http://schemas.openxmlformats.org/drawingml/2006/main" prst="rect">
             <a:avLst/>
@@ -20098,9 +20098,9 @@
           <a:lstStyle xmlns:a="http://schemas.openxmlformats.org/drawingml/2006/main"/>
           <a:p xmlns:a="http://schemas.openxmlformats.org/drawingml/2006/main">
             <a:pPr algn="l">
-              <a:defRPr sz="1350" b="1">
+              <a:defRPr sz="1950" b="1">
                 <a:solidFill>
-                  <a:srgbClr val="FFFFFF"/>
+                  <a:srgbClr val="FFDB5D"/>
                 </a:solidFill>
                 <a:latin typeface="Source Code Pro"/>
                 <a:ea typeface="Source Code Pro"/>
@@ -20108,13 +20108,69 @@
               </a:defRPr>
             </a:pPr>
             <a:r>
-              <a:rPr sz="1350" b="1">
+              <a:rPr sz="1950" b="1">
                 <a:solidFill>
-                  <a:srgbClr val="FFFFFF"/>
+                  <a:srgbClr val="FFDB5D"/>
                 </a:solidFill>
                 <a:latin typeface="Source Code Pro"/>
                 <a:ea typeface="Source Code Pro"/>
                 <a:cs typeface="Source Code Pro"/>
+              </a:rPr>
+              <a:t>&lt;/</a:t>
+            </a:r>
+          </a:p>
+        </p:txBody>
+      </p:sp>
+      <p:sp>
+        <p:nvSpPr>
+          <p:cNvPr id="314" name="slide-heading-text-10">
+            <a:extLst xmlns:a="http://schemas.openxmlformats.org/drawingml/2006/main">
+              <a:ext uri="{FF2B5EF4-FFF2-40B4-BE49-F238E27FC236}">
+                <a16:creationId xmlns:a16="http://schemas.microsoft.com/office/drawing/2014/main" id="{495A3B83-4C65-4C13-9FD7-4AD8AF24B897}"/>
+              </a:ext>
+            </a:extLst>
+          </p:cNvPr>
+          <p:cNvSpPr>
+            <a:spLocks xmlns:a="http://schemas.openxmlformats.org/drawingml/2006/main" noGrp="1"/>
+          </p:cNvSpPr>
+          <p:nvPr/>
+        </p:nvSpPr>
+        <p:spPr>
+          <a:xfrm xmlns:a="http://schemas.openxmlformats.org/drawingml/2006/main">
+            <a:off x="1152525" y="428625"/>
+            <a:ext cx="5619750" cy="361950"/>
+          </a:xfrm>
+          <a:prstGeom xmlns:a="http://schemas.openxmlformats.org/drawingml/2006/main" prst="rect">
+            <a:avLst/>
+          </a:prstGeom>
+          <a:noFill xmlns:a="http://schemas.openxmlformats.org/drawingml/2006/main"/>
+          <a:ln xmlns:a="http://schemas.openxmlformats.org/drawingml/2006/main" w="0">
+            <a:noFill/>
+            <a:prstDash val="solid"/>
+          </a:ln>
+        </p:spPr>
+        <p:txBody>
+          <a:bodyPr xmlns:a="http://schemas.openxmlformats.org/drawingml/2006/main"/>
+          <a:lstStyle xmlns:a="http://schemas.openxmlformats.org/drawingml/2006/main"/>
+          <a:p xmlns:a="http://schemas.openxmlformats.org/drawingml/2006/main">
+            <a:pPr algn="l">
+              <a:defRPr sz="1800" b="0">
+                <a:solidFill>
+                  <a:srgbClr val="FFFFFF"/>
+                </a:solidFill>
+                <a:latin typeface="Arial"/>
+                <a:ea typeface="Arial"/>
+                <a:cs typeface="Arial"/>
+              </a:defRPr>
+            </a:pPr>
+            <a:r>
+              <a:rPr sz="1800" b="0">
+                <a:solidFill>
+                  <a:srgbClr val="FFFFFF"/>
+                </a:solidFill>
+                <a:latin typeface="Arial"/>
+                <a:ea typeface="Arial"/>
+                <a:cs typeface="Arial"/>
               </a:rPr>
               <a:t>Find class in Microsoft Teams</a:t>
             </a:r>
@@ -20666,10 +20722,10 @@
       </p:sp>
       <p:sp>
         <p:nvSpPr>
-          <p:cNvPr id="313" name="slide-heading-11">
-            <a:extLst xmlns:a="http://schemas.openxmlformats.org/drawingml/2006/main">
-              <a:ext uri="{FF2B5EF4-FFF2-40B4-BE49-F238E27FC236}">
-                <a16:creationId xmlns:a16="http://schemas.microsoft.com/office/drawing/2014/main" id="{9DE39D22-8A17-4CC3-AD46-A745C8F2AF0D}"/>
+          <p:cNvPr id="313" name="slide-heading-marker-11">
+            <a:extLst xmlns:a="http://schemas.openxmlformats.org/drawingml/2006/main">
+              <a:ext uri="{FF2B5EF4-FFF2-40B4-BE49-F238E27FC236}">
+                <a16:creationId xmlns:a16="http://schemas.microsoft.com/office/drawing/2014/main" id="{E0D9E6CB-365E-4F2E-9D9B-DBFDD9CB055C}"/>
               </a:ext>
             </a:extLst>
           </p:cNvPr>
@@ -20680,8 +20736,8 @@
         </p:nvSpPr>
         <p:spPr>
           <a:xfrm xmlns:a="http://schemas.openxmlformats.org/drawingml/2006/main">
-            <a:off x="552450" y="219075"/>
-            <a:ext cx="6858000" cy="266700"/>
+            <a:off x="742950" y="447675"/>
+            <a:ext cx="476250" cy="323850"/>
           </a:xfrm>
           <a:prstGeom xmlns:a="http://schemas.openxmlformats.org/drawingml/2006/main" prst="rect">
             <a:avLst/>
@@ -20697,9 +20753,9 @@
           <a:lstStyle xmlns:a="http://schemas.openxmlformats.org/drawingml/2006/main"/>
           <a:p xmlns:a="http://schemas.openxmlformats.org/drawingml/2006/main">
             <a:pPr algn="l">
-              <a:defRPr sz="1350" b="1">
+              <a:defRPr sz="1950" b="1">
                 <a:solidFill>
-                  <a:srgbClr val="FFFFFF"/>
+                  <a:srgbClr val="FFDB5D"/>
                 </a:solidFill>
                 <a:latin typeface="Source Code Pro"/>
                 <a:ea typeface="Source Code Pro"/>
@@ -20707,13 +20763,69 @@
               </a:defRPr>
             </a:pPr>
             <a:r>
-              <a:rPr sz="1350" b="1">
+              <a:rPr sz="1950" b="1">
                 <a:solidFill>
-                  <a:srgbClr val="FFFFFF"/>
+                  <a:srgbClr val="FFDB5D"/>
                 </a:solidFill>
                 <a:latin typeface="Source Code Pro"/>
                 <a:ea typeface="Source Code Pro"/>
                 <a:cs typeface="Source Code Pro"/>
+              </a:rPr>
+              <a:t>&lt;/</a:t>
+            </a:r>
+          </a:p>
+        </p:txBody>
+      </p:sp>
+      <p:sp>
+        <p:nvSpPr>
+          <p:cNvPr id="314" name="slide-heading-text-11">
+            <a:extLst xmlns:a="http://schemas.openxmlformats.org/drawingml/2006/main">
+              <a:ext uri="{FF2B5EF4-FFF2-40B4-BE49-F238E27FC236}">
+                <a16:creationId xmlns:a16="http://schemas.microsoft.com/office/drawing/2014/main" id="{E036BAB6-753C-4A3C-BB90-409F06C989DB}"/>
+              </a:ext>
+            </a:extLst>
+          </p:cNvPr>
+          <p:cNvSpPr>
+            <a:spLocks xmlns:a="http://schemas.openxmlformats.org/drawingml/2006/main" noGrp="1"/>
+          </p:cNvSpPr>
+          <p:nvPr/>
+        </p:nvSpPr>
+        <p:spPr>
+          <a:xfrm xmlns:a="http://schemas.openxmlformats.org/drawingml/2006/main">
+            <a:off x="1152525" y="428625"/>
+            <a:ext cx="5619750" cy="361950"/>
+          </a:xfrm>
+          <a:prstGeom xmlns:a="http://schemas.openxmlformats.org/drawingml/2006/main" prst="rect">
+            <a:avLst/>
+          </a:prstGeom>
+          <a:noFill xmlns:a="http://schemas.openxmlformats.org/drawingml/2006/main"/>
+          <a:ln xmlns:a="http://schemas.openxmlformats.org/drawingml/2006/main" w="0">
+            <a:noFill/>
+            <a:prstDash val="solid"/>
+          </a:ln>
+        </p:spPr>
+        <p:txBody>
+          <a:bodyPr xmlns:a="http://schemas.openxmlformats.org/drawingml/2006/main"/>
+          <a:lstStyle xmlns:a="http://schemas.openxmlformats.org/drawingml/2006/main"/>
+          <a:p xmlns:a="http://schemas.openxmlformats.org/drawingml/2006/main">
+            <a:pPr algn="l">
+              <a:defRPr sz="1800" b="0">
+                <a:solidFill>
+                  <a:srgbClr val="FFFFFF"/>
+                </a:solidFill>
+                <a:latin typeface="Arial"/>
+                <a:ea typeface="Arial"/>
+                <a:cs typeface="Arial"/>
+              </a:defRPr>
+            </a:pPr>
+            <a:r>
+              <a:rPr sz="1800" b="0">
+                <a:solidFill>
+                  <a:srgbClr val="FFFFFF"/>
+                </a:solidFill>
+                <a:latin typeface="Arial"/>
+                <a:ea typeface="Arial"/>
+                <a:cs typeface="Arial"/>
               </a:rPr>
               <a:t>Know the Teams channels</a:t>
             </a:r>
@@ -21265,10 +21377,10 @@
       </p:sp>
       <p:sp>
         <p:nvSpPr>
-          <p:cNvPr id="313" name="slide-heading-12">
-            <a:extLst xmlns:a="http://schemas.openxmlformats.org/drawingml/2006/main">
-              <a:ext uri="{FF2B5EF4-FFF2-40B4-BE49-F238E27FC236}">
-                <a16:creationId xmlns:a16="http://schemas.microsoft.com/office/drawing/2014/main" id="{E9F6E9FD-1A91-403A-9E34-4884CF214F5B}"/>
+          <p:cNvPr id="313" name="slide-heading-marker-12">
+            <a:extLst xmlns:a="http://schemas.openxmlformats.org/drawingml/2006/main">
+              <a:ext uri="{FF2B5EF4-FFF2-40B4-BE49-F238E27FC236}">
+                <a16:creationId xmlns:a16="http://schemas.microsoft.com/office/drawing/2014/main" id="{AFA73CC8-D9D6-4500-B08A-A8EA76A0D0B7}"/>
               </a:ext>
             </a:extLst>
           </p:cNvPr>
@@ -21279,8 +21391,8 @@
         </p:nvSpPr>
         <p:spPr>
           <a:xfrm xmlns:a="http://schemas.openxmlformats.org/drawingml/2006/main">
-            <a:off x="552450" y="219075"/>
-            <a:ext cx="6858000" cy="266700"/>
+            <a:off x="742950" y="447675"/>
+            <a:ext cx="476250" cy="323850"/>
           </a:xfrm>
           <a:prstGeom xmlns:a="http://schemas.openxmlformats.org/drawingml/2006/main" prst="rect">
             <a:avLst/>
@@ -21296,9 +21408,9 @@
           <a:lstStyle xmlns:a="http://schemas.openxmlformats.org/drawingml/2006/main"/>
           <a:p xmlns:a="http://schemas.openxmlformats.org/drawingml/2006/main">
             <a:pPr algn="l">
-              <a:defRPr sz="1350" b="1">
+              <a:defRPr sz="1950" b="1">
                 <a:solidFill>
-                  <a:srgbClr val="FFFFFF"/>
+                  <a:srgbClr val="FFDB5D"/>
                 </a:solidFill>
                 <a:latin typeface="Source Code Pro"/>
                 <a:ea typeface="Source Code Pro"/>
@@ -21306,13 +21418,69 @@
               </a:defRPr>
             </a:pPr>
             <a:r>
-              <a:rPr sz="1350" b="1">
+              <a:rPr sz="1950" b="1">
                 <a:solidFill>
-                  <a:srgbClr val="FFFFFF"/>
+                  <a:srgbClr val="FFDB5D"/>
                 </a:solidFill>
                 <a:latin typeface="Source Code Pro"/>
                 <a:ea typeface="Source Code Pro"/>
                 <a:cs typeface="Source Code Pro"/>
+              </a:rPr>
+              <a:t>&lt;/</a:t>
+            </a:r>
+          </a:p>
+        </p:txBody>
+      </p:sp>
+      <p:sp>
+        <p:nvSpPr>
+          <p:cNvPr id="314" name="slide-heading-text-12">
+            <a:extLst xmlns:a="http://schemas.openxmlformats.org/drawingml/2006/main">
+              <a:ext uri="{FF2B5EF4-FFF2-40B4-BE49-F238E27FC236}">
+                <a16:creationId xmlns:a16="http://schemas.microsoft.com/office/drawing/2014/main" id="{055DA8BF-BF41-474D-9CE9-69D773356B96}"/>
+              </a:ext>
+            </a:extLst>
+          </p:cNvPr>
+          <p:cNvSpPr>
+            <a:spLocks xmlns:a="http://schemas.openxmlformats.org/drawingml/2006/main" noGrp="1"/>
+          </p:cNvSpPr>
+          <p:nvPr/>
+        </p:nvSpPr>
+        <p:spPr>
+          <a:xfrm xmlns:a="http://schemas.openxmlformats.org/drawingml/2006/main">
+            <a:off x="1152525" y="428625"/>
+            <a:ext cx="5619750" cy="361950"/>
+          </a:xfrm>
+          <a:prstGeom xmlns:a="http://schemas.openxmlformats.org/drawingml/2006/main" prst="rect">
+            <a:avLst/>
+          </a:prstGeom>
+          <a:noFill xmlns:a="http://schemas.openxmlformats.org/drawingml/2006/main"/>
+          <a:ln xmlns:a="http://schemas.openxmlformats.org/drawingml/2006/main" w="0">
+            <a:noFill/>
+            <a:prstDash val="solid"/>
+          </a:ln>
+        </p:spPr>
+        <p:txBody>
+          <a:bodyPr xmlns:a="http://schemas.openxmlformats.org/drawingml/2006/main"/>
+          <a:lstStyle xmlns:a="http://schemas.openxmlformats.org/drawingml/2006/main"/>
+          <a:p xmlns:a="http://schemas.openxmlformats.org/drawingml/2006/main">
+            <a:pPr algn="l">
+              <a:defRPr sz="1800" b="0">
+                <a:solidFill>
+                  <a:srgbClr val="FFFFFF"/>
+                </a:solidFill>
+                <a:latin typeface="Arial"/>
+                <a:ea typeface="Arial"/>
+                <a:cs typeface="Arial"/>
+              </a:defRPr>
+            </a:pPr>
+            <a:r>
+              <a:rPr sz="1800" b="0">
+                <a:solidFill>
+                  <a:srgbClr val="FFFFFF"/>
+                </a:solidFill>
+                <a:latin typeface="Arial"/>
+                <a:ea typeface="Arial"/>
+                <a:cs typeface="Arial"/>
               </a:rPr>
               <a:t>Use hangout for extra help</a:t>
             </a:r>
@@ -21878,10 +22046,10 @@
       </p:sp>
       <p:sp>
         <p:nvSpPr>
-          <p:cNvPr id="313" name="slide-heading-13">
-            <a:extLst xmlns:a="http://schemas.openxmlformats.org/drawingml/2006/main">
-              <a:ext uri="{FF2B5EF4-FFF2-40B4-BE49-F238E27FC236}">
-                <a16:creationId xmlns:a16="http://schemas.microsoft.com/office/drawing/2014/main" id="{4ECF204A-636A-4922-8392-3A1E06A68D47}"/>
+          <p:cNvPr id="313" name="slide-heading-marker-13">
+            <a:extLst xmlns:a="http://schemas.openxmlformats.org/drawingml/2006/main">
+              <a:ext uri="{FF2B5EF4-FFF2-40B4-BE49-F238E27FC236}">
+                <a16:creationId xmlns:a16="http://schemas.microsoft.com/office/drawing/2014/main" id="{CE43F6CE-4D82-4FBD-9536-475175BA4BAB}"/>
               </a:ext>
             </a:extLst>
           </p:cNvPr>
@@ -21892,8 +22060,8 @@
         </p:nvSpPr>
         <p:spPr>
           <a:xfrm xmlns:a="http://schemas.openxmlformats.org/drawingml/2006/main">
-            <a:off x="552450" y="219075"/>
-            <a:ext cx="6858000" cy="266700"/>
+            <a:off x="742950" y="447675"/>
+            <a:ext cx="476250" cy="323850"/>
           </a:xfrm>
           <a:prstGeom xmlns:a="http://schemas.openxmlformats.org/drawingml/2006/main" prst="rect">
             <a:avLst/>
@@ -21909,9 +22077,9 @@
           <a:lstStyle xmlns:a="http://schemas.openxmlformats.org/drawingml/2006/main"/>
           <a:p xmlns:a="http://schemas.openxmlformats.org/drawingml/2006/main">
             <a:pPr algn="l">
-              <a:defRPr sz="1350" b="1">
+              <a:defRPr sz="1950" b="1">
                 <a:solidFill>
-                  <a:srgbClr val="FFFFFF"/>
+                  <a:srgbClr val="FFDB5D"/>
                 </a:solidFill>
                 <a:latin typeface="Source Code Pro"/>
                 <a:ea typeface="Source Code Pro"/>
@@ -21919,13 +22087,69 @@
               </a:defRPr>
             </a:pPr>
             <a:r>
-              <a:rPr sz="1350" b="1">
+              <a:rPr sz="1950" b="1">
                 <a:solidFill>
-                  <a:srgbClr val="FFFFFF"/>
+                  <a:srgbClr val="FFDB5D"/>
                 </a:solidFill>
                 <a:latin typeface="Source Code Pro"/>
                 <a:ea typeface="Source Code Pro"/>
                 <a:cs typeface="Source Code Pro"/>
+              </a:rPr>
+              <a:t>&lt;/</a:t>
+            </a:r>
+          </a:p>
+        </p:txBody>
+      </p:sp>
+      <p:sp>
+        <p:nvSpPr>
+          <p:cNvPr id="314" name="slide-heading-text-13">
+            <a:extLst xmlns:a="http://schemas.openxmlformats.org/drawingml/2006/main">
+              <a:ext uri="{FF2B5EF4-FFF2-40B4-BE49-F238E27FC236}">
+                <a16:creationId xmlns:a16="http://schemas.microsoft.com/office/drawing/2014/main" id="{83BF32FD-0FAF-4485-80FA-BBFCBD628ABA}"/>
+              </a:ext>
+            </a:extLst>
+          </p:cNvPr>
+          <p:cNvSpPr>
+            <a:spLocks xmlns:a="http://schemas.openxmlformats.org/drawingml/2006/main" noGrp="1"/>
+          </p:cNvSpPr>
+          <p:nvPr/>
+        </p:nvSpPr>
+        <p:spPr>
+          <a:xfrm xmlns:a="http://schemas.openxmlformats.org/drawingml/2006/main">
+            <a:off x="1152525" y="428625"/>
+            <a:ext cx="5619750" cy="361950"/>
+          </a:xfrm>
+          <a:prstGeom xmlns:a="http://schemas.openxmlformats.org/drawingml/2006/main" prst="rect">
+            <a:avLst/>
+          </a:prstGeom>
+          <a:noFill xmlns:a="http://schemas.openxmlformats.org/drawingml/2006/main"/>
+          <a:ln xmlns:a="http://schemas.openxmlformats.org/drawingml/2006/main" w="0">
+            <a:noFill/>
+            <a:prstDash val="solid"/>
+          </a:ln>
+        </p:spPr>
+        <p:txBody>
+          <a:bodyPr xmlns:a="http://schemas.openxmlformats.org/drawingml/2006/main"/>
+          <a:lstStyle xmlns:a="http://schemas.openxmlformats.org/drawingml/2006/main"/>
+          <a:p xmlns:a="http://schemas.openxmlformats.org/drawingml/2006/main">
+            <a:pPr algn="l">
+              <a:defRPr sz="1800" b="0">
+                <a:solidFill>
+                  <a:srgbClr val="FFFFFF"/>
+                </a:solidFill>
+                <a:latin typeface="Arial"/>
+                <a:ea typeface="Arial"/>
+                <a:cs typeface="Arial"/>
+              </a:defRPr>
+            </a:pPr>
+            <a:r>
+              <a:rPr sz="1800" b="0">
+                <a:solidFill>
+                  <a:srgbClr val="FFFFFF"/>
+                </a:solidFill>
+                <a:latin typeface="Arial"/>
+                <a:ea typeface="Arial"/>
+                <a:cs typeface="Arial"/>
               </a:rPr>
               <a:t>Class habits that help everyone</a:t>
             </a:r>
@@ -24685,10 +24909,10 @@
       </p:sp>
       <p:sp>
         <p:nvSpPr>
-          <p:cNvPr id="313" name="slide-heading-17">
-            <a:extLst xmlns:a="http://schemas.openxmlformats.org/drawingml/2006/main">
-              <a:ext uri="{FF2B5EF4-FFF2-40B4-BE49-F238E27FC236}">
-                <a16:creationId xmlns:a16="http://schemas.microsoft.com/office/drawing/2014/main" id="{87C46D78-4836-4F18-AD1F-869A79E49118}"/>
+          <p:cNvPr id="313" name="slide-heading-marker-17">
+            <a:extLst xmlns:a="http://schemas.openxmlformats.org/drawingml/2006/main">
+              <a:ext uri="{FF2B5EF4-FFF2-40B4-BE49-F238E27FC236}">
+                <a16:creationId xmlns:a16="http://schemas.microsoft.com/office/drawing/2014/main" id="{559BC036-4BD0-412B-AB5C-572DD9375E95}"/>
               </a:ext>
             </a:extLst>
           </p:cNvPr>
@@ -24699,8 +24923,8 @@
         </p:nvSpPr>
         <p:spPr>
           <a:xfrm xmlns:a="http://schemas.openxmlformats.org/drawingml/2006/main">
-            <a:off x="552450" y="219075"/>
-            <a:ext cx="6858000" cy="266700"/>
+            <a:off x="742950" y="447675"/>
+            <a:ext cx="476250" cy="323850"/>
           </a:xfrm>
           <a:prstGeom xmlns:a="http://schemas.openxmlformats.org/drawingml/2006/main" prst="rect">
             <a:avLst/>
@@ -24716,9 +24940,9 @@
           <a:lstStyle xmlns:a="http://schemas.openxmlformats.org/drawingml/2006/main"/>
           <a:p xmlns:a="http://schemas.openxmlformats.org/drawingml/2006/main">
             <a:pPr algn="l">
-              <a:defRPr sz="1350" b="1">
+              <a:defRPr sz="1950" b="1">
                 <a:solidFill>
-                  <a:srgbClr val="FFFFFF"/>
+                  <a:srgbClr val="FFDB5D"/>
                 </a:solidFill>
                 <a:latin typeface="Source Code Pro"/>
                 <a:ea typeface="Source Code Pro"/>
@@ -24726,13 +24950,69 @@
               </a:defRPr>
             </a:pPr>
             <a:r>
-              <a:rPr sz="1350" b="1">
+              <a:rPr sz="1950" b="1">
                 <a:solidFill>
-                  <a:srgbClr val="FFFFFF"/>
+                  <a:srgbClr val="FFDB5D"/>
                 </a:solidFill>
                 <a:latin typeface="Source Code Pro"/>
                 <a:ea typeface="Source Code Pro"/>
                 <a:cs typeface="Source Code Pro"/>
+              </a:rPr>
+              <a:t>&lt;/</a:t>
+            </a:r>
+          </a:p>
+        </p:txBody>
+      </p:sp>
+      <p:sp>
+        <p:nvSpPr>
+          <p:cNvPr id="314" name="slide-heading-text-17">
+            <a:extLst xmlns:a="http://schemas.openxmlformats.org/drawingml/2006/main">
+              <a:ext uri="{FF2B5EF4-FFF2-40B4-BE49-F238E27FC236}">
+                <a16:creationId xmlns:a16="http://schemas.microsoft.com/office/drawing/2014/main" id="{7252F779-6AC0-41E4-A633-40E59A7D6DCB}"/>
+              </a:ext>
+            </a:extLst>
+          </p:cNvPr>
+          <p:cNvSpPr>
+            <a:spLocks xmlns:a="http://schemas.openxmlformats.org/drawingml/2006/main" noGrp="1"/>
+          </p:cNvSpPr>
+          <p:nvPr/>
+        </p:nvSpPr>
+        <p:spPr>
+          <a:xfrm xmlns:a="http://schemas.openxmlformats.org/drawingml/2006/main">
+            <a:off x="1152525" y="428625"/>
+            <a:ext cx="5619750" cy="361950"/>
+          </a:xfrm>
+          <a:prstGeom xmlns:a="http://schemas.openxmlformats.org/drawingml/2006/main" prst="rect">
+            <a:avLst/>
+          </a:prstGeom>
+          <a:noFill xmlns:a="http://schemas.openxmlformats.org/drawingml/2006/main"/>
+          <a:ln xmlns:a="http://schemas.openxmlformats.org/drawingml/2006/main" w="0">
+            <a:noFill/>
+            <a:prstDash val="solid"/>
+          </a:ln>
+        </p:spPr>
+        <p:txBody>
+          <a:bodyPr xmlns:a="http://schemas.openxmlformats.org/drawingml/2006/main"/>
+          <a:lstStyle xmlns:a="http://schemas.openxmlformats.org/drawingml/2006/main"/>
+          <a:p xmlns:a="http://schemas.openxmlformats.org/drawingml/2006/main">
+            <a:pPr algn="l">
+              <a:defRPr sz="1800" b="0">
+                <a:solidFill>
+                  <a:srgbClr val="FFFFFF"/>
+                </a:solidFill>
+                <a:latin typeface="Arial"/>
+                <a:ea typeface="Arial"/>
+                <a:cs typeface="Arial"/>
+              </a:defRPr>
+            </a:pPr>
+            <a:r>
+              <a:rPr sz="1800" b="0">
+                <a:solidFill>
+                  <a:srgbClr val="FFFFFF"/>
+                </a:solidFill>
+                <a:latin typeface="Arial"/>
+                <a:ea typeface="Arial"/>
+                <a:cs typeface="Arial"/>
               </a:rPr>
               <a:t>Breakout room jobs</a:t>
             </a:r>
@@ -25284,10 +25564,10 @@
       </p:sp>
       <p:sp>
         <p:nvSpPr>
-          <p:cNvPr id="313" name="slide-heading-18">
-            <a:extLst xmlns:a="http://schemas.openxmlformats.org/drawingml/2006/main">
-              <a:ext uri="{FF2B5EF4-FFF2-40B4-BE49-F238E27FC236}">
-                <a16:creationId xmlns:a16="http://schemas.microsoft.com/office/drawing/2014/main" id="{D99756FA-5D29-4B40-AB32-0BA3B9CC34F3}"/>
+          <p:cNvPr id="313" name="slide-heading-marker-18">
+            <a:extLst xmlns:a="http://schemas.openxmlformats.org/drawingml/2006/main">
+              <a:ext uri="{FF2B5EF4-FFF2-40B4-BE49-F238E27FC236}">
+                <a16:creationId xmlns:a16="http://schemas.microsoft.com/office/drawing/2014/main" id="{A39BB46D-1AA7-4211-9D40-E9FFDCFA524F}"/>
               </a:ext>
             </a:extLst>
           </p:cNvPr>
@@ -25298,8 +25578,8 @@
         </p:nvSpPr>
         <p:spPr>
           <a:xfrm xmlns:a="http://schemas.openxmlformats.org/drawingml/2006/main">
-            <a:off x="552450" y="219075"/>
-            <a:ext cx="6858000" cy="266700"/>
+            <a:off x="742950" y="447675"/>
+            <a:ext cx="476250" cy="323850"/>
           </a:xfrm>
           <a:prstGeom xmlns:a="http://schemas.openxmlformats.org/drawingml/2006/main" prst="rect">
             <a:avLst/>
@@ -25315,9 +25595,9 @@
           <a:lstStyle xmlns:a="http://schemas.openxmlformats.org/drawingml/2006/main"/>
           <a:p xmlns:a="http://schemas.openxmlformats.org/drawingml/2006/main">
             <a:pPr algn="l">
-              <a:defRPr sz="1350" b="1">
+              <a:defRPr sz="1950" b="1">
                 <a:solidFill>
-                  <a:srgbClr val="FFFFFF"/>
+                  <a:srgbClr val="FFDB5D"/>
                 </a:solidFill>
                 <a:latin typeface="Source Code Pro"/>
                 <a:ea typeface="Source Code Pro"/>
@@ -25325,13 +25605,69 @@
               </a:defRPr>
             </a:pPr>
             <a:r>
-              <a:rPr sz="1350" b="1">
+              <a:rPr sz="1950" b="1">
                 <a:solidFill>
-                  <a:srgbClr val="FFFFFF"/>
+                  <a:srgbClr val="FFDB5D"/>
                 </a:solidFill>
                 <a:latin typeface="Source Code Pro"/>
                 <a:ea typeface="Source Code Pro"/>
                 <a:cs typeface="Source Code Pro"/>
+              </a:rPr>
+              <a:t>&lt;/</a:t>
+            </a:r>
+          </a:p>
+        </p:txBody>
+      </p:sp>
+      <p:sp>
+        <p:nvSpPr>
+          <p:cNvPr id="314" name="slide-heading-text-18">
+            <a:extLst xmlns:a="http://schemas.openxmlformats.org/drawingml/2006/main">
+              <a:ext uri="{FF2B5EF4-FFF2-40B4-BE49-F238E27FC236}">
+                <a16:creationId xmlns:a16="http://schemas.microsoft.com/office/drawing/2014/main" id="{FC3829C1-E401-4194-8D1B-38B699279D94}"/>
+              </a:ext>
+            </a:extLst>
+          </p:cNvPr>
+          <p:cNvSpPr>
+            <a:spLocks xmlns:a="http://schemas.openxmlformats.org/drawingml/2006/main" noGrp="1"/>
+          </p:cNvSpPr>
+          <p:nvPr/>
+        </p:nvSpPr>
+        <p:spPr>
+          <a:xfrm xmlns:a="http://schemas.openxmlformats.org/drawingml/2006/main">
+            <a:off x="1152525" y="428625"/>
+            <a:ext cx="5619750" cy="361950"/>
+          </a:xfrm>
+          <a:prstGeom xmlns:a="http://schemas.openxmlformats.org/drawingml/2006/main" prst="rect">
+            <a:avLst/>
+          </a:prstGeom>
+          <a:noFill xmlns:a="http://schemas.openxmlformats.org/drawingml/2006/main"/>
+          <a:ln xmlns:a="http://schemas.openxmlformats.org/drawingml/2006/main" w="0">
+            <a:noFill/>
+            <a:prstDash val="solid"/>
+          </a:ln>
+        </p:spPr>
+        <p:txBody>
+          <a:bodyPr xmlns:a="http://schemas.openxmlformats.org/drawingml/2006/main"/>
+          <a:lstStyle xmlns:a="http://schemas.openxmlformats.org/drawingml/2006/main"/>
+          <a:p xmlns:a="http://schemas.openxmlformats.org/drawingml/2006/main">
+            <a:pPr algn="l">
+              <a:defRPr sz="1800" b="0">
+                <a:solidFill>
+                  <a:srgbClr val="FFFFFF"/>
+                </a:solidFill>
+                <a:latin typeface="Arial"/>
+                <a:ea typeface="Arial"/>
+                <a:cs typeface="Arial"/>
+              </a:defRPr>
+            </a:pPr>
+            <a:r>
+              <a:rPr sz="1800" b="0">
+                <a:solidFill>
+                  <a:srgbClr val="FFFFFF"/>
+                </a:solidFill>
+                <a:latin typeface="Arial"/>
+                <a:ea typeface="Arial"/>
+                <a:cs typeface="Arial"/>
               </a:rPr>
               <a:t>How to work as a code crew</a:t>
             </a:r>
@@ -25883,10 +26219,10 @@
       </p:sp>
       <p:sp>
         <p:nvSpPr>
-          <p:cNvPr id="313" name="slide-heading-19">
-            <a:extLst xmlns:a="http://schemas.openxmlformats.org/drawingml/2006/main">
-              <a:ext uri="{FF2B5EF4-FFF2-40B4-BE49-F238E27FC236}">
-                <a16:creationId xmlns:a16="http://schemas.microsoft.com/office/drawing/2014/main" id="{B4DFFC3B-38DB-4F89-B81C-9AD2BCCEEDE4}"/>
+          <p:cNvPr id="313" name="slide-heading-marker-19">
+            <a:extLst xmlns:a="http://schemas.openxmlformats.org/drawingml/2006/main">
+              <a:ext uri="{FF2B5EF4-FFF2-40B4-BE49-F238E27FC236}">
+                <a16:creationId xmlns:a16="http://schemas.microsoft.com/office/drawing/2014/main" id="{F56B54AD-AC38-4C09-9E91-D1E5CB005254}"/>
               </a:ext>
             </a:extLst>
           </p:cNvPr>
@@ -25897,8 +26233,8 @@
         </p:nvSpPr>
         <p:spPr>
           <a:xfrm xmlns:a="http://schemas.openxmlformats.org/drawingml/2006/main">
-            <a:off x="552450" y="219075"/>
-            <a:ext cx="6858000" cy="266700"/>
+            <a:off x="742950" y="447675"/>
+            <a:ext cx="476250" cy="323850"/>
           </a:xfrm>
           <a:prstGeom xmlns:a="http://schemas.openxmlformats.org/drawingml/2006/main" prst="rect">
             <a:avLst/>
@@ -25914,9 +26250,9 @@
           <a:lstStyle xmlns:a="http://schemas.openxmlformats.org/drawingml/2006/main"/>
           <a:p xmlns:a="http://schemas.openxmlformats.org/drawingml/2006/main">
             <a:pPr algn="l">
-              <a:defRPr sz="1350" b="1">
+              <a:defRPr sz="1950" b="1">
                 <a:solidFill>
-                  <a:srgbClr val="FFFFFF"/>
+                  <a:srgbClr val="FFDB5D"/>
                 </a:solidFill>
                 <a:latin typeface="Source Code Pro"/>
                 <a:ea typeface="Source Code Pro"/>
@@ -25924,13 +26260,69 @@
               </a:defRPr>
             </a:pPr>
             <a:r>
-              <a:rPr sz="1350" b="1">
+              <a:rPr sz="1950" b="1">
                 <a:solidFill>
-                  <a:srgbClr val="FFFFFF"/>
+                  <a:srgbClr val="FFDB5D"/>
                 </a:solidFill>
                 <a:latin typeface="Source Code Pro"/>
                 <a:ea typeface="Source Code Pro"/>
                 <a:cs typeface="Source Code Pro"/>
+              </a:rPr>
+              <a:t>&lt;/</a:t>
+            </a:r>
+          </a:p>
+        </p:txBody>
+      </p:sp>
+      <p:sp>
+        <p:nvSpPr>
+          <p:cNvPr id="314" name="slide-heading-text-19">
+            <a:extLst xmlns:a="http://schemas.openxmlformats.org/drawingml/2006/main">
+              <a:ext uri="{FF2B5EF4-FFF2-40B4-BE49-F238E27FC236}">
+                <a16:creationId xmlns:a16="http://schemas.microsoft.com/office/drawing/2014/main" id="{BEE061BA-D36C-48C1-9B9A-1C904F65885B}"/>
+              </a:ext>
+            </a:extLst>
+          </p:cNvPr>
+          <p:cNvSpPr>
+            <a:spLocks xmlns:a="http://schemas.openxmlformats.org/drawingml/2006/main" noGrp="1"/>
+          </p:cNvSpPr>
+          <p:nvPr/>
+        </p:nvSpPr>
+        <p:spPr>
+          <a:xfrm xmlns:a="http://schemas.openxmlformats.org/drawingml/2006/main">
+            <a:off x="1152525" y="428625"/>
+            <a:ext cx="5619750" cy="361950"/>
+          </a:xfrm>
+          <a:prstGeom xmlns:a="http://schemas.openxmlformats.org/drawingml/2006/main" prst="rect">
+            <a:avLst/>
+          </a:prstGeom>
+          <a:noFill xmlns:a="http://schemas.openxmlformats.org/drawingml/2006/main"/>
+          <a:ln xmlns:a="http://schemas.openxmlformats.org/drawingml/2006/main" w="0">
+            <a:noFill/>
+            <a:prstDash val="solid"/>
+          </a:ln>
+        </p:spPr>
+        <p:txBody>
+          <a:bodyPr xmlns:a="http://schemas.openxmlformats.org/drawingml/2006/main"/>
+          <a:lstStyle xmlns:a="http://schemas.openxmlformats.org/drawingml/2006/main"/>
+          <a:p xmlns:a="http://schemas.openxmlformats.org/drawingml/2006/main">
+            <a:pPr algn="l">
+              <a:defRPr sz="1800" b="0">
+                <a:solidFill>
+                  <a:srgbClr val="FFFFFF"/>
+                </a:solidFill>
+                <a:latin typeface="Arial"/>
+                <a:ea typeface="Arial"/>
+                <a:cs typeface="Arial"/>
+              </a:defRPr>
+            </a:pPr>
+            <a:r>
+              <a:rPr sz="1800" b="0">
+                <a:solidFill>
+                  <a:srgbClr val="FFFFFF"/>
+                </a:solidFill>
+                <a:latin typeface="Arial"/>
+                <a:ea typeface="Arial"/>
+                <a:cs typeface="Arial"/>
               </a:rPr>
               <a:t>Code.org Music Lab</a:t>
             </a:r>
@@ -26378,7 +26770,7 @@
           <p:nvPr/>
         </p:nvPicPr>
         <p:blipFill>
-          <a:blip xmlns:r="http://schemas.openxmlformats.org/officeDocument/2006/relationships" xmlns:a="http://schemas.openxmlformats.org/drawingml/2006/main" r:embed="R96d59a3c51fb40f4">
+          <a:blip xmlns:r="http://schemas.openxmlformats.org/officeDocument/2006/relationships" xmlns:a="http://schemas.openxmlformats.org/drawingml/2006/main" r:embed="R01a281b9a14a4469">
             <a:alphaModFix/>
           </a:blip>
           <a:stretch xmlns:a="http://schemas.openxmlformats.org/drawingml/2006/main">
@@ -26943,10 +27335,10 @@
       </p:sp>
       <p:sp>
         <p:nvSpPr>
-          <p:cNvPr id="313" name="slide-heading-20">
-            <a:extLst xmlns:a="http://schemas.openxmlformats.org/drawingml/2006/main">
-              <a:ext uri="{FF2B5EF4-FFF2-40B4-BE49-F238E27FC236}">
-                <a16:creationId xmlns:a16="http://schemas.microsoft.com/office/drawing/2014/main" id="{C5439BF0-29BD-4E5A-9CA0-F03254D0EA24}"/>
+          <p:cNvPr id="313" name="slide-heading-marker-20">
+            <a:extLst xmlns:a="http://schemas.openxmlformats.org/drawingml/2006/main">
+              <a:ext uri="{FF2B5EF4-FFF2-40B4-BE49-F238E27FC236}">
+                <a16:creationId xmlns:a16="http://schemas.microsoft.com/office/drawing/2014/main" id="{45868136-9554-4792-BEFF-67B1A93DE446}"/>
               </a:ext>
             </a:extLst>
           </p:cNvPr>
@@ -26957,8 +27349,8 @@
         </p:nvSpPr>
         <p:spPr>
           <a:xfrm xmlns:a="http://schemas.openxmlformats.org/drawingml/2006/main">
-            <a:off x="552450" y="219075"/>
-            <a:ext cx="6858000" cy="266700"/>
+            <a:off x="742950" y="447675"/>
+            <a:ext cx="476250" cy="323850"/>
           </a:xfrm>
           <a:prstGeom xmlns:a="http://schemas.openxmlformats.org/drawingml/2006/main" prst="rect">
             <a:avLst/>
@@ -26974,9 +27366,9 @@
           <a:lstStyle xmlns:a="http://schemas.openxmlformats.org/drawingml/2006/main"/>
           <a:p xmlns:a="http://schemas.openxmlformats.org/drawingml/2006/main">
             <a:pPr algn="l">
-              <a:defRPr sz="1350" b="1">
+              <a:defRPr sz="1950" b="1">
                 <a:solidFill>
-                  <a:srgbClr val="FFFFFF"/>
+                  <a:srgbClr val="FFDB5D"/>
                 </a:solidFill>
                 <a:latin typeface="Source Code Pro"/>
                 <a:ea typeface="Source Code Pro"/>
@@ -26984,13 +27376,69 @@
               </a:defRPr>
             </a:pPr>
             <a:r>
-              <a:rPr sz="1350" b="1">
+              <a:rPr sz="1950" b="1">
                 <a:solidFill>
-                  <a:srgbClr val="FFFFFF"/>
+                  <a:srgbClr val="FFDB5D"/>
                 </a:solidFill>
                 <a:latin typeface="Source Code Pro"/>
                 <a:ea typeface="Source Code Pro"/>
                 <a:cs typeface="Source Code Pro"/>
+              </a:rPr>
+              <a:t>&lt;/</a:t>
+            </a:r>
+          </a:p>
+        </p:txBody>
+      </p:sp>
+      <p:sp>
+        <p:nvSpPr>
+          <p:cNvPr id="314" name="slide-heading-text-20">
+            <a:extLst xmlns:a="http://schemas.openxmlformats.org/drawingml/2006/main">
+              <a:ext uri="{FF2B5EF4-FFF2-40B4-BE49-F238E27FC236}">
+                <a16:creationId xmlns:a16="http://schemas.microsoft.com/office/drawing/2014/main" id="{E354BC7C-CD89-4A48-A4B0-863C4553A9BC}"/>
+              </a:ext>
+            </a:extLst>
+          </p:cNvPr>
+          <p:cNvSpPr>
+            <a:spLocks xmlns:a="http://schemas.openxmlformats.org/drawingml/2006/main" noGrp="1"/>
+          </p:cNvSpPr>
+          <p:nvPr/>
+        </p:nvSpPr>
+        <p:spPr>
+          <a:xfrm xmlns:a="http://schemas.openxmlformats.org/drawingml/2006/main">
+            <a:off x="1152525" y="428625"/>
+            <a:ext cx="5619750" cy="361950"/>
+          </a:xfrm>
+          <a:prstGeom xmlns:a="http://schemas.openxmlformats.org/drawingml/2006/main" prst="rect">
+            <a:avLst/>
+          </a:prstGeom>
+          <a:noFill xmlns:a="http://schemas.openxmlformats.org/drawingml/2006/main"/>
+          <a:ln xmlns:a="http://schemas.openxmlformats.org/drawingml/2006/main" w="0">
+            <a:noFill/>
+            <a:prstDash val="solid"/>
+          </a:ln>
+        </p:spPr>
+        <p:txBody>
+          <a:bodyPr xmlns:a="http://schemas.openxmlformats.org/drawingml/2006/main"/>
+          <a:lstStyle xmlns:a="http://schemas.openxmlformats.org/drawingml/2006/main"/>
+          <a:p xmlns:a="http://schemas.openxmlformats.org/drawingml/2006/main">
+            <a:pPr algn="l">
+              <a:defRPr sz="1800" b="0">
+                <a:solidFill>
+                  <a:srgbClr val="FFFFFF"/>
+                </a:solidFill>
+                <a:latin typeface="Arial"/>
+                <a:ea typeface="Arial"/>
+                <a:cs typeface="Arial"/>
+              </a:defRPr>
+            </a:pPr>
+            <a:r>
+              <a:rPr sz="1800" b="0">
+                <a:solidFill>
+                  <a:srgbClr val="FFFFFF"/>
+                </a:solidFill>
+                <a:latin typeface="Arial"/>
+                <a:ea typeface="Arial"/>
+                <a:cs typeface="Arial"/>
               </a:rPr>
               <a:t>Programming words we will use</a:t>
             </a:r>
@@ -27542,10 +27990,10 @@
       </p:sp>
       <p:sp>
         <p:nvSpPr>
-          <p:cNvPr id="313" name="slide-heading-21">
-            <a:extLst xmlns:a="http://schemas.openxmlformats.org/drawingml/2006/main">
-              <a:ext uri="{FF2B5EF4-FFF2-40B4-BE49-F238E27FC236}">
-                <a16:creationId xmlns:a16="http://schemas.microsoft.com/office/drawing/2014/main" id="{C7C205A3-D42F-435E-AA4F-28E016136596}"/>
+          <p:cNvPr id="313" name="slide-heading-marker-21">
+            <a:extLst xmlns:a="http://schemas.openxmlformats.org/drawingml/2006/main">
+              <a:ext uri="{FF2B5EF4-FFF2-40B4-BE49-F238E27FC236}">
+                <a16:creationId xmlns:a16="http://schemas.microsoft.com/office/drawing/2014/main" id="{538DD39C-610E-410F-AFD9-AB9C2149CD18}"/>
               </a:ext>
             </a:extLst>
           </p:cNvPr>
@@ -27556,8 +28004,8 @@
         </p:nvSpPr>
         <p:spPr>
           <a:xfrm xmlns:a="http://schemas.openxmlformats.org/drawingml/2006/main">
-            <a:off x="552450" y="219075"/>
-            <a:ext cx="6858000" cy="266700"/>
+            <a:off x="742950" y="447675"/>
+            <a:ext cx="476250" cy="323850"/>
           </a:xfrm>
           <a:prstGeom xmlns:a="http://schemas.openxmlformats.org/drawingml/2006/main" prst="rect">
             <a:avLst/>
@@ -27573,9 +28021,9 @@
           <a:lstStyle xmlns:a="http://schemas.openxmlformats.org/drawingml/2006/main"/>
           <a:p xmlns:a="http://schemas.openxmlformats.org/drawingml/2006/main">
             <a:pPr algn="l">
-              <a:defRPr sz="1350" b="1">
+              <a:defRPr sz="1950" b="1">
                 <a:solidFill>
-                  <a:srgbClr val="FFFFFF"/>
+                  <a:srgbClr val="FFDB5D"/>
                 </a:solidFill>
                 <a:latin typeface="Source Code Pro"/>
                 <a:ea typeface="Source Code Pro"/>
@@ -27583,13 +28031,69 @@
               </a:defRPr>
             </a:pPr>
             <a:r>
-              <a:rPr sz="1350" b="1">
+              <a:rPr sz="1950" b="1">
                 <a:solidFill>
-                  <a:srgbClr val="FFFFFF"/>
+                  <a:srgbClr val="FFDB5D"/>
                 </a:solidFill>
                 <a:latin typeface="Source Code Pro"/>
                 <a:ea typeface="Source Code Pro"/>
                 <a:cs typeface="Source Code Pro"/>
+              </a:rPr>
+              <a:t>&lt;/</a:t>
+            </a:r>
+          </a:p>
+        </p:txBody>
+      </p:sp>
+      <p:sp>
+        <p:nvSpPr>
+          <p:cNvPr id="314" name="slide-heading-text-21">
+            <a:extLst xmlns:a="http://schemas.openxmlformats.org/drawingml/2006/main">
+              <a:ext uri="{FF2B5EF4-FFF2-40B4-BE49-F238E27FC236}">
+                <a16:creationId xmlns:a16="http://schemas.microsoft.com/office/drawing/2014/main" id="{F41FAAE0-8387-417B-9A51-260235602C2B}"/>
+              </a:ext>
+            </a:extLst>
+          </p:cNvPr>
+          <p:cNvSpPr>
+            <a:spLocks xmlns:a="http://schemas.openxmlformats.org/drawingml/2006/main" noGrp="1"/>
+          </p:cNvSpPr>
+          <p:nvPr/>
+        </p:nvSpPr>
+        <p:spPr>
+          <a:xfrm xmlns:a="http://schemas.openxmlformats.org/drawingml/2006/main">
+            <a:off x="1152525" y="428625"/>
+            <a:ext cx="5619750" cy="361950"/>
+          </a:xfrm>
+          <a:prstGeom xmlns:a="http://schemas.openxmlformats.org/drawingml/2006/main" prst="rect">
+            <a:avLst/>
+          </a:prstGeom>
+          <a:noFill xmlns:a="http://schemas.openxmlformats.org/drawingml/2006/main"/>
+          <a:ln xmlns:a="http://schemas.openxmlformats.org/drawingml/2006/main" w="0">
+            <a:noFill/>
+            <a:prstDash val="solid"/>
+          </a:ln>
+        </p:spPr>
+        <p:txBody>
+          <a:bodyPr xmlns:a="http://schemas.openxmlformats.org/drawingml/2006/main"/>
+          <a:lstStyle xmlns:a="http://schemas.openxmlformats.org/drawingml/2006/main"/>
+          <a:p xmlns:a="http://schemas.openxmlformats.org/drawingml/2006/main">
+            <a:pPr algn="l">
+              <a:defRPr sz="1800" b="0">
+                <a:solidFill>
+                  <a:srgbClr val="FFFFFF"/>
+                </a:solidFill>
+                <a:latin typeface="Arial"/>
+                <a:ea typeface="Arial"/>
+                <a:cs typeface="Arial"/>
+              </a:defRPr>
+            </a:pPr>
+            <a:r>
+              <a:rPr sz="1800" b="0">
+                <a:solidFill>
+                  <a:srgbClr val="FFFFFF"/>
+                </a:solidFill>
+                <a:latin typeface="Arial"/>
+                <a:ea typeface="Arial"/>
+                <a:cs typeface="Arial"/>
               </a:rPr>
               <a:t>AI can help, but you decide</a:t>
             </a:r>
@@ -28141,10 +28645,10 @@
       </p:sp>
       <p:sp>
         <p:nvSpPr>
-          <p:cNvPr id="313" name="slide-heading-22">
-            <a:extLst xmlns:a="http://schemas.openxmlformats.org/drawingml/2006/main">
-              <a:ext uri="{FF2B5EF4-FFF2-40B4-BE49-F238E27FC236}">
-                <a16:creationId xmlns:a16="http://schemas.microsoft.com/office/drawing/2014/main" id="{7ACF9CCC-EB63-42EC-8B0B-7C8D856395B8}"/>
+          <p:cNvPr id="313" name="slide-heading-marker-22">
+            <a:extLst xmlns:a="http://schemas.openxmlformats.org/drawingml/2006/main">
+              <a:ext uri="{FF2B5EF4-FFF2-40B4-BE49-F238E27FC236}">
+                <a16:creationId xmlns:a16="http://schemas.microsoft.com/office/drawing/2014/main" id="{F6C2D193-E68A-4077-9735-13C38DF15C7D}"/>
               </a:ext>
             </a:extLst>
           </p:cNvPr>
@@ -28155,8 +28659,8 @@
         </p:nvSpPr>
         <p:spPr>
           <a:xfrm xmlns:a="http://schemas.openxmlformats.org/drawingml/2006/main">
-            <a:off x="552450" y="219075"/>
-            <a:ext cx="6858000" cy="266700"/>
+            <a:off x="742950" y="447675"/>
+            <a:ext cx="476250" cy="323850"/>
           </a:xfrm>
           <a:prstGeom xmlns:a="http://schemas.openxmlformats.org/drawingml/2006/main" prst="rect">
             <a:avLst/>
@@ -28172,9 +28676,9 @@
           <a:lstStyle xmlns:a="http://schemas.openxmlformats.org/drawingml/2006/main"/>
           <a:p xmlns:a="http://schemas.openxmlformats.org/drawingml/2006/main">
             <a:pPr algn="l">
-              <a:defRPr sz="1350" b="1">
+              <a:defRPr sz="1950" b="1">
                 <a:solidFill>
-                  <a:srgbClr val="FFFFFF"/>
+                  <a:srgbClr val="FFDB5D"/>
                 </a:solidFill>
                 <a:latin typeface="Source Code Pro"/>
                 <a:ea typeface="Source Code Pro"/>
@@ -28182,13 +28686,69 @@
               </a:defRPr>
             </a:pPr>
             <a:r>
-              <a:rPr sz="1350" b="1">
+              <a:rPr sz="1950" b="1">
                 <a:solidFill>
-                  <a:srgbClr val="FFFFFF"/>
+                  <a:srgbClr val="FFDB5D"/>
                 </a:solidFill>
                 <a:latin typeface="Source Code Pro"/>
                 <a:ea typeface="Source Code Pro"/>
                 <a:cs typeface="Source Code Pro"/>
+              </a:rPr>
+              <a:t>&lt;/</a:t>
+            </a:r>
+          </a:p>
+        </p:txBody>
+      </p:sp>
+      <p:sp>
+        <p:nvSpPr>
+          <p:cNvPr id="314" name="slide-heading-text-22">
+            <a:extLst xmlns:a="http://schemas.openxmlformats.org/drawingml/2006/main">
+              <a:ext uri="{FF2B5EF4-FFF2-40B4-BE49-F238E27FC236}">
+                <a16:creationId xmlns:a16="http://schemas.microsoft.com/office/drawing/2014/main" id="{5B04327E-6B3F-46C1-9339-73C7435C5DF0}"/>
+              </a:ext>
+            </a:extLst>
+          </p:cNvPr>
+          <p:cNvSpPr>
+            <a:spLocks xmlns:a="http://schemas.openxmlformats.org/drawingml/2006/main" noGrp="1"/>
+          </p:cNvSpPr>
+          <p:nvPr/>
+        </p:nvSpPr>
+        <p:spPr>
+          <a:xfrm xmlns:a="http://schemas.openxmlformats.org/drawingml/2006/main">
+            <a:off x="1152525" y="428625"/>
+            <a:ext cx="5619750" cy="361950"/>
+          </a:xfrm>
+          <a:prstGeom xmlns:a="http://schemas.openxmlformats.org/drawingml/2006/main" prst="rect">
+            <a:avLst/>
+          </a:prstGeom>
+          <a:noFill xmlns:a="http://schemas.openxmlformats.org/drawingml/2006/main"/>
+          <a:ln xmlns:a="http://schemas.openxmlformats.org/drawingml/2006/main" w="0">
+            <a:noFill/>
+            <a:prstDash val="solid"/>
+          </a:ln>
+        </p:spPr>
+        <p:txBody>
+          <a:bodyPr xmlns:a="http://schemas.openxmlformats.org/drawingml/2006/main"/>
+          <a:lstStyle xmlns:a="http://schemas.openxmlformats.org/drawingml/2006/main"/>
+          <a:p xmlns:a="http://schemas.openxmlformats.org/drawingml/2006/main">
+            <a:pPr algn="l">
+              <a:defRPr sz="1800" b="0">
+                <a:solidFill>
+                  <a:srgbClr val="FFFFFF"/>
+                </a:solidFill>
+                <a:latin typeface="Arial"/>
+                <a:ea typeface="Arial"/>
+                <a:cs typeface="Arial"/>
+              </a:defRPr>
+            </a:pPr>
+            <a:r>
+              <a:rPr sz="1800" b="0">
+                <a:solidFill>
+                  <a:srgbClr val="FFFFFF"/>
+                </a:solidFill>
+                <a:latin typeface="Arial"/>
+                <a:ea typeface="Arial"/>
+                <a:cs typeface="Arial"/>
               </a:rPr>
               <a:t>Share what your crew made</a:t>
             </a:r>
@@ -29476,10 +30036,10 @@
       </p:sp>
       <p:sp>
         <p:nvSpPr>
-          <p:cNvPr id="313" name="slide-heading-24">
-            <a:extLst xmlns:a="http://schemas.openxmlformats.org/drawingml/2006/main">
-              <a:ext uri="{FF2B5EF4-FFF2-40B4-BE49-F238E27FC236}">
-                <a16:creationId xmlns:a16="http://schemas.microsoft.com/office/drawing/2014/main" id="{10A7C660-D469-4279-8BF0-C97A112E2F74}"/>
+          <p:cNvPr id="313" name="slide-heading-marker-24">
+            <a:extLst xmlns:a="http://schemas.openxmlformats.org/drawingml/2006/main">
+              <a:ext uri="{FF2B5EF4-FFF2-40B4-BE49-F238E27FC236}">
+                <a16:creationId xmlns:a16="http://schemas.microsoft.com/office/drawing/2014/main" id="{3B558470-BCEC-4DFB-81AE-A82ED8F6A4C5}"/>
               </a:ext>
             </a:extLst>
           </p:cNvPr>
@@ -29490,8 +30050,8 @@
         </p:nvSpPr>
         <p:spPr>
           <a:xfrm xmlns:a="http://schemas.openxmlformats.org/drawingml/2006/main">
-            <a:off x="552450" y="219075"/>
-            <a:ext cx="6858000" cy="266700"/>
+            <a:off x="742950" y="447675"/>
+            <a:ext cx="476250" cy="323850"/>
           </a:xfrm>
           <a:prstGeom xmlns:a="http://schemas.openxmlformats.org/drawingml/2006/main" prst="rect">
             <a:avLst/>
@@ -29507,9 +30067,9 @@
           <a:lstStyle xmlns:a="http://schemas.openxmlformats.org/drawingml/2006/main"/>
           <a:p xmlns:a="http://schemas.openxmlformats.org/drawingml/2006/main">
             <a:pPr algn="l">
-              <a:defRPr sz="1350" b="1">
+              <a:defRPr sz="1950" b="1">
                 <a:solidFill>
-                  <a:srgbClr val="FFFFFF"/>
+                  <a:srgbClr val="FFDB5D"/>
                 </a:solidFill>
                 <a:latin typeface="Source Code Pro"/>
                 <a:ea typeface="Source Code Pro"/>
@@ -29517,13 +30077,69 @@
               </a:defRPr>
             </a:pPr>
             <a:r>
-              <a:rPr sz="1350" b="1">
+              <a:rPr sz="1950" b="1">
                 <a:solidFill>
-                  <a:srgbClr val="FFFFFF"/>
+                  <a:srgbClr val="FFDB5D"/>
                 </a:solidFill>
                 <a:latin typeface="Source Code Pro"/>
                 <a:ea typeface="Source Code Pro"/>
                 <a:cs typeface="Source Code Pro"/>
+              </a:rPr>
+              <a:t>&lt;/</a:t>
+            </a:r>
+          </a:p>
+        </p:txBody>
+      </p:sp>
+      <p:sp>
+        <p:nvSpPr>
+          <p:cNvPr id="314" name="slide-heading-text-24">
+            <a:extLst xmlns:a="http://schemas.openxmlformats.org/drawingml/2006/main">
+              <a:ext uri="{FF2B5EF4-FFF2-40B4-BE49-F238E27FC236}">
+                <a16:creationId xmlns:a16="http://schemas.microsoft.com/office/drawing/2014/main" id="{8B23174A-638A-46EC-AD07-1B1BC78D919D}"/>
+              </a:ext>
+            </a:extLst>
+          </p:cNvPr>
+          <p:cNvSpPr>
+            <a:spLocks xmlns:a="http://schemas.openxmlformats.org/drawingml/2006/main" noGrp="1"/>
+          </p:cNvSpPr>
+          <p:nvPr/>
+        </p:nvSpPr>
+        <p:spPr>
+          <a:xfrm xmlns:a="http://schemas.openxmlformats.org/drawingml/2006/main">
+            <a:off x="1152525" y="428625"/>
+            <a:ext cx="5619750" cy="361950"/>
+          </a:xfrm>
+          <a:prstGeom xmlns:a="http://schemas.openxmlformats.org/drawingml/2006/main" prst="rect">
+            <a:avLst/>
+          </a:prstGeom>
+          <a:noFill xmlns:a="http://schemas.openxmlformats.org/drawingml/2006/main"/>
+          <a:ln xmlns:a="http://schemas.openxmlformats.org/drawingml/2006/main" w="0">
+            <a:noFill/>
+            <a:prstDash val="solid"/>
+          </a:ln>
+        </p:spPr>
+        <p:txBody>
+          <a:bodyPr xmlns:a="http://schemas.openxmlformats.org/drawingml/2006/main"/>
+          <a:lstStyle xmlns:a="http://schemas.openxmlformats.org/drawingml/2006/main"/>
+          <a:p xmlns:a="http://schemas.openxmlformats.org/drawingml/2006/main">
+            <a:pPr algn="l">
+              <a:defRPr sz="1800" b="0">
+                <a:solidFill>
+                  <a:srgbClr val="FFFFFF"/>
+                </a:solidFill>
+                <a:latin typeface="Arial"/>
+                <a:ea typeface="Arial"/>
+                <a:cs typeface="Arial"/>
+              </a:defRPr>
+            </a:pPr>
+            <a:r>
+              <a:rPr sz="1800" b="0">
+                <a:solidFill>
+                  <a:srgbClr val="FFFFFF"/>
+                </a:solidFill>
+                <a:latin typeface="Arial"/>
+                <a:ea typeface="Arial"/>
+                <a:cs typeface="Arial"/>
               </a:rPr>
               <a:t>Homework: Music Lab remix</a:t>
             </a:r>
@@ -30075,10 +30691,10 @@
       </p:sp>
       <p:sp>
         <p:nvSpPr>
-          <p:cNvPr id="313" name="slide-heading-25">
-            <a:extLst xmlns:a="http://schemas.openxmlformats.org/drawingml/2006/main">
-              <a:ext uri="{FF2B5EF4-FFF2-40B4-BE49-F238E27FC236}">
-                <a16:creationId xmlns:a16="http://schemas.microsoft.com/office/drawing/2014/main" id="{72E08CB2-5A61-45A9-9E0B-B95914960732}"/>
+          <p:cNvPr id="313" name="slide-heading-marker-25">
+            <a:extLst xmlns:a="http://schemas.openxmlformats.org/drawingml/2006/main">
+              <a:ext uri="{FF2B5EF4-FFF2-40B4-BE49-F238E27FC236}">
+                <a16:creationId xmlns:a16="http://schemas.microsoft.com/office/drawing/2014/main" id="{079E65ED-329B-4E2D-81E6-058ECD3A6287}"/>
               </a:ext>
             </a:extLst>
           </p:cNvPr>
@@ -30089,8 +30705,8 @@
         </p:nvSpPr>
         <p:spPr>
           <a:xfrm xmlns:a="http://schemas.openxmlformats.org/drawingml/2006/main">
-            <a:off x="552450" y="219075"/>
-            <a:ext cx="6858000" cy="266700"/>
+            <a:off x="742950" y="447675"/>
+            <a:ext cx="476250" cy="323850"/>
           </a:xfrm>
           <a:prstGeom xmlns:a="http://schemas.openxmlformats.org/drawingml/2006/main" prst="rect">
             <a:avLst/>
@@ -30106,9 +30722,9 @@
           <a:lstStyle xmlns:a="http://schemas.openxmlformats.org/drawingml/2006/main"/>
           <a:p xmlns:a="http://schemas.openxmlformats.org/drawingml/2006/main">
             <a:pPr algn="l">
-              <a:defRPr sz="1350" b="1">
+              <a:defRPr sz="1950" b="1">
                 <a:solidFill>
-                  <a:srgbClr val="FFFFFF"/>
+                  <a:srgbClr val="FFDB5D"/>
                 </a:solidFill>
                 <a:latin typeface="Source Code Pro"/>
                 <a:ea typeface="Source Code Pro"/>
@@ -30116,13 +30732,69 @@
               </a:defRPr>
             </a:pPr>
             <a:r>
-              <a:rPr sz="1350" b="1">
+              <a:rPr sz="1950" b="1">
                 <a:solidFill>
-                  <a:srgbClr val="FFFFFF"/>
+                  <a:srgbClr val="FFDB5D"/>
                 </a:solidFill>
                 <a:latin typeface="Source Code Pro"/>
                 <a:ea typeface="Source Code Pro"/>
                 <a:cs typeface="Source Code Pro"/>
+              </a:rPr>
+              <a:t>&lt;/</a:t>
+            </a:r>
+          </a:p>
+        </p:txBody>
+      </p:sp>
+      <p:sp>
+        <p:nvSpPr>
+          <p:cNvPr id="314" name="slide-heading-text-25">
+            <a:extLst xmlns:a="http://schemas.openxmlformats.org/drawingml/2006/main">
+              <a:ext uri="{FF2B5EF4-FFF2-40B4-BE49-F238E27FC236}">
+                <a16:creationId xmlns:a16="http://schemas.microsoft.com/office/drawing/2014/main" id="{2D39112E-D020-422B-8364-BD10B744919B}"/>
+              </a:ext>
+            </a:extLst>
+          </p:cNvPr>
+          <p:cNvSpPr>
+            <a:spLocks xmlns:a="http://schemas.openxmlformats.org/drawingml/2006/main" noGrp="1"/>
+          </p:cNvSpPr>
+          <p:nvPr/>
+        </p:nvSpPr>
+        <p:spPr>
+          <a:xfrm xmlns:a="http://schemas.openxmlformats.org/drawingml/2006/main">
+            <a:off x="1152525" y="428625"/>
+            <a:ext cx="5619750" cy="361950"/>
+          </a:xfrm>
+          <a:prstGeom xmlns:a="http://schemas.openxmlformats.org/drawingml/2006/main" prst="rect">
+            <a:avLst/>
+          </a:prstGeom>
+          <a:noFill xmlns:a="http://schemas.openxmlformats.org/drawingml/2006/main"/>
+          <a:ln xmlns:a="http://schemas.openxmlformats.org/drawingml/2006/main" w="0">
+            <a:noFill/>
+            <a:prstDash val="solid"/>
+          </a:ln>
+        </p:spPr>
+        <p:txBody>
+          <a:bodyPr xmlns:a="http://schemas.openxmlformats.org/drawingml/2006/main"/>
+          <a:lstStyle xmlns:a="http://schemas.openxmlformats.org/drawingml/2006/main"/>
+          <a:p xmlns:a="http://schemas.openxmlformats.org/drawingml/2006/main">
+            <a:pPr algn="l">
+              <a:defRPr sz="1800" b="0">
+                <a:solidFill>
+                  <a:srgbClr val="FFFFFF"/>
+                </a:solidFill>
+                <a:latin typeface="Arial"/>
+                <a:ea typeface="Arial"/>
+                <a:cs typeface="Arial"/>
+              </a:defRPr>
+            </a:pPr>
+            <a:r>
+              <a:rPr sz="1800" b="0">
+                <a:solidFill>
+                  <a:srgbClr val="FFFFFF"/>
+                </a:solidFill>
+                <a:latin typeface="Arial"/>
+                <a:ea typeface="Arial"/>
+                <a:cs typeface="Arial"/>
               </a:rPr>
               <a:t>Next week we start TypeScript</a:t>
             </a:r>
@@ -31192,7 +31864,7 @@
           <p:nvPr/>
         </p:nvPicPr>
         <p:blipFill>
-          <a:blip xmlns:r="http://schemas.openxmlformats.org/officeDocument/2006/relationships" xmlns:a="http://schemas.openxmlformats.org/drawingml/2006/main" r:embed="Re20179d6e9c74a8c"/>
+          <a:blip xmlns:r="http://schemas.openxmlformats.org/officeDocument/2006/relationships" xmlns:a="http://schemas.openxmlformats.org/drawingml/2006/main" r:embed="Recfdc9f447464a0d"/>
           <a:stretch xmlns:a="http://schemas.openxmlformats.org/drawingml/2006/main">
             <a:fillRect l="0" t="0" r="0" b="0"/>
           </a:stretch>
@@ -31554,7 +32226,7 @@
           <p:nvPr/>
         </p:nvPicPr>
         <p:blipFill>
-          <a:blip xmlns:r="http://schemas.openxmlformats.org/officeDocument/2006/relationships" xmlns:a="http://schemas.openxmlformats.org/drawingml/2006/main" r:embed="Rde2092cdea9b4126"/>
+          <a:blip xmlns:r="http://schemas.openxmlformats.org/officeDocument/2006/relationships" xmlns:a="http://schemas.openxmlformats.org/drawingml/2006/main" r:embed="R99f16198d822401b"/>
           <a:stretch xmlns:a="http://schemas.openxmlformats.org/drawingml/2006/main">
             <a:fillRect l="0" t="0" r="0" b="0"/>
           </a:stretch>
@@ -31758,7 +32430,7 @@
           <p:nvPr/>
         </p:nvPicPr>
         <p:blipFill>
-          <a:blip xmlns:r="http://schemas.openxmlformats.org/officeDocument/2006/relationships" xmlns:a="http://schemas.openxmlformats.org/drawingml/2006/main" r:embed="R0f2426831e324b49"/>
+          <a:blip xmlns:r="http://schemas.openxmlformats.org/officeDocument/2006/relationships" xmlns:a="http://schemas.openxmlformats.org/drawingml/2006/main" r:embed="R28a3943f73514f90"/>
           <a:stretch xmlns:a="http://schemas.openxmlformats.org/drawingml/2006/main">
             <a:fillRect l="0" t="0" r="0" b="0"/>
           </a:stretch>
@@ -32318,10 +32990,10 @@
       </p:sp>
       <p:sp>
         <p:nvSpPr>
-          <p:cNvPr id="313" name="slide-heading-6">
-            <a:extLst xmlns:a="http://schemas.openxmlformats.org/drawingml/2006/main">
-              <a:ext uri="{FF2B5EF4-FFF2-40B4-BE49-F238E27FC236}">
-                <a16:creationId xmlns:a16="http://schemas.microsoft.com/office/drawing/2014/main" id="{E73CF497-0584-42DA-AFC9-6F53A87DBDF6}"/>
+          <p:cNvPr id="313" name="slide-heading-marker-6">
+            <a:extLst xmlns:a="http://schemas.openxmlformats.org/drawingml/2006/main">
+              <a:ext uri="{FF2B5EF4-FFF2-40B4-BE49-F238E27FC236}">
+                <a16:creationId xmlns:a16="http://schemas.microsoft.com/office/drawing/2014/main" id="{2C098171-21A5-4CC8-BC03-EC51286BE3DD}"/>
               </a:ext>
             </a:extLst>
           </p:cNvPr>
@@ -32332,8 +33004,8 @@
         </p:nvSpPr>
         <p:spPr>
           <a:xfrm xmlns:a="http://schemas.openxmlformats.org/drawingml/2006/main">
-            <a:off x="552450" y="219075"/>
-            <a:ext cx="6858000" cy="266700"/>
+            <a:off x="742950" y="447675"/>
+            <a:ext cx="476250" cy="323850"/>
           </a:xfrm>
           <a:prstGeom xmlns:a="http://schemas.openxmlformats.org/drawingml/2006/main" prst="rect">
             <a:avLst/>
@@ -32349,9 +33021,9 @@
           <a:lstStyle xmlns:a="http://schemas.openxmlformats.org/drawingml/2006/main"/>
           <a:p xmlns:a="http://schemas.openxmlformats.org/drawingml/2006/main">
             <a:pPr algn="l">
-              <a:defRPr sz="1350" b="1">
+              <a:defRPr sz="1950" b="1">
                 <a:solidFill>
-                  <a:srgbClr val="FFFFFF"/>
+                  <a:srgbClr val="FFDB5D"/>
                 </a:solidFill>
                 <a:latin typeface="Source Code Pro"/>
                 <a:ea typeface="Source Code Pro"/>
@@ -32359,13 +33031,69 @@
               </a:defRPr>
             </a:pPr>
             <a:r>
-              <a:rPr sz="1350" b="1">
+              <a:rPr sz="1950" b="1">
                 <a:solidFill>
-                  <a:srgbClr val="FFFFFF"/>
+                  <a:srgbClr val="FFDB5D"/>
                 </a:solidFill>
                 <a:latin typeface="Source Code Pro"/>
                 <a:ea typeface="Source Code Pro"/>
                 <a:cs typeface="Source Code Pro"/>
+              </a:rPr>
+              <a:t>&lt;/</a:t>
+            </a:r>
+          </a:p>
+        </p:txBody>
+      </p:sp>
+      <p:sp>
+        <p:nvSpPr>
+          <p:cNvPr id="314" name="slide-heading-text-6">
+            <a:extLst xmlns:a="http://schemas.openxmlformats.org/drawingml/2006/main">
+              <a:ext uri="{FF2B5EF4-FFF2-40B4-BE49-F238E27FC236}">
+                <a16:creationId xmlns:a16="http://schemas.microsoft.com/office/drawing/2014/main" id="{5479F54C-0325-47A0-9630-F0FCCB742455}"/>
+              </a:ext>
+            </a:extLst>
+          </p:cNvPr>
+          <p:cNvSpPr>
+            <a:spLocks xmlns:a="http://schemas.openxmlformats.org/drawingml/2006/main" noGrp="1"/>
+          </p:cNvSpPr>
+          <p:nvPr/>
+        </p:nvSpPr>
+        <p:spPr>
+          <a:xfrm xmlns:a="http://schemas.openxmlformats.org/drawingml/2006/main">
+            <a:off x="1152525" y="428625"/>
+            <a:ext cx="5619750" cy="361950"/>
+          </a:xfrm>
+          <a:prstGeom xmlns:a="http://schemas.openxmlformats.org/drawingml/2006/main" prst="rect">
+            <a:avLst/>
+          </a:prstGeom>
+          <a:noFill xmlns:a="http://schemas.openxmlformats.org/drawingml/2006/main"/>
+          <a:ln xmlns:a="http://schemas.openxmlformats.org/drawingml/2006/main" w="0">
+            <a:noFill/>
+            <a:prstDash val="solid"/>
+          </a:ln>
+        </p:spPr>
+        <p:txBody>
+          <a:bodyPr xmlns:a="http://schemas.openxmlformats.org/drawingml/2006/main"/>
+          <a:lstStyle xmlns:a="http://schemas.openxmlformats.org/drawingml/2006/main"/>
+          <a:p xmlns:a="http://schemas.openxmlformats.org/drawingml/2006/main">
+            <a:pPr algn="l">
+              <a:defRPr sz="1800" b="0">
+                <a:solidFill>
+                  <a:srgbClr val="FFFFFF"/>
+                </a:solidFill>
+                <a:latin typeface="Arial"/>
+                <a:ea typeface="Arial"/>
+                <a:cs typeface="Arial"/>
+              </a:defRPr>
+            </a:pPr>
+            <a:r>
+              <a:rPr sz="1800" b="0">
+                <a:solidFill>
+                  <a:srgbClr val="FFFFFF"/>
+                </a:solidFill>
+                <a:latin typeface="Arial"/>
+                <a:ea typeface="Arial"/>
+                <a:cs typeface="Arial"/>
               </a:rPr>
               <a:t>Today's mission</a:t>
             </a:r>
@@ -32917,10 +33645,10 @@
       </p:sp>
       <p:sp>
         <p:nvSpPr>
-          <p:cNvPr id="313" name="slide-heading-7">
-            <a:extLst xmlns:a="http://schemas.openxmlformats.org/drawingml/2006/main">
-              <a:ext uri="{FF2B5EF4-FFF2-40B4-BE49-F238E27FC236}">
-                <a16:creationId xmlns:a16="http://schemas.microsoft.com/office/drawing/2014/main" id="{0C27150C-6CF9-4E45-86A8-40688D407385}"/>
+          <p:cNvPr id="313" name="slide-heading-marker-7">
+            <a:extLst xmlns:a="http://schemas.openxmlformats.org/drawingml/2006/main">
+              <a:ext uri="{FF2B5EF4-FFF2-40B4-BE49-F238E27FC236}">
+                <a16:creationId xmlns:a16="http://schemas.microsoft.com/office/drawing/2014/main" id="{31E9FE38-047B-4F43-B15D-E811F696848C}"/>
               </a:ext>
             </a:extLst>
           </p:cNvPr>
@@ -32931,8 +33659,8 @@
         </p:nvSpPr>
         <p:spPr>
           <a:xfrm xmlns:a="http://schemas.openxmlformats.org/drawingml/2006/main">
-            <a:off x="552450" y="219075"/>
-            <a:ext cx="6858000" cy="266700"/>
+            <a:off x="742950" y="447675"/>
+            <a:ext cx="476250" cy="323850"/>
           </a:xfrm>
           <a:prstGeom xmlns:a="http://schemas.openxmlformats.org/drawingml/2006/main" prst="rect">
             <a:avLst/>
@@ -32948,9 +33676,9 @@
           <a:lstStyle xmlns:a="http://schemas.openxmlformats.org/drawingml/2006/main"/>
           <a:p xmlns:a="http://schemas.openxmlformats.org/drawingml/2006/main">
             <a:pPr algn="l">
-              <a:defRPr sz="1350" b="1">
+              <a:defRPr sz="1950" b="1">
                 <a:solidFill>
-                  <a:srgbClr val="FFFFFF"/>
+                  <a:srgbClr val="FFDB5D"/>
                 </a:solidFill>
                 <a:latin typeface="Source Code Pro"/>
                 <a:ea typeface="Source Code Pro"/>
@@ -32958,13 +33686,69 @@
               </a:defRPr>
             </a:pPr>
             <a:r>
-              <a:rPr sz="1350" b="1">
+              <a:rPr sz="1950" b="1">
                 <a:solidFill>
-                  <a:srgbClr val="FFFFFF"/>
+                  <a:srgbClr val="FFDB5D"/>
                 </a:solidFill>
                 <a:latin typeface="Source Code Pro"/>
                 <a:ea typeface="Source Code Pro"/>
                 <a:cs typeface="Source Code Pro"/>
+              </a:rPr>
+              <a:t>&lt;/</a:t>
+            </a:r>
+          </a:p>
+        </p:txBody>
+      </p:sp>
+      <p:sp>
+        <p:nvSpPr>
+          <p:cNvPr id="314" name="slide-heading-text-7">
+            <a:extLst xmlns:a="http://schemas.openxmlformats.org/drawingml/2006/main">
+              <a:ext uri="{FF2B5EF4-FFF2-40B4-BE49-F238E27FC236}">
+                <a16:creationId xmlns:a16="http://schemas.microsoft.com/office/drawing/2014/main" id="{A5C51008-35EA-4C2F-893C-55B209672C0D}"/>
+              </a:ext>
+            </a:extLst>
+          </p:cNvPr>
+          <p:cNvSpPr>
+            <a:spLocks xmlns:a="http://schemas.openxmlformats.org/drawingml/2006/main" noGrp="1"/>
+          </p:cNvSpPr>
+          <p:nvPr/>
+        </p:nvSpPr>
+        <p:spPr>
+          <a:xfrm xmlns:a="http://schemas.openxmlformats.org/drawingml/2006/main">
+            <a:off x="1152525" y="428625"/>
+            <a:ext cx="5619750" cy="361950"/>
+          </a:xfrm>
+          <a:prstGeom xmlns:a="http://schemas.openxmlformats.org/drawingml/2006/main" prst="rect">
+            <a:avLst/>
+          </a:prstGeom>
+          <a:noFill xmlns:a="http://schemas.openxmlformats.org/drawingml/2006/main"/>
+          <a:ln xmlns:a="http://schemas.openxmlformats.org/drawingml/2006/main" w="0">
+            <a:noFill/>
+            <a:prstDash val="solid"/>
+          </a:ln>
+        </p:spPr>
+        <p:txBody>
+          <a:bodyPr xmlns:a="http://schemas.openxmlformats.org/drawingml/2006/main"/>
+          <a:lstStyle xmlns:a="http://schemas.openxmlformats.org/drawingml/2006/main"/>
+          <a:p xmlns:a="http://schemas.openxmlformats.org/drawingml/2006/main">
+            <a:pPr algn="l">
+              <a:defRPr sz="1800" b="0">
+                <a:solidFill>
+                  <a:srgbClr val="FFFFFF"/>
+                </a:solidFill>
+                <a:latin typeface="Arial"/>
+                <a:ea typeface="Arial"/>
+                <a:cs typeface="Arial"/>
+              </a:defRPr>
+            </a:pPr>
+            <a:r>
+              <a:rPr sz="1800" b="0">
+                <a:solidFill>
+                  <a:srgbClr val="FFFFFF"/>
+                </a:solidFill>
+                <a:latin typeface="Arial"/>
+                <a:ea typeface="Arial"/>
+                <a:cs typeface="Arial"/>
               </a:rPr>
               <a:t>Introduce yourself</a:t>
             </a:r>
@@ -33516,10 +34300,10 @@
       </p:sp>
       <p:sp>
         <p:nvSpPr>
-          <p:cNvPr id="313" name="slide-heading-8">
-            <a:extLst xmlns:a="http://schemas.openxmlformats.org/drawingml/2006/main">
-              <a:ext uri="{FF2B5EF4-FFF2-40B4-BE49-F238E27FC236}">
-                <a16:creationId xmlns:a16="http://schemas.microsoft.com/office/drawing/2014/main" id="{42A63C4E-0D5B-4E2F-9924-0968778D40A2}"/>
+          <p:cNvPr id="313" name="slide-heading-marker-8">
+            <a:extLst xmlns:a="http://schemas.openxmlformats.org/drawingml/2006/main">
+              <a:ext uri="{FF2B5EF4-FFF2-40B4-BE49-F238E27FC236}">
+                <a16:creationId xmlns:a16="http://schemas.microsoft.com/office/drawing/2014/main" id="{3A8C6A94-A94C-44E1-ADDF-B4561B404724}"/>
               </a:ext>
             </a:extLst>
           </p:cNvPr>
@@ -33530,8 +34314,8 @@
         </p:nvSpPr>
         <p:spPr>
           <a:xfrm xmlns:a="http://schemas.openxmlformats.org/drawingml/2006/main">
-            <a:off x="552450" y="219075"/>
-            <a:ext cx="6858000" cy="266700"/>
+            <a:off x="742950" y="447675"/>
+            <a:ext cx="476250" cy="323850"/>
           </a:xfrm>
           <a:prstGeom xmlns:a="http://schemas.openxmlformats.org/drawingml/2006/main" prst="rect">
             <a:avLst/>
@@ -33547,9 +34331,9 @@
           <a:lstStyle xmlns:a="http://schemas.openxmlformats.org/drawingml/2006/main"/>
           <a:p xmlns:a="http://schemas.openxmlformats.org/drawingml/2006/main">
             <a:pPr algn="l">
-              <a:defRPr sz="1350" b="1">
+              <a:defRPr sz="1950" b="1">
                 <a:solidFill>
-                  <a:srgbClr val="FFFFFF"/>
+                  <a:srgbClr val="FFDB5D"/>
                 </a:solidFill>
                 <a:latin typeface="Source Code Pro"/>
                 <a:ea typeface="Source Code Pro"/>
@@ -33557,13 +34341,69 @@
               </a:defRPr>
             </a:pPr>
             <a:r>
-              <a:rPr sz="1350" b="1">
+              <a:rPr sz="1950" b="1">
                 <a:solidFill>
-                  <a:srgbClr val="FFFFFF"/>
+                  <a:srgbClr val="FFDB5D"/>
                 </a:solidFill>
                 <a:latin typeface="Source Code Pro"/>
                 <a:ea typeface="Source Code Pro"/>
                 <a:cs typeface="Source Code Pro"/>
+              </a:rPr>
+              <a:t>&lt;/</a:t>
+            </a:r>
+          </a:p>
+        </p:txBody>
+      </p:sp>
+      <p:sp>
+        <p:nvSpPr>
+          <p:cNvPr id="314" name="slide-heading-text-8">
+            <a:extLst xmlns:a="http://schemas.openxmlformats.org/drawingml/2006/main">
+              <a:ext uri="{FF2B5EF4-FFF2-40B4-BE49-F238E27FC236}">
+                <a16:creationId xmlns:a16="http://schemas.microsoft.com/office/drawing/2014/main" id="{D8FEFC39-CF12-4D35-9E56-0675E79EBED3}"/>
+              </a:ext>
+            </a:extLst>
+          </p:cNvPr>
+          <p:cNvSpPr>
+            <a:spLocks xmlns:a="http://schemas.openxmlformats.org/drawingml/2006/main" noGrp="1"/>
+          </p:cNvSpPr>
+          <p:nvPr/>
+        </p:nvSpPr>
+        <p:spPr>
+          <a:xfrm xmlns:a="http://schemas.openxmlformats.org/drawingml/2006/main">
+            <a:off x="1152525" y="428625"/>
+            <a:ext cx="5619750" cy="361950"/>
+          </a:xfrm>
+          <a:prstGeom xmlns:a="http://schemas.openxmlformats.org/drawingml/2006/main" prst="rect">
+            <a:avLst/>
+          </a:prstGeom>
+          <a:noFill xmlns:a="http://schemas.openxmlformats.org/drawingml/2006/main"/>
+          <a:ln xmlns:a="http://schemas.openxmlformats.org/drawingml/2006/main" w="0">
+            <a:noFill/>
+            <a:prstDash val="solid"/>
+          </a:ln>
+        </p:spPr>
+        <p:txBody>
+          <a:bodyPr xmlns:a="http://schemas.openxmlformats.org/drawingml/2006/main"/>
+          <a:lstStyle xmlns:a="http://schemas.openxmlformats.org/drawingml/2006/main"/>
+          <a:p xmlns:a="http://schemas.openxmlformats.org/drawingml/2006/main">
+            <a:pPr algn="l">
+              <a:defRPr sz="1800" b="0">
+                <a:solidFill>
+                  <a:srgbClr val="FFFFFF"/>
+                </a:solidFill>
+                <a:latin typeface="Arial"/>
+                <a:ea typeface="Arial"/>
+                <a:cs typeface="Arial"/>
+              </a:defRPr>
+            </a:pPr>
+            <a:r>
+              <a:rPr sz="1800" b="0">
+                <a:solidFill>
+                  <a:srgbClr val="FFFFFF"/>
+                </a:solidFill>
+                <a:latin typeface="Arial"/>
+                <a:ea typeface="Arial"/>
+                <a:cs typeface="Arial"/>
               </a:rPr>
               <a:t>Programming starts with ideas</a:t>
             </a:r>
@@ -34115,10 +34955,10 @@
       </p:sp>
       <p:sp>
         <p:nvSpPr>
-          <p:cNvPr id="313" name="slide-heading-9">
-            <a:extLst xmlns:a="http://schemas.openxmlformats.org/drawingml/2006/main">
-              <a:ext uri="{FF2B5EF4-FFF2-40B4-BE49-F238E27FC236}">
-                <a16:creationId xmlns:a16="http://schemas.microsoft.com/office/drawing/2014/main" id="{DC58C05B-4865-470F-A3BA-388C322B816A}"/>
+          <p:cNvPr id="313" name="slide-heading-marker-9">
+            <a:extLst xmlns:a="http://schemas.openxmlformats.org/drawingml/2006/main">
+              <a:ext uri="{FF2B5EF4-FFF2-40B4-BE49-F238E27FC236}">
+                <a16:creationId xmlns:a16="http://schemas.microsoft.com/office/drawing/2014/main" id="{49DBD3CA-3E4D-4E27-8CFD-2ECB71A27EDB}"/>
               </a:ext>
             </a:extLst>
           </p:cNvPr>
@@ -34129,8 +34969,8 @@
         </p:nvSpPr>
         <p:spPr>
           <a:xfrm xmlns:a="http://schemas.openxmlformats.org/drawingml/2006/main">
-            <a:off x="552450" y="219075"/>
-            <a:ext cx="6858000" cy="266700"/>
+            <a:off x="742950" y="447675"/>
+            <a:ext cx="476250" cy="323850"/>
           </a:xfrm>
           <a:prstGeom xmlns:a="http://schemas.openxmlformats.org/drawingml/2006/main" prst="rect">
             <a:avLst/>
@@ -34146,9 +34986,9 @@
           <a:lstStyle xmlns:a="http://schemas.openxmlformats.org/drawingml/2006/main"/>
           <a:p xmlns:a="http://schemas.openxmlformats.org/drawingml/2006/main">
             <a:pPr algn="l">
-              <a:defRPr sz="1350" b="1">
+              <a:defRPr sz="1950" b="1">
                 <a:solidFill>
-                  <a:srgbClr val="FFFFFF"/>
+                  <a:srgbClr val="FFDB5D"/>
                 </a:solidFill>
                 <a:latin typeface="Source Code Pro"/>
                 <a:ea typeface="Source Code Pro"/>
@@ -34156,13 +34996,69 @@
               </a:defRPr>
             </a:pPr>
             <a:r>
-              <a:rPr sz="1350" b="1">
+              <a:rPr sz="1950" b="1">
                 <a:solidFill>
-                  <a:srgbClr val="FFFFFF"/>
+                  <a:srgbClr val="FFDB5D"/>
                 </a:solidFill>
                 <a:latin typeface="Source Code Pro"/>
                 <a:ea typeface="Source Code Pro"/>
                 <a:cs typeface="Source Code Pro"/>
+              </a:rPr>
+              <a:t>&lt;/</a:t>
+            </a:r>
+          </a:p>
+        </p:txBody>
+      </p:sp>
+      <p:sp>
+        <p:nvSpPr>
+          <p:cNvPr id="314" name="slide-heading-text-9">
+            <a:extLst xmlns:a="http://schemas.openxmlformats.org/drawingml/2006/main">
+              <a:ext uri="{FF2B5EF4-FFF2-40B4-BE49-F238E27FC236}">
+                <a16:creationId xmlns:a16="http://schemas.microsoft.com/office/drawing/2014/main" id="{69BDD1A1-B1AD-49F4-94CD-9D4423E1A401}"/>
+              </a:ext>
+            </a:extLst>
+          </p:cNvPr>
+          <p:cNvSpPr>
+            <a:spLocks xmlns:a="http://schemas.openxmlformats.org/drawingml/2006/main" noGrp="1"/>
+          </p:cNvSpPr>
+          <p:nvPr/>
+        </p:nvSpPr>
+        <p:spPr>
+          <a:xfrm xmlns:a="http://schemas.openxmlformats.org/drawingml/2006/main">
+            <a:off x="1152525" y="428625"/>
+            <a:ext cx="5619750" cy="361950"/>
+          </a:xfrm>
+          <a:prstGeom xmlns:a="http://schemas.openxmlformats.org/drawingml/2006/main" prst="rect">
+            <a:avLst/>
+          </a:prstGeom>
+          <a:noFill xmlns:a="http://schemas.openxmlformats.org/drawingml/2006/main"/>
+          <a:ln xmlns:a="http://schemas.openxmlformats.org/drawingml/2006/main" w="0">
+            <a:noFill/>
+            <a:prstDash val="solid"/>
+          </a:ln>
+        </p:spPr>
+        <p:txBody>
+          <a:bodyPr xmlns:a="http://schemas.openxmlformats.org/drawingml/2006/main"/>
+          <a:lstStyle xmlns:a="http://schemas.openxmlformats.org/drawingml/2006/main"/>
+          <a:p xmlns:a="http://schemas.openxmlformats.org/drawingml/2006/main">
+            <a:pPr algn="l">
+              <a:defRPr sz="1800" b="0">
+                <a:solidFill>
+                  <a:srgbClr val="FFFFFF"/>
+                </a:solidFill>
+                <a:latin typeface="Arial"/>
+                <a:ea typeface="Arial"/>
+                <a:cs typeface="Arial"/>
+              </a:defRPr>
+            </a:pPr>
+            <a:r>
+              <a:rPr sz="1800" b="0">
+                <a:solidFill>
+                  <a:srgbClr val="FFFFFF"/>
+                </a:solidFill>
+                <a:latin typeface="Arial"/>
+                <a:ea typeface="Arial"/>
+                <a:cs typeface="Arial"/>
               </a:rPr>
               <a:t>Our Saturday class routine</a:t>
             </a:r>

</xml_diff>